<commit_message>
Remove comparison-quote slide from Fairtech deck per author request
Co-Authored-By: Claude Fable 5 <noreply@anthropic.com>
Claude-Session: https://claude.ai/code/session_01ShZ1Lvoqxyx1rhNnLmjNSE
</commit_message>
<xml_diff>
--- a/presentation/Fairtech-Schweiz.pptx
+++ b/presentation/Fairtech-Schweiz.pptx
@@ -32,10 +32,9 @@
     <p:sldId id="280" r:id="rId26"/>
     <p:sldId id="281" r:id="rId27"/>
     <p:sldId id="282" r:id="rId28"/>
-    <p:sldId id="283" r:id="rId29"/>
   </p:sldIdLst>
   <p:notesMasterIdLst>
-    <p:notesMasterId r:id="rId30"/>
+    <p:notesMasterId r:id="rId29"/>
   </p:notesMasterIdLst>
   <p:sldSz cx="12192000" cy="6858000"/>
   <p:notesSz cx="6858000" cy="12192000"/>
@@ -614,7 +613,7 @@
           <a:lstStyle/>
           <a:p>
             <a:r>
-              <a:t>UNSERE BESTE FOLIE — aber nur, wenn ihr es wirklich macht: vergleicht die Preise am Abend vorher wirklich, macht Screenshots und druckt sie aus. Rayaan, langsam: «Wir behaupten nicht, dass wir günstiger sind. Wir haben es verglichen — Franken für Franken, Gerät für Gerät, mit Screenshot und Datum. Die Ausdrucke liegen hier vorne.» In die Klasse schauen. Wer Beweise auf den Tisch legt, gewinnt jede Nachfrage.</a:t>
+              <a:t>Die Persona. Rayaan: «Unsere Kundin heisst Nadia, 19, gerade mit der Lehre fertig. Ihr Laptop stirbt vor der Berufsmatur. Sie hat 500 Franken — nicht 1'300. Im Laden bekommt sie dafür ein Plastik-Notebook. Bei uns: ein Business-Gerät, refurbished, geprüft, mit Garantie — und es bleibt Geld übrig.» Konkret schlägt allgemein, immer.</a:t>
             </a:r>
           </a:p>
         </p:txBody>
@@ -700,7 +699,7 @@
           <a:lstStyle/>
           <a:p>
             <a:r>
-              <a:t>Die Persona. Rayaan: «Unsere Kundin heisst Nadia, 19, gerade mit der Lehre fertig. Ihr Laptop stirbt vor der Berufsmatur. Sie hat 500 Franken — nicht 1'300. Im Laden bekommt sie dafür ein Plastik-Notebook. Bei uns: ein Business-Gerät, refurbished, geprüft, mit Garantie — und es bleibt Geld übrig.» Konkret schlägt allgemein, immer.</a:t>
+              <a:t>Konkurrenz — WICHTIG: Digitec Galaxus zuerst nennen, nicht MediaMarkt. Rayaan: «Der echte Gegner online in der Schweiz heisst nicht MediaMarkt — er heisst Digitec Galaxus. Riesiges Sortiment, super Logistik. Gegen die gewinnen wir bei Neuware nicht. Müssen wir auch nicht: unser Feld ist refurbished mit Beratung und schmalem Sortiment. Und unsere Schwäche sagen wir gleich selber: uns kennt noch niemand.» Im Kurzmodus ist das deine LETZTE Folie — übergeben: «Was genau im Regal liegt, zeigt euch Fernando.»</a:t>
             </a:r>
           </a:p>
         </p:txBody>
@@ -786,7 +785,7 @@
           <a:lstStyle/>
           <a:p>
             <a:r>
-              <a:t>Konkurrenz — WICHTIG: Digitec Galaxus zuerst nennen, nicht MediaMarkt. Rayaan: «Der echte Gegner online in der Schweiz heisst nicht MediaMarkt — er heisst Digitec Galaxus. Riesiges Sortiment, super Logistik. Gegen die gewinnen wir bei Neuware nicht. Müssen wir auch nicht: unser Feld ist refurbished mit Beratung und schmalem Sortiment. Und unsere Schwäche sagen wir gleich selber: uns kennt noch niemand.»</a:t>
+              <a:t>RESERVE — diese Folie ist NICHT im kurzen Durchlauf. Sie ist eure vorbereitete Antwort, falls die MediaMarkt-Frage kommt: Taste K drücken, eine Folie zurück — und die Antwort steht an der Wand. Rayaan: «Und jetzt die Frage, die Sie sich seit fünf Minuten stellen: Wie können ein paar Lernende billiger sein als MediaMarkt, wenn MediaMarkt hunderttausend Geräte einkauft und wir zehn? Ehrliche Antwort: beim Einkauf können wir es nicht. Unser Vorteil liegt woanders — erstens: keine Läden, keine Miete, kein Verkaufspersonal. Zweitens: sechs Produkte, kein totes Lager. Drittens: refurbished, wo nicht der Einkauf entscheidet, sondern Prüfung und Vertrauen.» Pause. «Beim Einkauf verlieren wir. Bei der Struktur gewinnen wir.» Dann übergeben: «Was genau im Regal liegt, zeigt euch Fernando.»</a:t>
             </a:r>
           </a:p>
         </p:txBody>
@@ -872,7 +871,7 @@
           <a:lstStyle/>
           <a:p>
             <a:r>
-              <a:t>RESERVE — diese Folie ist NICHT im kurzen Durchlauf. Sie ist eure vorbereitete Antwort, falls die MediaMarkt-Frage kommt: Taste K drücken, eine Folie zurück — und die Antwort steht an der Wand. Rayaan: «Und jetzt die Frage, die Sie sich seit fünf Minuten stellen: Wie können ein paar Lernende billiger sein als MediaMarkt, wenn MediaMarkt hunderttausend Geräte einkauft und wir zehn? Ehrliche Antwort: beim Einkauf können wir es nicht. Unser Vorteil liegt woanders — erstens: keine Läden, keine Miete, kein Verkaufspersonal. Zweitens: sechs Produkte, kein totes Lager. Drittens: refurbished, wo nicht der Einkauf entscheidet, sondern Prüfung und Vertrauen.» Pause. «Beim Einkauf verlieren wir. Bei der Struktur gewinnen wir.» Dann übergeben: «Was genau im Regal liegt, zeigt euch Fernando.»</a:t>
+              <a:t>Rayaan zurück, Fernando nach vorne.</a:t>
             </a:r>
           </a:p>
         </p:txBody>
@@ -958,7 +957,7 @@
           <a:lstStyle/>
           <a:p>
             <a:r>
-              <a:t>Rayaan zurück, Fernando nach vorne.</a:t>
+              <a:t>Fernando: Die Tabelle NICHT vorlesen. Dein Text: «Sechs Produkte, mehr nicht. Oben die Neuware: iPhone, MacBook, AirPods — knapp unter dem Ladenpreis. Unten die refurbished-Geräte: geprüft, Grad A, bis zu vierzig Prozent unter dem Neupreis.» Mit der Hand auf die letzte Zeile zeigen: «Und dieses Notebook hier ist unser wichtigstes Produkt — warum, zeige ich gleich.» Die Vergleichspreise am Abend vorher aktualisieren!</a:t>
             </a:r>
           </a:p>
         </p:txBody>
@@ -1044,7 +1043,7 @@
           <a:lstStyle/>
           <a:p>
             <a:r>
-              <a:t>Fernando: Die Tabelle NICHT vorlesen. Dein Text: «Sechs Produkte, mehr nicht. Oben die Neuware: iPhone, MacBook, AirPods — knapp unter dem Ladenpreis. Unten die refurbished-Geräte: geprüft, Grad A, bis zu vierzig Prozent unter dem Neupreis.» Mit der Hand auf die letzte Zeile zeigen: «Und dieses Notebook hier ist unser wichtigstes Produkt — warum, zeige ich gleich.» Die Vergleichspreise am Abend vorher aktualisieren!</a:t>
+              <a:t>Kaufmännischer Teil — hier zeigt ihr, dass ihr rechnen könnt. Fernando: «Was verdienen wir an einem neuen iPhone für 799 Franken? Wir kaufen es beim Schweizer Grossisten für rund 745. Dazu kommen Zahlungsgebühr und Versand, etwa 27 Franken. Bleiben —» (Pause) «— 27 Franken. Siebenundzwanzig Franken an einem 800-Franken-Gerät, gut drei Prozent. Die Summe stimmt: 745 plus 27 plus 27 ist 799.» Das ist Absicht: die dünne Marge hier macht die dicke Marge auf der nächsten Folie glaubwürdig.</a:t>
             </a:r>
           </a:p>
         </p:txBody>
@@ -1130,7 +1129,7 @@
           <a:lstStyle/>
           <a:p>
             <a:r>
-              <a:t>Kaufmännischer Teil — hier zeigt ihr, dass ihr rechnen könnt. Fernando: «Was verdienen wir an einem neuen iPhone für 799 Franken? Wir kaufen es beim Schweizer Grossisten für rund 745. Dazu kommen Zahlungsgebühr und Versand, etwa 27 Franken. Bleiben —» (Pause) «— 27 Franken. Siebenundzwanzig Franken an einem 800-Franken-Gerät, gut drei Prozent. Die Summe stimmt: 745 plus 27 plus 27 ist 799.» Das ist Absicht: die dünne Marge hier macht die dicke Marge auf der nächsten Folie glaubwürdig.</a:t>
+              <a:t>Fernando, die wichtigste Folie deines Teils: «Deshalb liegt unser Geld im zweiten Leben der Geräte. Ein iPhone 14, refurbished, Grad A: der Kunde zahlt 449 statt 749 für neu — er spart 300 Franken. Und wir? Rund 20 Prozent Marge statt 4. Der Kunde gewinnt, wir gewinnen — und ein gutes Gerät landet nicht im Schrank.» Pause. «Neuware ist unser Schaufenster. Refurbished ist unser Geschäft.» Dann übergeben: «Wie eine Bestellung technisch läuft, zeigt euch Samed.»</a:t>
             </a:r>
           </a:p>
         </p:txBody>
@@ -1216,7 +1215,7 @@
           <a:lstStyle/>
           <a:p>
             <a:r>
-              <a:t>Fernando, die wichtigste Folie deines Teils: «Deshalb liegt unser Geld im zweiten Leben der Geräte. Ein iPhone 14, refurbished, Grad A: der Kunde zahlt 449 statt 749 für neu — er spart 300 Franken. Und wir? Rund 20 Prozent Marge statt 4. Der Kunde gewinnt, wir gewinnen — und ein gutes Gerät landet nicht im Schrank.» Pause. «Neuware ist unser Schaufenster. Refurbished ist unser Geschäft.» Dann übergeben: «Wie eine Bestellung technisch läuft, zeigt euch Samed.»</a:t>
+              <a:t>Fernando zurück, Samed nach vorne.</a:t>
             </a:r>
           </a:p>
         </p:txBody>
@@ -1302,7 +1301,7 @@
           <a:lstStyle/>
           <a:p>
             <a:r>
-              <a:t>Fernando zurück, Samed nach vorne.</a:t>
+              <a:t>Samed, dein Text: «Warum Shopify? Erstens: die Zahlung ist gelöst — TWINT und Karte, ohne eine Zeile Code. Zweitens: Lager, Bestellungen und Versandetiketten sind eingebaut. Drittens: es kostet am Anfang einen Franken im Monat, später rund 36.» Der stärkste Satz ist der letzte — langsam: «Wir könnten so einen Shop selber programmieren. Wir haben es trotzdem nicht gemacht — denn ein Shop ist kein Programmierprojekt. Er ist ein Verkaufsprojekt.»</a:t>
             </a:r>
           </a:p>
         </p:txBody>
@@ -1388,7 +1387,7 @@
           <a:lstStyle/>
           <a:p>
             <a:r>
-              <a:t>Samed, dein Text: «Warum Shopify? Erstens: die Zahlung ist gelöst — TWINT und Karte, ohne eine Zeile Code. Zweitens: Lager, Bestellungen und Versandetiketten sind eingebaut. Drittens: es kostet am Anfang einen Franken im Monat, später rund 36.» Der stärkste Satz ist der letzte — langsam: «Wir könnten so einen Shop selber programmieren. Wir haben es trotzdem nicht gemacht — denn ein Shop ist kein Programmierprojekt. Er ist ein Verkaufsprojekt.»</a:t>
+              <a:t>Die Tutorial-Folie — Schritt für Schritt, wie in einem Anleitung-Video. Samed: «Das kann jeder hier nachmachen. Schritt eins: Konto auf shopify.com — drei Tage gratis, dann ein Franken im Monat. Schritt zwei: die sechs Produkte anlegen, mit Foto und Preis. Schritt drei: TWINT und Karte einschalten. Schritt vier: den Versand einrichten — dazu gleich mehr. Schritt fünf: Testbestellung machen, Screenshot als Beweis. Fünf Schritte — ein Wochenende.» Auf jeden Schritt einzeln zeigen.</a:t>
             </a:r>
           </a:p>
         </p:txBody>
@@ -1560,7 +1559,7 @@
           <a:lstStyle/>
           <a:p>
             <a:r>
-              <a:t>Die Tutorial-Folie — Schritt für Schritt, wie in einem Anleitung-Video. Samed: «Das kann jeder hier nachmachen. Schritt eins: Konto auf shopify.com — drei Tage gratis, dann ein Franken im Monat. Schritt zwei: die sechs Produkte anlegen, mit Foto und Preis. Schritt drei: TWINT und Karte einschalten. Schritt vier: den Versand einrichten — dazu gleich mehr. Schritt fünf: Testbestellung machen, Screenshot als Beweis. Fünf Schritte — ein Wochenende.» Auf jeden Schritt einzeln zeigen.</a:t>
+              <a:t>Der Ablauf einer Bestellung — fünf Schritte, je zehn Sekunden. Samed: «Nadia bestellt am Sonntagabend das refurbished-Notebook. TWINT bestätigt in Sekunden. Bei Neuware geht die Bestellung automatisch an den Grossisten — Streckengeschäft, wie Yassin gesagt hat — und der liefert direkt zu ihr. Die refurbished-Geräte verschicken wir selber: versichert, mit der Post, in zwei bis drei Tagen. Rechnung mit MWST kommt per Mail.» Betone: bei 800-Franken-Geräten ist der Versand IMMER versichert. Im Kurzmodus ist das deine LETZTE Folie — übergeben: «Was das Gesetz verlangt und was am Ende übrig bleibt, zeigt euch Kim.»</a:t>
             </a:r>
           </a:p>
         </p:txBody>
@@ -1646,7 +1645,7 @@
           <a:lstStyle/>
           <a:p>
             <a:r>
-              <a:t>Der Ablauf einer Bestellung — fünf Schritte, je zehn Sekunden. Samed: «Nadia bestellt am Sonntagabend das refurbished-Notebook. TWINT bestätigt in Sekunden. Bei Neuware geht die Bestellung automatisch an den Grossisten — Streckengeschäft, wie Yassin gesagt hat — und der liefert direkt zu ihr. Die refurbished-Geräte verschicken wir selber: versichert, mit der Post, in zwei bis drei Tagen. Rechnung mit MWST kommt per Mail.» Betone: bei 800-Franken-Geräten ist der Versand IMMER versichert.</a:t>
+              <a:t>Samed: «Bezahlt wird mit TWINT — ohne TWINT verliert man in der Schweiz Bestellungen — oder mit Karte. Und eine bewusste Entscheidung: Kauf auf Rechnung gibt es bei uns NICHT. Bei 800-Franken-Geräten ist das Betrugsrisiko zu gross — das ist eine Risikoentscheidung, keine Bequemlichkeit.» Das zeigt der Lehrperson kaufmännisches Denken. Dann übergeben: «Was das Gesetz von uns verlangt und was am Ende übrig bleibt, zeigt euch Kim.»</a:t>
             </a:r>
           </a:p>
         </p:txBody>
@@ -1732,7 +1731,7 @@
           <a:lstStyle/>
           <a:p>
             <a:r>
-              <a:t>Samed: «Bezahlt wird mit TWINT — ohne TWINT verliert man in der Schweiz Bestellungen — oder mit Karte. Und eine bewusste Entscheidung: Kauf auf Rechnung gibt es bei uns NICHT. Bei 800-Franken-Geräten ist das Betrugsrisiko zu gross — das ist eine Risikoentscheidung, keine Bequemlichkeit.» Das zeigt der Lehrperson kaufmännisches Denken. Dann übergeben: «Was das Gesetz von uns verlangt und was am Ende übrig bleibt, zeigt euch Kim.»</a:t>
+              <a:t>Samed zurück, Kim nach vorne. Kim macht den Schluss — am Ende kommen alle fünf wieder nach vorne.</a:t>
             </a:r>
           </a:p>
         </p:txBody>
@@ -1818,7 +1817,7 @@
           <a:lstStyle/>
           <a:p>
             <a:r>
-              <a:t>Samed zurück, Kim nach vorne. Kim macht den Schluss — am Ende kommen alle fünf wieder nach vorne.</a:t>
+              <a:t>Kim, nach dieser Folie fragt in der Schweiz fast jede Lehrperson. Dein Text: «Vier Dinge verlangt das Gesetz, ein fünftes geben wir freiwillig. Impressum — Pflicht. Datenschutzerklärung — Pflicht. Preise inklusive Mehrwertsteuer — Pflicht. Und die Gewährleistung: bei Neuware zwei Jahre — bei Occasion, also refurbished, darf sie per AGB auf ein Jahr verkürzt werden. Das nutzen wir, und es steht gross und ehrlich beim Produkt. Ein gesetzliches Widerrufsrecht gibt es in der Schweiz übrigens NICHT — wir geben trotzdem 14 Tage, freiwillig, als Vertrauensbeweis.» Die Begriffe auswendig: UWG, revDSG, PBV, OR.</a:t>
             </a:r>
           </a:p>
         </p:txBody>
@@ -1904,7 +1903,7 @@
           <a:lstStyle/>
           <a:p>
             <a:r>
-              <a:t>Kim, nach dieser Folie fragt in der Schweiz fast jede Lehrperson. Dein Text: «Vier Dinge verlangt das Gesetz, ein fünftes geben wir freiwillig. Impressum — Pflicht. Datenschutzerklärung — Pflicht. Preise inklusive Mehrwertsteuer — Pflicht. Und die Gewährleistung: bei Neuware zwei Jahre — bei Occasion, also refurbished, darf sie per AGB auf ein Jahr verkürzt werden. Das nutzen wir, und es steht gross und ehrlich beim Produkt. Ein gesetzliches Widerrufsrecht gibt es in der Schweiz übrigens NICHT — wir geben trotzdem 14 Tage, freiwillig, als Vertrauensbeweis.» Die Begriffe auswendig: UWG, revDSG, PBV, OR.</a:t>
+              <a:t>Kim: «Annahme» sagen, nie «Ergebnis». Dein Text: «Unsere Annahme: 20 Bestellungen im Monat, Durchschnitt 500 Franken — 10'000 Franken Umsatz. Klingt gross. Aber jetzt ehrlich weiterrechnen: 8'800 gehen für den Wareneinkauf weg. 200 für Zahlungsgebühren, 200 als Reserve für Retouren, 50 für Shopify und Domain. Es bleiben —» (auf den Balken zeigen) «— rund 750 Franken. Von jedem Franken Umsatz bleiben uns SIEBEN Rappen. Elektronikhandel heisst: viel Umsatz, wenig Marge. Genau deshalb sind die refurbished-Geräte so wichtig — dort bleiben zwanzig Rappen, nicht sieben.»</a:t>
             </a:r>
           </a:p>
         </p:txBody>
@@ -1990,7 +1989,7 @@
           <a:lstStyle/>
           <a:p>
             <a:r>
-              <a:t>Kim: «Annahme» sagen, nie «Ergebnis». Dein Text: «Unsere Annahme: 20 Bestellungen im Monat, Durchschnitt 500 Franken — 10'000 Franken Umsatz. Klingt gross. Aber jetzt ehrlich weiterrechnen: 8'800 gehen für den Wareneinkauf weg. 200 für Zahlungsgebühren, 200 als Reserve für Retouren, 50 für Shopify und Domain. Es bleiben —» (auf den Balken zeigen) «— rund 750 Franken. Von jedem Franken Umsatz bleiben uns SIEBEN Rappen. Elektronikhandel heisst: viel Umsatz, wenig Marge. Genau deshalb sind die refurbished-Geräte so wichtig — dort bleiben zwanzig Rappen, nicht sieben.»</a:t>
+              <a:t>Kim, die Risiken ZUERST — das wirkt souverän: «Was kann schiefgehen? Erstens: der Preiskrieg. Digitec kann jeden unserer Neuware-Preise unterbieten, jederzeit. Unsere Antwort: dort nicht kämpfen — unser Feld ist refurbished. Zweitens: Betrug und Transportschäden bei teuren Geräten. Antwort: kein Kauf auf Rechnung, immer versicherter Versand. Und die Chancen: refurbished wächst — Nachhaltigkeit ist kein Trend mehr, sondern Kaufgrund. Und jedes Jahr kommt eine neue Geräte-Generation — jede davon macht den Occasionsmarkt grösser.»</a:t>
             </a:r>
           </a:p>
         </p:txBody>
@@ -2076,7 +2075,7 @@
           <a:lstStyle/>
           <a:p>
             <a:r>
-              <a:t>Kim, die Risiken ZUERST — das wirkt souverän: «Was kann schiefgehen? Erstens: der Preiskrieg. Digitec kann jeden unserer Neuware-Preise unterbieten, jederzeit. Unsere Antwort: dort nicht kämpfen — unser Feld ist refurbished. Zweitens: Betrug und Transportschäden bei teuren Geräten. Antwort: kein Kauf auf Rechnung, immer versicherter Versand. Und die Chancen: refurbished wächst — Nachhaltigkeit ist kein Trend mehr, sondern Kaufgrund. Und jedes Jahr kommt eine neue Geräte-Generation — jede davon macht den Occasionsmarkt grösser.»</a:t>
+              <a:t>Der ehrliche Teil — genau das trennt eine 5 von einer 6. Kim: «Drei Dinge haben wir gelernt. Erstens: Handel mit Markenware ist ein Volumengeschäft — die Marge liegt nicht im Logo, sondern im zweiten Leben der Geräte. Zweitens: der Preis allein verkauft nicht — Vertrauen verkauft: Garantie, TWINT, eine Schweizer Adresse. Und drittens —» (langsam) «— wir haben noch nichts verkauft. Alle Zahlen heute sind gerechnet, nicht gemessen. Das sagen wir lieber selber, bevor es jemand fragt.»</a:t>
             </a:r>
           </a:p>
         </p:txBody>
@@ -2162,7 +2161,7 @@
           <a:lstStyle/>
           <a:p>
             <a:r>
-              <a:t>Der ehrliche Teil — genau das trennt eine 5 von einer 6. Kim: «Drei Dinge haben wir gelernt. Erstens: Handel mit Markenware ist ein Volumengeschäft — die Marge liegt nicht im Logo, sondern im zweiten Leben der Geräte. Zweitens: der Preis allein verkauft nicht — Vertrauen verkauft: Garantie, TWINT, eine Schweizer Adresse. Und drittens —» (langsam) «— wir haben noch nichts verkauft. Alle Zahlen heute sind gerechnet, nicht gemessen. Das sagen wir lieber selber, bevor es jemand fragt.»</a:t>
+              <a:t>ALLE FÜNF kommen nach vorne. Kim sagt «Danke.» — dann Stille, Hände ruhig, auf die Fragen warten. Wer die Frage bekommt, antwortet; die anderen schauen ihn an. Wahrscheinliche Fragen: «Wie könnt ihr billiger sein als MediaMarkt?» (Rayaan: keine Läden, 6 Produkte, refurbished — beim Einkauf verlieren wir, bei der Struktur gewinnen wir.) «Und wenn Digitec die Preise senkt?» (Kim: bei Neuware können wir nicht gewinnen — unser Feld ist refurbished.) «Woher kommt die Ware?» (Yassin: Neuware im Streckengeschäft vom Schweizer Grossisten, refurbished als geprüfte Lots.) «Habt ihr schon verkauft?» (Nein — alle Zahlen sind Annahmen, das haben wir auch so gesagt.)</a:t>
             </a:r>
           </a:p>
         </p:txBody>
@@ -2185,92 +2184,6 @@
             <a:fld id="{F7021451-1387-4CA6-816F-3879F97B5CBC}" type="slidenum">
               <a:rPr lang="en-US"/>
               <a:t>27</a:t>
-            </a:fld>
-            <a:endParaRPr lang="en-US"/>
-          </a:p>
-        </p:txBody>
-      </p:sp>
-    </p:spTree>
-    <p:extLst>
-      <p:ext uri="{BB962C8B-B14F-4D97-AF65-F5344CB8AC3E}">
-        <p14:creationId xmlns:p14="http://schemas.microsoft.com/office/powerpoint/2010/main" val="1024086991"/>
-      </p:ext>
-    </p:extLst>
-  </p:cSld>
-  <p:clrMapOvr>
-    <a:masterClrMapping/>
-  </p:clrMapOvr>
-</p:notes>
-</file>
-
-<file path=ppt/notesSlides/notesSlide28.xml><?xml version="1.0" encoding="utf-8"?>
-<p:notes xmlns:a="http://schemas.openxmlformats.org/drawingml/2006/main" xmlns:r="http://schemas.openxmlformats.org/officeDocument/2006/relationships" xmlns:p="http://schemas.openxmlformats.org/presentationml/2006/main">
-  <p:cSld>
-    <p:spTree>
-      <p:nvGrpSpPr>
-        <p:cNvPr id="1" name=""/>
-        <p:cNvGrpSpPr/>
-        <p:nvPr/>
-      </p:nvGrpSpPr>
-      <p:grpSpPr>
-        <a:xfrm>
-          <a:off x="0" y="0"/>
-          <a:ext cx="0" cy="0"/>
-          <a:chOff x="0" y="0"/>
-          <a:chExt cx="0" cy="0"/>
-        </a:xfrm>
-      </p:grpSpPr>
-      <p:sp>
-        <p:nvSpPr>
-          <p:cNvPr id="2" name="Slide Image Placeholder 1"/>
-          <p:cNvSpPr>
-            <a:spLocks noGrp="1" noRot="1" noChangeAspect="1"/>
-          </p:cNvSpPr>
-          <p:nvPr>
-            <p:ph type="sldImg"/>
-          </p:nvPr>
-        </p:nvSpPr>
-        <p:spPr/>
-      </p:sp>
-      <p:sp>
-        <p:nvSpPr>
-          <p:cNvPr id="3" name="Notes Placeholder 2"/>
-          <p:cNvSpPr>
-            <a:spLocks noGrp="1"/>
-          </p:cNvSpPr>
-          <p:nvPr>
-            <p:ph type="body" idx="1"/>
-          </p:nvPr>
-        </p:nvSpPr>
-        <p:spPr/>
-        <p:txBody>
-          <a:bodyPr/>
-          <a:lstStyle/>
-          <a:p>
-            <a:r>
-              <a:t>ALLE FÜNF kommen nach vorne. Kim sagt «Danke.» — dann Stille, Hände ruhig, auf die Fragen warten. Wer die Frage bekommt, antwortet; die anderen schauen ihn an. Wahrscheinliche Fragen: «Wie könnt ihr billiger sein als MediaMarkt?» (Rayaan: keine Läden, 6 Produkte, refurbished — beim Einkauf verlieren wir, bei der Struktur gewinnen wir.) «Und wenn Digitec die Preise senkt?» (Kim: bei Neuware können wir nicht gewinnen — unser Feld ist refurbished.) «Woher kommt die Ware?» (Yassin: Neuware im Streckengeschäft vom Schweizer Grossisten, refurbished als geprüfte Lots.) «Habt ihr schon verkauft?» (Nein — alle Zahlen sind Annahmen, das haben wir auch so gesagt.)</a:t>
-            </a:r>
-          </a:p>
-        </p:txBody>
-      </p:sp>
-      <p:sp>
-        <p:nvSpPr>
-          <p:cNvPr id="4" name="Slide Number Placeholder 3"/>
-          <p:cNvSpPr>
-            <a:spLocks noGrp="1"/>
-          </p:cNvSpPr>
-          <p:nvPr>
-            <p:ph type="sldNum" sz="quarter" idx="10"/>
-          </p:nvPr>
-        </p:nvSpPr>
-        <p:spPr/>
-        <p:txBody>
-          <a:bodyPr/>
-          <a:lstStyle/>
-          <a:p>
-            <a:fld id="{F7021451-1387-4CA6-816F-3879F97B5CBC}" type="slidenum">
-              <a:rPr lang="en-US"/>
-              <a:t>28</a:t>
             </a:fld>
             <a:endParaRPr lang="en-US"/>
           </a:p>
@@ -2592,7 +2505,7 @@
           <a:lstStyle/>
           <a:p>
             <a:r>
-              <a:t>Yassin: «Unsere Idee hat drei Teile. Erstens: kein Laden — wir verkaufen nur online, die zehn bis fünfzehn Prozent Struktur fallen weg. Zweitens: sechs Produkte statt sechstausend — kein totes Lager, keine Liquidationen. Drittens, und das ist der wichtigste Teil: refurbished. Geprüfte, wieder aufbereitete Geräte — da sind wir nicht fünf Prozent günstiger, sondern vierzig.» Die drei Karten je fünf Sekunden.</a:t>
+              <a:t>Yassin: «Unsere Idee hat drei Teile. Erstens: kein Laden — wir verkaufen nur online, die zehn bis fünfzehn Prozent Struktur fallen weg. Zweitens: sechs Produkte statt sechstausend — kein totes Lager, keine Liquidationen. Drittens, und das ist der wichtigste Teil: refurbished. Geprüfte, wieder aufbereitete Geräte — da sind wir nicht fünf Prozent günstiger, sondern vierzig.» Die drei Karten je fünf Sekunden. Im Kurzmodus ist das deine LETZTE Folie — übergeben: «Wer das kauft und gegen wen wir antreten, zeigt euch Rayaan.»</a:t>
             </a:r>
           </a:p>
         </p:txBody>
@@ -3800,443 +3713,6 @@
       </p:sp>
       <p:sp>
         <p:nvSpPr>
-          <p:cNvPr id="4" name="Text 2"/>
-          <p:cNvSpPr/>
-          <p:nvPr/>
-        </p:nvSpPr>
-        <p:spPr>
-          <a:xfrm>
-            <a:off x="502920" y="411480"/>
-            <a:ext cx="8229600" cy="274320"/>
-          </a:xfrm>
-          <a:prstGeom prst="rect">
-            <a:avLst/>
-          </a:prstGeom>
-          <a:noFill/>
-          <a:ln/>
-        </p:spPr>
-        <p:txBody>
-          <a:bodyPr wrap="square" lIns="0" tIns="0" rIns="0" bIns="0" rtlCol="0" anchor="ctr"/>
-          <a:lstStyle/>
-          <a:p>
-            <a:pPr indent="0" marL="0">
-              <a:buNone/>
-            </a:pPr>
-            <a:r>
-              <a:rPr lang="en-US" sz="1050" b="1" spc="300" kern="0" dirty="0">
-                <a:solidFill>
-                  <a:srgbClr val="3ED6AC"/>
-                </a:solidFill>
-                <a:latin typeface="Arial" pitchFamily="34" charset="0"/>
-                <a:ea typeface="Arial" pitchFamily="34" charset="-122"/>
-                <a:cs typeface="Arial" pitchFamily="34" charset="-120"/>
-              </a:rPr>
-              <a:t>04 · DIE KUNDSCHAFT</a:t>
-            </a:r>
-            <a:endParaRPr lang="en-US" sz="1050" dirty="0"/>
-          </a:p>
-        </p:txBody>
-      </p:sp>
-      <p:sp>
-        <p:nvSpPr>
-          <p:cNvPr id="5" name="Text 3"/>
-          <p:cNvSpPr/>
-          <p:nvPr/>
-        </p:nvSpPr>
-        <p:spPr>
-          <a:xfrm>
-            <a:off x="1069848" y="2011680"/>
-            <a:ext cx="10058400" cy="2377440"/>
-          </a:xfrm>
-          <a:prstGeom prst="rect">
-            <a:avLst/>
-          </a:prstGeom>
-          <a:noFill/>
-          <a:ln/>
-        </p:spPr>
-        <p:txBody>
-          <a:bodyPr wrap="square" lIns="0" tIns="0" rIns="0" bIns="0" rtlCol="0" anchor="ctr"/>
-          <a:lstStyle/>
-          <a:p>
-            <a:pPr algn="ctr" indent="0" marL="0">
-              <a:lnSpc>
-                <a:spcPct val="120000"/>
-              </a:lnSpc>
-              <a:buNone/>
-            </a:pPr>
-            <a:r>
-              <a:rPr lang="en-US" sz="3400" b="1" dirty="0">
-                <a:solidFill>
-                  <a:srgbClr val="EDF2F7"/>
-                </a:solidFill>
-                <a:latin typeface="Arial" pitchFamily="34" charset="0"/>
-                <a:ea typeface="Arial" pitchFamily="34" charset="-122"/>
-                <a:cs typeface="Arial" pitchFamily="34" charset="-120"/>
-              </a:rPr>
-              <a:t>Wir behaupten nicht, dass wir günstiger sind. </a:t>
-            </a:r>
-            <a:pPr algn="ctr" indent="0" marL="0">
-              <a:lnSpc>
-                <a:spcPct val="120000"/>
-              </a:lnSpc>
-              <a:buNone/>
-            </a:pPr>
-            <a:r>
-              <a:rPr lang="en-US" sz="3400" b="1" dirty="0">
-                <a:solidFill>
-                  <a:srgbClr val="3ED6AC"/>
-                </a:solidFill>
-                <a:latin typeface="Arial" pitchFamily="34" charset="0"/>
-                <a:ea typeface="Arial" pitchFamily="34" charset="-122"/>
-                <a:cs typeface="Arial" pitchFamily="34" charset="-120"/>
-              </a:rPr>
-              <a:t>Wir haben es verglichen</a:t>
-            </a:r>
-            <a:pPr algn="ctr" indent="0" marL="0">
-              <a:lnSpc>
-                <a:spcPct val="120000"/>
-              </a:lnSpc>
-              <a:buNone/>
-            </a:pPr>
-            <a:r>
-              <a:rPr lang="en-US" sz="3400" b="1" dirty="0">
-                <a:solidFill>
-                  <a:srgbClr val="EDF2F7"/>
-                </a:solidFill>
-                <a:latin typeface="Arial" pitchFamily="34" charset="0"/>
-                <a:ea typeface="Arial" pitchFamily="34" charset="-122"/>
-                <a:cs typeface="Arial" pitchFamily="34" charset="-120"/>
-              </a:rPr>
-              <a:t> — mit Screenshot und Datum.</a:t>
-            </a:r>
-            <a:endParaRPr lang="en-US" sz="3400" dirty="0"/>
-          </a:p>
-        </p:txBody>
-      </p:sp>
-      <p:sp>
-        <p:nvSpPr>
-          <p:cNvPr id="6" name="Text 4"/>
-          <p:cNvSpPr/>
-          <p:nvPr/>
-        </p:nvSpPr>
-        <p:spPr>
-          <a:xfrm>
-            <a:off x="1069848" y="4709160"/>
-            <a:ext cx="10058400" cy="320040"/>
-          </a:xfrm>
-          <a:prstGeom prst="rect">
-            <a:avLst/>
-          </a:prstGeom>
-          <a:noFill/>
-          <a:ln/>
-        </p:spPr>
-        <p:txBody>
-          <a:bodyPr wrap="square" lIns="0" tIns="0" rIns="0" bIns="0" rtlCol="0" anchor="ctr"/>
-          <a:lstStyle/>
-          <a:p>
-            <a:pPr algn="ctr" indent="0" marL="0">
-              <a:buNone/>
-            </a:pPr>
-            <a:r>
-              <a:rPr lang="en-US" sz="1050" b="1" spc="300" kern="0" dirty="0">
-                <a:solidFill>
-                  <a:srgbClr val="5C6E82"/>
-                </a:solidFill>
-                <a:latin typeface="Arial" pitchFamily="34" charset="0"/>
-                <a:ea typeface="Arial" pitchFamily="34" charset="-122"/>
-                <a:cs typeface="Arial" pitchFamily="34" charset="-120"/>
-              </a:rPr>
-              <a:t>MEDIAMARKT · DIGITEC GALAXUS · INTERDISCOUNT</a:t>
-            </a:r>
-            <a:endParaRPr lang="en-US" sz="1050" dirty="0"/>
-          </a:p>
-        </p:txBody>
-      </p:sp>
-    </p:spTree>
-  </p:cSld>
-  <p:clrMapOvr>
-    <a:masterClrMapping/>
-  </p:clrMapOvr>
-  <mc:AlternateContent xmlns:mc="http://schemas.openxmlformats.org/markup-compatibility/2006">
-    <mc:Choice xmlns:p159="http://schemas.microsoft.com/office/powerpoint/2015/09/main" Requires="p159">
-      <p:transition xmlns:p14="http://schemas.microsoft.com/office/powerpoint/2010/main" spd="slow" p14:dur="700">
-        <p159:morph option="byObject"/>
-      </p:transition>
-    </mc:Choice>
-    <mc:Fallback>
-      <p:transition spd="slow">
-        <p:fade/>
-      </p:transition>
-    </mc:Fallback>
-  </mc:AlternateContent>
-  <p:timing>
-    <p:tnLst>
-      <p:par>
-        <p:cTn id="1" dur="indefinite" restart="never" nodeType="tmRoot">
-          <p:childTnLst>
-            <p:seq concurrent="1" nextAc="seek">
-              <p:cTn id="2" dur="indefinite" nodeType="mainSeq">
-                <p:childTnLst>
-                  <p:par>
-                    <p:cTn id="13" fill="hold">
-                      <p:stCondLst>
-                        <p:cond delay="indefinite"/>
-                        <p:cond evt="onBegin" delay="0">
-                          <p:tn val="2"/>
-                        </p:cond>
-                      </p:stCondLst>
-                      <p:childTnLst>
-                        <p:par>
-                          <p:cTn id="12" fill="hold">
-                            <p:stCondLst>
-                              <p:cond delay="0"/>
-                            </p:stCondLst>
-                            <p:childTnLst>
-                              <p:par>
-                                <p:cTn id="3" presetID="10" presetClass="entr" presetSubtype="0" fill="hold" grpId="0" nodeType="withEffect">
-                                  <p:stCondLst>
-                                    <p:cond delay="0"/>
-                                  </p:stCondLst>
-                                  <p:childTnLst>
-                                    <p:set>
-                                      <p:cBhvr>
-                                        <p:cTn id="4" dur="1" fill="hold">
-                                          <p:stCondLst>
-                                            <p:cond delay="0"/>
-                                          </p:stCondLst>
-                                        </p:cTn>
-                                        <p:tgtEl>
-                                          <p:spTgt spid="4"/>
-                                        </p:tgtEl>
-                                        <p:attrNameLst>
-                                          <p:attrName>style.visibility</p:attrName>
-                                        </p:attrNameLst>
-                                      </p:cBhvr>
-                                      <p:to>
-                                        <p:strVal val="visible"/>
-                                      </p:to>
-                                    </p:set>
-                                    <p:animEffect transition="in" filter="fade">
-                                      <p:cBhvr>
-                                        <p:cTn id="5" dur="400"/>
-                                        <p:tgtEl>
-                                          <p:spTgt spid="4"/>
-                                        </p:tgtEl>
-                                      </p:cBhvr>
-                                    </p:animEffect>
-                                  </p:childTnLst>
-                                </p:cTn>
-                              </p:par>
-                              <p:par>
-                                <p:cTn id="6" presetID="10" presetClass="entr" presetSubtype="0" fill="hold" grpId="0" nodeType="afterEffect">
-                                  <p:stCondLst>
-                                    <p:cond delay="130"/>
-                                  </p:stCondLst>
-                                  <p:childTnLst>
-                                    <p:set>
-                                      <p:cBhvr>
-                                        <p:cTn id="7" dur="1" fill="hold">
-                                          <p:stCondLst>
-                                            <p:cond delay="0"/>
-                                          </p:stCondLst>
-                                        </p:cTn>
-                                        <p:tgtEl>
-                                          <p:spTgt spid="5"/>
-                                        </p:tgtEl>
-                                        <p:attrNameLst>
-                                          <p:attrName>style.visibility</p:attrName>
-                                        </p:attrNameLst>
-                                      </p:cBhvr>
-                                      <p:to>
-                                        <p:strVal val="visible"/>
-                                      </p:to>
-                                    </p:set>
-                                    <p:animEffect transition="in" filter="fade">
-                                      <p:cBhvr>
-                                        <p:cTn id="8" dur="400"/>
-                                        <p:tgtEl>
-                                          <p:spTgt spid="5"/>
-                                        </p:tgtEl>
-                                      </p:cBhvr>
-                                    </p:animEffect>
-                                  </p:childTnLst>
-                                </p:cTn>
-                              </p:par>
-                              <p:par>
-                                <p:cTn id="9" presetID="10" presetClass="entr" presetSubtype="0" fill="hold" grpId="0" nodeType="afterEffect">
-                                  <p:stCondLst>
-                                    <p:cond delay="260"/>
-                                  </p:stCondLst>
-                                  <p:childTnLst>
-                                    <p:set>
-                                      <p:cBhvr>
-                                        <p:cTn id="10" dur="1" fill="hold">
-                                          <p:stCondLst>
-                                            <p:cond delay="0"/>
-                                          </p:stCondLst>
-                                        </p:cTn>
-                                        <p:tgtEl>
-                                          <p:spTgt spid="6"/>
-                                        </p:tgtEl>
-                                        <p:attrNameLst>
-                                          <p:attrName>style.visibility</p:attrName>
-                                        </p:attrNameLst>
-                                      </p:cBhvr>
-                                      <p:to>
-                                        <p:strVal val="visible"/>
-                                      </p:to>
-                                    </p:set>
-                                    <p:animEffect transition="in" filter="fade">
-                                      <p:cBhvr>
-                                        <p:cTn id="11" dur="400"/>
-                                        <p:tgtEl>
-                                          <p:spTgt spid="6"/>
-                                        </p:tgtEl>
-                                      </p:cBhvr>
-                                    </p:animEffect>
-                                  </p:childTnLst>
-                                </p:cTn>
-                              </p:par>
-                            </p:childTnLst>
-                          </p:cTn>
-                        </p:par>
-                      </p:childTnLst>
-                    </p:cTn>
-                  </p:par>
-                </p:childTnLst>
-              </p:cTn>
-              <p:prevCondLst>
-                <p:cond evt="onPrev" delay="0">
-                  <p:tgtEl>
-                    <p:sldTgt/>
-                  </p:tgtEl>
-                </p:cond>
-              </p:prevCondLst>
-              <p:nextCondLst>
-                <p:cond evt="onNext" delay="0">
-                  <p:tgtEl>
-                    <p:sldTgt/>
-                  </p:tgtEl>
-                </p:cond>
-              </p:nextCondLst>
-            </p:seq>
-          </p:childTnLst>
-        </p:cTn>
-      </p:par>
-    </p:tnLst>
-    <p:bldLst>
-      <p:bldP spid="4" grpId="0"/>
-      <p:bldP spid="5" grpId="0"/>
-      <p:bldP spid="6" grpId="0"/>
-    </p:bldLst>
-  </p:timing>
-</p:sld>
-</file>
-
-<file path=ppt/slides/slide11.xml><?xml version="1.0" encoding="utf-8"?>
-<p:sld xmlns:a="http://schemas.openxmlformats.org/drawingml/2006/main" xmlns:r="http://schemas.openxmlformats.org/officeDocument/2006/relationships" xmlns:p="http://schemas.openxmlformats.org/presentationml/2006/main">
-  <p:cSld name="Slide 11">
-    <p:bg>
-      <p:bgPr>
-        <a:solidFill>
-          <a:srgbClr val="080B0F"/>
-        </a:solidFill>
-      </p:bgPr>
-    </p:bg>
-    <p:spTree>
-      <p:nvGrpSpPr>
-        <p:cNvPr id="1" name=""/>
-        <p:cNvGrpSpPr/>
-        <p:nvPr/>
-      </p:nvGrpSpPr>
-      <p:grpSpPr>
-        <a:xfrm>
-          <a:off x="0" y="0"/>
-          <a:ext cx="0" cy="0"/>
-          <a:chOff x="0" y="0"/>
-          <a:chExt cx="0" cy="0"/>
-        </a:xfrm>
-      </p:grpSpPr>
-      <p:sp>
-        <p:nvSpPr>
-          <p:cNvPr id="2" name="chrome-footer"/>
-          <p:cNvSpPr/>
-          <p:nvPr/>
-        </p:nvSpPr>
-        <p:spPr>
-          <a:xfrm>
-            <a:off x="502920" y="6510528"/>
-            <a:ext cx="4572000" cy="237744"/>
-          </a:xfrm>
-          <a:prstGeom prst="rect">
-            <a:avLst/>
-          </a:prstGeom>
-          <a:noFill/>
-          <a:ln/>
-        </p:spPr>
-        <p:txBody>
-          <a:bodyPr wrap="square" lIns="0" tIns="0" rIns="0" bIns="0" rtlCol="0" anchor="ctr"/>
-          <a:lstStyle/>
-          <a:p>
-            <a:pPr indent="0" marL="0">
-              <a:buNone/>
-            </a:pPr>
-            <a:r>
-              <a:rPr lang="en-US" sz="850" dirty="0">
-                <a:solidFill>
-                  <a:srgbClr val="5C6E82"/>
-                </a:solidFill>
-                <a:latin typeface="Arial" pitchFamily="34" charset="0"/>
-                <a:ea typeface="Arial" pitchFamily="34" charset="-122"/>
-                <a:cs typeface="Arial" pitchFamily="34" charset="-120"/>
-              </a:rPr>
-              <a:t>Fairtech Schweiz · Projekt E-Commerce</a:t>
-            </a:r>
-            <a:endParaRPr lang="en-US" sz="850" dirty="0"/>
-          </a:p>
-        </p:txBody>
-      </p:sp>
-      <p:sp>
-        <p:nvSpPr>
-          <p:cNvPr id="3" name="chrome-page"/>
-          <p:cNvSpPr/>
-          <p:nvPr/>
-        </p:nvSpPr>
-        <p:spPr>
-          <a:xfrm>
-            <a:off x="11430000" y="6510528"/>
-            <a:ext cx="256032" cy="237744"/>
-          </a:xfrm>
-          <a:prstGeom prst="rect">
-            <a:avLst/>
-          </a:prstGeom>
-          <a:noFill/>
-          <a:ln/>
-        </p:spPr>
-        <p:txBody>
-          <a:bodyPr wrap="square" lIns="0" tIns="0" rIns="0" bIns="0" rtlCol="0" anchor="ctr"/>
-          <a:lstStyle/>
-          <a:p>
-            <a:pPr algn="r" indent="0" marL="0">
-              <a:buNone/>
-            </a:pPr>
-            <a:r>
-              <a:rPr lang="en-US" sz="850" dirty="0">
-                <a:solidFill>
-                  <a:srgbClr val="5C6E82"/>
-                </a:solidFill>
-                <a:latin typeface="Arial" pitchFamily="34" charset="0"/>
-                <a:ea typeface="Arial" pitchFamily="34" charset="-122"/>
-                <a:cs typeface="Arial" pitchFamily="34" charset="-120"/>
-              </a:rPr>
-              <a:t>11</a:t>
-            </a:r>
-            <a:endParaRPr lang="en-US" sz="850" dirty="0"/>
-          </a:p>
-        </p:txBody>
-      </p:sp>
-      <p:sp>
-        <p:nvSpPr>
           <p:cNvPr id="4" name="chrome-reserve"/>
           <p:cNvSpPr/>
           <p:nvPr/>
@@ -5379,9 +4855,9 @@
 </p:sld>
 </file>
 
-<file path=ppt/slides/slide12.xml><?xml version="1.0" encoding="utf-8"?>
+<file path=ppt/slides/slide11.xml><?xml version="1.0" encoding="utf-8"?>
 <p:sld xmlns:a="http://schemas.openxmlformats.org/drawingml/2006/main" xmlns:r="http://schemas.openxmlformats.org/officeDocument/2006/relationships" xmlns:p="http://schemas.openxmlformats.org/presentationml/2006/main">
-  <p:cSld name="Slide 12">
+  <p:cSld name="Slide 11">
     <p:bg>
       <p:bgPr>
         <a:solidFill>
@@ -5475,7 +4951,7 @@
                 <a:ea typeface="Arial" pitchFamily="34" charset="-122"/>
                 <a:cs typeface="Arial" pitchFamily="34" charset="-120"/>
               </a:rPr>
-              <a:t>12</a:t>
+              <a:t>11</a:t>
             </a:r>
             <a:endParaRPr lang="en-US" sz="850" dirty="0"/>
           </a:p>
@@ -5561,7 +5037,7 @@
       </p:sp>
       <p:graphicFrame>
         <p:nvGraphicFramePr>
-          <p:cNvPr id="13" name="Table 0"/>
+          <p:cNvPr id="12" name="Table 0"/>
           <p:cNvGraphicFramePr>
             <a:graphicFrameLocks noGrp="1"/>
           </p:cNvGraphicFramePr>
@@ -6744,7 +6220,7 @@
                                           </p:stCondLst>
                                         </p:cTn>
                                         <p:tgtEl>
-                                          <p:spTgt spid="13"/>
+                                          <p:spTgt spid="12"/>
                                         </p:tgtEl>
                                         <p:attrNameLst>
                                           <p:attrName>style.visibility</p:attrName>
@@ -6758,7 +6234,7 @@
                                       <p:cBhvr>
                                         <p:cTn id="11" dur="400"/>
                                         <p:tgtEl>
-                                          <p:spTgt spid="13"/>
+                                          <p:spTgt spid="12"/>
                                         </p:tgtEl>
                                       </p:cBhvr>
                                     </p:animEffect>
@@ -6795,15 +6271,15 @@
     <p:bldLst>
       <p:bldP spid="4" grpId="0"/>
       <p:bldP spid="5" grpId="0"/>
-      <p:bldP spid="13" grpId="0"/>
+      <p:bldP spid="12" grpId="0"/>
     </p:bldLst>
   </p:timing>
 </p:sld>
 </file>
 
-<file path=ppt/slides/slide13.xml><?xml version="1.0" encoding="utf-8"?>
+<file path=ppt/slides/slide12.xml><?xml version="1.0" encoding="utf-8"?>
 <p:sld xmlns:a="http://schemas.openxmlformats.org/drawingml/2006/main" xmlns:r="http://schemas.openxmlformats.org/officeDocument/2006/relationships" xmlns:p="http://schemas.openxmlformats.org/presentationml/2006/main">
-  <p:cSld name="Slide 13">
+  <p:cSld name="Slide 12">
     <p:bg>
       <p:bgPr>
         <a:solidFill>
@@ -6897,7 +6373,7 @@
                 <a:ea typeface="Arial" pitchFamily="34" charset="-122"/>
                 <a:cs typeface="Arial" pitchFamily="34" charset="-120"/>
               </a:rPr>
-              <a:t>13</a:t>
+              <a:t>12</a:t>
             </a:r>
             <a:endParaRPr lang="en-US" sz="850" dirty="0"/>
           </a:p>
@@ -8136,9 +7612,9 @@
 </p:sld>
 </file>
 
-<file path=ppt/slides/slide14.xml><?xml version="1.0" encoding="utf-8"?>
+<file path=ppt/slides/slide13.xml><?xml version="1.0" encoding="utf-8"?>
 <p:sld xmlns:a="http://schemas.openxmlformats.org/drawingml/2006/main" xmlns:r="http://schemas.openxmlformats.org/officeDocument/2006/relationships" xmlns:p="http://schemas.openxmlformats.org/presentationml/2006/main">
-  <p:cSld name="Slide 14">
+  <p:cSld name="Slide 13">
     <p:bg>
       <p:bgPr>
         <a:solidFill>
@@ -8232,7 +7708,7 @@
                 <a:ea typeface="Arial" pitchFamily="34" charset="-122"/>
                 <a:cs typeface="Arial" pitchFamily="34" charset="-120"/>
               </a:rPr>
-              <a:t>14</a:t>
+              <a:t>13</a:t>
             </a:r>
             <a:endParaRPr lang="en-US" sz="850" dirty="0"/>
           </a:p>
@@ -8611,9 +8087,9 @@
 </p:sld>
 </file>
 
-<file path=ppt/slides/slide15.xml><?xml version="1.0" encoding="utf-8"?>
+<file path=ppt/slides/slide14.xml><?xml version="1.0" encoding="utf-8"?>
 <p:sld xmlns:a="http://schemas.openxmlformats.org/drawingml/2006/main" xmlns:r="http://schemas.openxmlformats.org/officeDocument/2006/relationships" xmlns:p="http://schemas.openxmlformats.org/presentationml/2006/main">
-  <p:cSld name="Slide 15">
+  <p:cSld name="Slide 14">
     <p:bg>
       <p:bgPr>
         <a:solidFill>
@@ -8707,7 +8183,7 @@
                 <a:ea typeface="Arial" pitchFamily="34" charset="-122"/>
                 <a:cs typeface="Arial" pitchFamily="34" charset="-120"/>
               </a:rPr>
-              <a:t>15</a:t>
+              <a:t>14</a:t>
             </a:r>
             <a:endParaRPr lang="en-US" sz="850" dirty="0"/>
           </a:p>
@@ -8793,7 +8269,7 @@
       </p:sp>
       <p:graphicFrame>
         <p:nvGraphicFramePr>
-          <p:cNvPr id="16" name="Table 0"/>
+          <p:cNvPr id="15" name="Table 0"/>
           <p:cNvGraphicFramePr>
             <a:graphicFrameLocks noGrp="1"/>
           </p:cNvGraphicFramePr>
@@ -10904,7 +10380,7 @@
                                           </p:stCondLst>
                                         </p:cTn>
                                         <p:tgtEl>
-                                          <p:spTgt spid="16"/>
+                                          <p:spTgt spid="15"/>
                                         </p:tgtEl>
                                         <p:attrNameLst>
                                           <p:attrName>style.visibility</p:attrName>
@@ -10918,7 +10394,7 @@
                                       <p:cBhvr>
                                         <p:cTn id="11" dur="400"/>
                                         <p:tgtEl>
-                                          <p:spTgt spid="16"/>
+                                          <p:spTgt spid="15"/>
                                         </p:tgtEl>
                                       </p:cBhvr>
                                     </p:animEffect>
@@ -10990,16 +10466,16 @@
     <p:bldLst>
       <p:bldP spid="4" grpId="0"/>
       <p:bldP spid="5" grpId="0"/>
-      <p:bldP spid="16" grpId="0"/>
+      <p:bldP spid="15" grpId="0"/>
       <p:bldP spid="7" grpId="0"/>
     </p:bldLst>
   </p:timing>
 </p:sld>
 </file>
 
-<file path=ppt/slides/slide16.xml><?xml version="1.0" encoding="utf-8"?>
+<file path=ppt/slides/slide15.xml><?xml version="1.0" encoding="utf-8"?>
 <p:sld xmlns:a="http://schemas.openxmlformats.org/drawingml/2006/main" xmlns:r="http://schemas.openxmlformats.org/officeDocument/2006/relationships" xmlns:p="http://schemas.openxmlformats.org/presentationml/2006/main">
-  <p:cSld name="Slide 16">
+  <p:cSld name="Slide 15">
     <p:bg>
       <p:bgPr>
         <a:solidFill>
@@ -11093,7 +10569,7 @@
                 <a:ea typeface="Arial" pitchFamily="34" charset="-122"/>
                 <a:cs typeface="Arial" pitchFamily="34" charset="-120"/>
               </a:rPr>
-              <a:t>16</a:t>
+              <a:t>15</a:t>
             </a:r>
             <a:endParaRPr lang="en-US" sz="850" dirty="0"/>
           </a:p>
@@ -12603,9 +12079,9 @@
 </p:sld>
 </file>
 
-<file path=ppt/slides/slide17.xml><?xml version="1.0" encoding="utf-8"?>
+<file path=ppt/slides/slide16.xml><?xml version="1.0" encoding="utf-8"?>
 <p:sld xmlns:a="http://schemas.openxmlformats.org/drawingml/2006/main" xmlns:r="http://schemas.openxmlformats.org/officeDocument/2006/relationships" xmlns:p="http://schemas.openxmlformats.org/presentationml/2006/main">
-  <p:cSld name="Slide 17">
+  <p:cSld name="Slide 16">
     <p:bg>
       <p:bgPr>
         <a:solidFill>
@@ -12699,7 +12175,7 @@
                 <a:ea typeface="Arial" pitchFamily="34" charset="-122"/>
                 <a:cs typeface="Arial" pitchFamily="34" charset="-120"/>
               </a:rPr>
-              <a:t>17</a:t>
+              <a:t>16</a:t>
             </a:r>
             <a:endParaRPr lang="en-US" sz="850" dirty="0"/>
           </a:p>
@@ -13878,9 +13354,9 @@
 </p:sld>
 </file>
 
-<file path=ppt/slides/slide18.xml><?xml version="1.0" encoding="utf-8"?>
+<file path=ppt/slides/slide17.xml><?xml version="1.0" encoding="utf-8"?>
 <p:sld xmlns:a="http://schemas.openxmlformats.org/drawingml/2006/main" xmlns:r="http://schemas.openxmlformats.org/officeDocument/2006/relationships" xmlns:p="http://schemas.openxmlformats.org/presentationml/2006/main">
-  <p:cSld name="Slide 18">
+  <p:cSld name="Slide 17">
     <p:bg>
       <p:bgPr>
         <a:solidFill>
@@ -13974,7 +13450,7 @@
                 <a:ea typeface="Arial" pitchFamily="34" charset="-122"/>
                 <a:cs typeface="Arial" pitchFamily="34" charset="-120"/>
               </a:rPr>
-              <a:t>18</a:t>
+              <a:t>17</a:t>
             </a:r>
             <a:endParaRPr lang="en-US" sz="850" dirty="0"/>
           </a:p>
@@ -14353,9 +13829,9 @@
 </p:sld>
 </file>
 
-<file path=ppt/slides/slide19.xml><?xml version="1.0" encoding="utf-8"?>
+<file path=ppt/slides/slide18.xml><?xml version="1.0" encoding="utf-8"?>
 <p:sld xmlns:a="http://schemas.openxmlformats.org/drawingml/2006/main" xmlns:r="http://schemas.openxmlformats.org/officeDocument/2006/relationships" xmlns:p="http://schemas.openxmlformats.org/presentationml/2006/main">
-  <p:cSld name="Slide 19">
+  <p:cSld name="Slide 18">
     <p:bg>
       <p:bgPr>
         <a:solidFill>
@@ -14449,7 +13925,7 @@
                 <a:ea typeface="Arial" pitchFamily="34" charset="-122"/>
                 <a:cs typeface="Arial" pitchFamily="34" charset="-120"/>
               </a:rPr>
-              <a:t>19</a:t>
+              <a:t>18</a:t>
             </a:r>
             <a:endParaRPr lang="en-US" sz="850" dirty="0"/>
           </a:p>
@@ -15277,6 +14753,1903 @@
       <p:bldP spid="11" grpId="0"/>
       <p:bldP spid="12" grpId="0"/>
       <p:bldP spid="13" grpId="0"/>
+    </p:bldLst>
+  </p:timing>
+</p:sld>
+</file>
+
+<file path=ppt/slides/slide19.xml><?xml version="1.0" encoding="utf-8"?>
+<p:sld xmlns:a="http://schemas.openxmlformats.org/drawingml/2006/main" xmlns:r="http://schemas.openxmlformats.org/officeDocument/2006/relationships" xmlns:p="http://schemas.openxmlformats.org/presentationml/2006/main">
+  <p:cSld name="Slide 19">
+    <p:bg>
+      <p:bgPr>
+        <a:solidFill>
+          <a:srgbClr val="080B0F"/>
+        </a:solidFill>
+      </p:bgPr>
+    </p:bg>
+    <p:spTree>
+      <p:nvGrpSpPr>
+        <p:cNvPr id="1" name=""/>
+        <p:cNvGrpSpPr/>
+        <p:nvPr/>
+      </p:nvGrpSpPr>
+      <p:grpSpPr>
+        <a:xfrm>
+          <a:off x="0" y="0"/>
+          <a:ext cx="0" cy="0"/>
+          <a:chOff x="0" y="0"/>
+          <a:chExt cx="0" cy="0"/>
+        </a:xfrm>
+      </p:grpSpPr>
+      <p:sp>
+        <p:nvSpPr>
+          <p:cNvPr id="2" name="chrome-footer"/>
+          <p:cNvSpPr/>
+          <p:nvPr/>
+        </p:nvSpPr>
+        <p:spPr>
+          <a:xfrm>
+            <a:off x="502920" y="6510528"/>
+            <a:ext cx="4572000" cy="237744"/>
+          </a:xfrm>
+          <a:prstGeom prst="rect">
+            <a:avLst/>
+          </a:prstGeom>
+          <a:noFill/>
+          <a:ln/>
+        </p:spPr>
+        <p:txBody>
+          <a:bodyPr wrap="square" lIns="0" tIns="0" rIns="0" bIns="0" rtlCol="0" anchor="ctr"/>
+          <a:lstStyle/>
+          <a:p>
+            <a:pPr indent="0" marL="0">
+              <a:buNone/>
+            </a:pPr>
+            <a:r>
+              <a:rPr lang="en-US" sz="850" dirty="0">
+                <a:solidFill>
+                  <a:srgbClr val="5C6E82"/>
+                </a:solidFill>
+                <a:latin typeface="Arial" pitchFamily="34" charset="0"/>
+                <a:ea typeface="Arial" pitchFamily="34" charset="-122"/>
+                <a:cs typeface="Arial" pitchFamily="34" charset="-120"/>
+              </a:rPr>
+              <a:t>Fairtech Schweiz · Projekt E-Commerce</a:t>
+            </a:r>
+            <a:endParaRPr lang="en-US" sz="850" dirty="0"/>
+          </a:p>
+        </p:txBody>
+      </p:sp>
+      <p:sp>
+        <p:nvSpPr>
+          <p:cNvPr id="3" name="chrome-page"/>
+          <p:cNvSpPr/>
+          <p:nvPr/>
+        </p:nvSpPr>
+        <p:spPr>
+          <a:xfrm>
+            <a:off x="11430000" y="6510528"/>
+            <a:ext cx="256032" cy="237744"/>
+          </a:xfrm>
+          <a:prstGeom prst="rect">
+            <a:avLst/>
+          </a:prstGeom>
+          <a:noFill/>
+          <a:ln/>
+        </p:spPr>
+        <p:txBody>
+          <a:bodyPr wrap="square" lIns="0" tIns="0" rIns="0" bIns="0" rtlCol="0" anchor="ctr"/>
+          <a:lstStyle/>
+          <a:p>
+            <a:pPr algn="r" indent="0" marL="0">
+              <a:buNone/>
+            </a:pPr>
+            <a:r>
+              <a:rPr lang="en-US" sz="850" dirty="0">
+                <a:solidFill>
+                  <a:srgbClr val="5C6E82"/>
+                </a:solidFill>
+                <a:latin typeface="Arial" pitchFamily="34" charset="0"/>
+                <a:ea typeface="Arial" pitchFamily="34" charset="-122"/>
+                <a:cs typeface="Arial" pitchFamily="34" charset="-120"/>
+              </a:rPr>
+              <a:t>19</a:t>
+            </a:r>
+            <a:endParaRPr lang="en-US" sz="850" dirty="0"/>
+          </a:p>
+        </p:txBody>
+      </p:sp>
+      <p:sp>
+        <p:nvSpPr>
+          <p:cNvPr id="4" name="chrome-reserve"/>
+          <p:cNvSpPr/>
+          <p:nvPr/>
+        </p:nvSpPr>
+        <p:spPr>
+          <a:xfrm>
+            <a:off x="8778240" y="384048"/>
+            <a:ext cx="2926080" cy="274320"/>
+          </a:xfrm>
+          <a:prstGeom prst="rect">
+            <a:avLst/>
+          </a:prstGeom>
+          <a:noFill/>
+          <a:ln/>
+        </p:spPr>
+        <p:txBody>
+          <a:bodyPr wrap="square" lIns="0" tIns="0" rIns="0" bIns="0" rtlCol="0" anchor="ctr"/>
+          <a:lstStyle/>
+          <a:p>
+            <a:pPr algn="r" indent="0" marL="0">
+              <a:buNone/>
+            </a:pPr>
+            <a:r>
+              <a:rPr lang="en-US" sz="900" b="1" spc="200" kern="0" dirty="0">
+                <a:solidFill>
+                  <a:srgbClr val="5C6E82"/>
+                </a:solidFill>
+                <a:latin typeface="Arial" pitchFamily="34" charset="0"/>
+                <a:ea typeface="Arial" pitchFamily="34" charset="-122"/>
+                <a:cs typeface="Arial" pitchFamily="34" charset="-120"/>
+              </a:rPr>
+              <a:t>RESERVE · NUR BEI NACHFRAGE</a:t>
+            </a:r>
+            <a:endParaRPr lang="en-US" sz="900" dirty="0"/>
+          </a:p>
+        </p:txBody>
+      </p:sp>
+      <p:sp>
+        <p:nvSpPr>
+          <p:cNvPr id="5" name="Text 3"/>
+          <p:cNvSpPr/>
+          <p:nvPr/>
+        </p:nvSpPr>
+        <p:spPr>
+          <a:xfrm>
+            <a:off x="502920" y="411480"/>
+            <a:ext cx="8229600" cy="274320"/>
+          </a:xfrm>
+          <a:prstGeom prst="rect">
+            <a:avLst/>
+          </a:prstGeom>
+          <a:noFill/>
+          <a:ln/>
+        </p:spPr>
+        <p:txBody>
+          <a:bodyPr wrap="square" lIns="0" tIns="0" rIns="0" bIns="0" rtlCol="0" anchor="ctr"/>
+          <a:lstStyle/>
+          <a:p>
+            <a:pPr indent="0" marL="0">
+              <a:buNone/>
+            </a:pPr>
+            <a:r>
+              <a:rPr lang="en-US" sz="1050" b="1" spc="300" kern="0" dirty="0">
+                <a:solidFill>
+                  <a:srgbClr val="6699FF"/>
+                </a:solidFill>
+                <a:latin typeface="Arial" pitchFamily="34" charset="0"/>
+                <a:ea typeface="Arial" pitchFamily="34" charset="-122"/>
+                <a:cs typeface="Arial" pitchFamily="34" charset="-120"/>
+              </a:rPr>
+              <a:t>10 · SELBER MACHEN</a:t>
+            </a:r>
+            <a:endParaRPr lang="en-US" sz="1050" dirty="0"/>
+          </a:p>
+        </p:txBody>
+      </p:sp>
+      <p:sp>
+        <p:nvSpPr>
+          <p:cNvPr id="6" name="Text 4"/>
+          <p:cNvSpPr/>
+          <p:nvPr/>
+        </p:nvSpPr>
+        <p:spPr>
+          <a:xfrm>
+            <a:off x="502920" y="777240"/>
+            <a:ext cx="11155680" cy="685800"/>
+          </a:xfrm>
+          <a:prstGeom prst="rect">
+            <a:avLst/>
+          </a:prstGeom>
+          <a:noFill/>
+          <a:ln/>
+        </p:spPr>
+        <p:txBody>
+          <a:bodyPr wrap="square" lIns="0" tIns="0" rIns="0" bIns="0" rtlCol="0" anchor="ctr"/>
+          <a:lstStyle/>
+          <a:p>
+            <a:pPr indent="0" marL="0">
+              <a:buNone/>
+            </a:pPr>
+            <a:r>
+              <a:rPr lang="en-US" sz="3000" b="1" dirty="0">
+                <a:solidFill>
+                  <a:srgbClr val="EDF2F7"/>
+                </a:solidFill>
+                <a:latin typeface="Arial" pitchFamily="34" charset="0"/>
+                <a:ea typeface="Arial" pitchFamily="34" charset="-122"/>
+                <a:cs typeface="Arial" pitchFamily="34" charset="-120"/>
+              </a:rPr>
+              <a:t>In fünf Schritten zum eigenen Shop</a:t>
+            </a:r>
+            <a:endParaRPr lang="en-US" sz="3000" dirty="0"/>
+          </a:p>
+        </p:txBody>
+      </p:sp>
+      <p:sp>
+        <p:nvSpPr>
+          <p:cNvPr id="7" name="Shape 5"/>
+          <p:cNvSpPr/>
+          <p:nvPr/>
+        </p:nvSpPr>
+        <p:spPr>
+          <a:xfrm>
+            <a:off x="502920" y="2103120"/>
+            <a:ext cx="2104949" cy="1828800"/>
+          </a:xfrm>
+          <a:prstGeom prst="roundRect">
+            <a:avLst>
+              <a:gd name="adj" fmla="val 2500"/>
+            </a:avLst>
+          </a:prstGeom>
+          <a:solidFill>
+            <a:srgbClr val="141B24"/>
+          </a:solidFill>
+          <a:ln w="9525">
+            <a:solidFill>
+              <a:srgbClr val="243040"/>
+            </a:solidFill>
+            <a:prstDash val="solid"/>
+          </a:ln>
+        </p:spPr>
+      </p:sp>
+      <p:sp>
+        <p:nvSpPr>
+          <p:cNvPr id="8" name="Text 6"/>
+          <p:cNvSpPr/>
+          <p:nvPr/>
+        </p:nvSpPr>
+        <p:spPr>
+          <a:xfrm>
+            <a:off x="704088" y="2267712"/>
+            <a:ext cx="548640" cy="274320"/>
+          </a:xfrm>
+          <a:prstGeom prst="rect">
+            <a:avLst/>
+          </a:prstGeom>
+          <a:noFill/>
+          <a:ln/>
+        </p:spPr>
+        <p:txBody>
+          <a:bodyPr wrap="square" lIns="0" tIns="0" rIns="0" bIns="0" rtlCol="0" anchor="ctr"/>
+          <a:lstStyle/>
+          <a:p>
+            <a:pPr indent="0" marL="0">
+              <a:buNone/>
+            </a:pPr>
+            <a:r>
+              <a:rPr lang="en-US" sz="1100" b="1" dirty="0">
+                <a:solidFill>
+                  <a:srgbClr val="6699FF"/>
+                </a:solidFill>
+                <a:latin typeface="Arial" pitchFamily="34" charset="0"/>
+                <a:ea typeface="Arial" pitchFamily="34" charset="-122"/>
+                <a:cs typeface="Arial" pitchFamily="34" charset="-120"/>
+              </a:rPr>
+              <a:t>1</a:t>
+            </a:r>
+            <a:endParaRPr lang="en-US" sz="1100" dirty="0"/>
+          </a:p>
+        </p:txBody>
+      </p:sp>
+      <p:sp>
+        <p:nvSpPr>
+          <p:cNvPr id="9" name="Text 7"/>
+          <p:cNvSpPr/>
+          <p:nvPr/>
+        </p:nvSpPr>
+        <p:spPr>
+          <a:xfrm>
+            <a:off x="704088" y="2560320"/>
+            <a:ext cx="1702613" cy="365760"/>
+          </a:xfrm>
+          <a:prstGeom prst="rect">
+            <a:avLst/>
+          </a:prstGeom>
+          <a:noFill/>
+          <a:ln/>
+        </p:spPr>
+        <p:txBody>
+          <a:bodyPr wrap="square" lIns="0" tIns="0" rIns="0" bIns="0" rtlCol="0" anchor="ctr"/>
+          <a:lstStyle/>
+          <a:p>
+            <a:pPr indent="0" marL="0">
+              <a:buNone/>
+            </a:pPr>
+            <a:r>
+              <a:rPr lang="en-US" sz="1350" b="1" dirty="0">
+                <a:solidFill>
+                  <a:srgbClr val="EDF2F7"/>
+                </a:solidFill>
+                <a:latin typeface="Arial" pitchFamily="34" charset="0"/>
+                <a:ea typeface="Arial" pitchFamily="34" charset="-122"/>
+                <a:cs typeface="Arial" pitchFamily="34" charset="-120"/>
+              </a:rPr>
+              <a:t>Konto</a:t>
+            </a:r>
+            <a:endParaRPr lang="en-US" sz="1350" dirty="0"/>
+          </a:p>
+        </p:txBody>
+      </p:sp>
+      <p:sp>
+        <p:nvSpPr>
+          <p:cNvPr id="10" name="Text 8"/>
+          <p:cNvSpPr/>
+          <p:nvPr/>
+        </p:nvSpPr>
+        <p:spPr>
+          <a:xfrm>
+            <a:off x="704088" y="2944368"/>
+            <a:ext cx="1702613" cy="822960"/>
+          </a:xfrm>
+          <a:prstGeom prst="rect">
+            <a:avLst/>
+          </a:prstGeom>
+          <a:noFill/>
+          <a:ln/>
+        </p:spPr>
+        <p:txBody>
+          <a:bodyPr wrap="square" lIns="0" tIns="0" rIns="0" bIns="0" rtlCol="0" anchor="ctr"/>
+          <a:lstStyle/>
+          <a:p>
+            <a:pPr indent="0" marL="0">
+              <a:lnSpc>
+                <a:spcPct val="115000"/>
+              </a:lnSpc>
+              <a:buNone/>
+            </a:pPr>
+            <a:r>
+              <a:rPr lang="en-US" sz="1000" dirty="0">
+                <a:solidFill>
+                  <a:srgbClr val="8FA0B4"/>
+                </a:solidFill>
+                <a:latin typeface="Arial" pitchFamily="34" charset="0"/>
+                <a:ea typeface="Arial" pitchFamily="34" charset="-122"/>
+                <a:cs typeface="Arial" pitchFamily="34" charset="-120"/>
+              </a:rPr>
+              <a:t>shopify.com — 3 Tage gratis, dann CHF 1/Monat</a:t>
+            </a:r>
+            <a:endParaRPr lang="en-US" sz="1000" dirty="0"/>
+          </a:p>
+        </p:txBody>
+      </p:sp>
+      <p:sp>
+        <p:nvSpPr>
+          <p:cNvPr id="11" name="Shape 9"/>
+          <p:cNvSpPr/>
+          <p:nvPr/>
+        </p:nvSpPr>
+        <p:spPr>
+          <a:xfrm>
+            <a:off x="2772461" y="2103120"/>
+            <a:ext cx="2104949" cy="1828800"/>
+          </a:xfrm>
+          <a:prstGeom prst="roundRect">
+            <a:avLst>
+              <a:gd name="adj" fmla="val 2500"/>
+            </a:avLst>
+          </a:prstGeom>
+          <a:solidFill>
+            <a:srgbClr val="141B24"/>
+          </a:solidFill>
+          <a:ln w="9525">
+            <a:solidFill>
+              <a:srgbClr val="243040"/>
+            </a:solidFill>
+            <a:prstDash val="solid"/>
+          </a:ln>
+        </p:spPr>
+      </p:sp>
+      <p:sp>
+        <p:nvSpPr>
+          <p:cNvPr id="12" name="Text 10"/>
+          <p:cNvSpPr/>
+          <p:nvPr/>
+        </p:nvSpPr>
+        <p:spPr>
+          <a:xfrm>
+            <a:off x="2973629" y="2267712"/>
+            <a:ext cx="548640" cy="274320"/>
+          </a:xfrm>
+          <a:prstGeom prst="rect">
+            <a:avLst/>
+          </a:prstGeom>
+          <a:noFill/>
+          <a:ln/>
+        </p:spPr>
+        <p:txBody>
+          <a:bodyPr wrap="square" lIns="0" tIns="0" rIns="0" bIns="0" rtlCol="0" anchor="ctr"/>
+          <a:lstStyle/>
+          <a:p>
+            <a:pPr indent="0" marL="0">
+              <a:buNone/>
+            </a:pPr>
+            <a:r>
+              <a:rPr lang="en-US" sz="1100" b="1" dirty="0">
+                <a:solidFill>
+                  <a:srgbClr val="6699FF"/>
+                </a:solidFill>
+                <a:latin typeface="Arial" pitchFamily="34" charset="0"/>
+                <a:ea typeface="Arial" pitchFamily="34" charset="-122"/>
+                <a:cs typeface="Arial" pitchFamily="34" charset="-120"/>
+              </a:rPr>
+              <a:t>2</a:t>
+            </a:r>
+            <a:endParaRPr lang="en-US" sz="1100" dirty="0"/>
+          </a:p>
+        </p:txBody>
+      </p:sp>
+      <p:sp>
+        <p:nvSpPr>
+          <p:cNvPr id="13" name="Text 11"/>
+          <p:cNvSpPr/>
+          <p:nvPr/>
+        </p:nvSpPr>
+        <p:spPr>
+          <a:xfrm>
+            <a:off x="2973629" y="2560320"/>
+            <a:ext cx="1702613" cy="365760"/>
+          </a:xfrm>
+          <a:prstGeom prst="rect">
+            <a:avLst/>
+          </a:prstGeom>
+          <a:noFill/>
+          <a:ln/>
+        </p:spPr>
+        <p:txBody>
+          <a:bodyPr wrap="square" lIns="0" tIns="0" rIns="0" bIns="0" rtlCol="0" anchor="ctr"/>
+          <a:lstStyle/>
+          <a:p>
+            <a:pPr indent="0" marL="0">
+              <a:buNone/>
+            </a:pPr>
+            <a:r>
+              <a:rPr lang="en-US" sz="1350" b="1" dirty="0">
+                <a:solidFill>
+                  <a:srgbClr val="EDF2F7"/>
+                </a:solidFill>
+                <a:latin typeface="Arial" pitchFamily="34" charset="0"/>
+                <a:ea typeface="Arial" pitchFamily="34" charset="-122"/>
+                <a:cs typeface="Arial" pitchFamily="34" charset="-120"/>
+              </a:rPr>
+              <a:t>Produkte</a:t>
+            </a:r>
+            <a:endParaRPr lang="en-US" sz="1350" dirty="0"/>
+          </a:p>
+        </p:txBody>
+      </p:sp>
+      <p:sp>
+        <p:nvSpPr>
+          <p:cNvPr id="14" name="Text 12"/>
+          <p:cNvSpPr/>
+          <p:nvPr/>
+        </p:nvSpPr>
+        <p:spPr>
+          <a:xfrm>
+            <a:off x="2973629" y="2944368"/>
+            <a:ext cx="1702613" cy="822960"/>
+          </a:xfrm>
+          <a:prstGeom prst="rect">
+            <a:avLst/>
+          </a:prstGeom>
+          <a:noFill/>
+          <a:ln/>
+        </p:spPr>
+        <p:txBody>
+          <a:bodyPr wrap="square" lIns="0" tIns="0" rIns="0" bIns="0" rtlCol="0" anchor="ctr"/>
+          <a:lstStyle/>
+          <a:p>
+            <a:pPr indent="0" marL="0">
+              <a:lnSpc>
+                <a:spcPct val="115000"/>
+              </a:lnSpc>
+              <a:buNone/>
+            </a:pPr>
+            <a:r>
+              <a:rPr lang="en-US" sz="1000" dirty="0">
+                <a:solidFill>
+                  <a:srgbClr val="8FA0B4"/>
+                </a:solidFill>
+                <a:latin typeface="Arial" pitchFamily="34" charset="0"/>
+                <a:ea typeface="Arial" pitchFamily="34" charset="-122"/>
+                <a:cs typeface="Arial" pitchFamily="34" charset="-120"/>
+              </a:rPr>
+              <a:t>6 Artikel anlegen: Foto, Text, Preis</a:t>
+            </a:r>
+            <a:endParaRPr lang="en-US" sz="1000" dirty="0"/>
+          </a:p>
+        </p:txBody>
+      </p:sp>
+      <p:sp>
+        <p:nvSpPr>
+          <p:cNvPr id="15" name="Shape 13"/>
+          <p:cNvSpPr/>
+          <p:nvPr/>
+        </p:nvSpPr>
+        <p:spPr>
+          <a:xfrm>
+            <a:off x="5042002" y="2103120"/>
+            <a:ext cx="2104949" cy="1828800"/>
+          </a:xfrm>
+          <a:prstGeom prst="roundRect">
+            <a:avLst>
+              <a:gd name="adj" fmla="val 2500"/>
+            </a:avLst>
+          </a:prstGeom>
+          <a:solidFill>
+            <a:srgbClr val="141B24"/>
+          </a:solidFill>
+          <a:ln w="9525">
+            <a:solidFill>
+              <a:srgbClr val="243040"/>
+            </a:solidFill>
+            <a:prstDash val="solid"/>
+          </a:ln>
+        </p:spPr>
+      </p:sp>
+      <p:sp>
+        <p:nvSpPr>
+          <p:cNvPr id="16" name="Text 14"/>
+          <p:cNvSpPr/>
+          <p:nvPr/>
+        </p:nvSpPr>
+        <p:spPr>
+          <a:xfrm>
+            <a:off x="5243170" y="2267712"/>
+            <a:ext cx="548640" cy="274320"/>
+          </a:xfrm>
+          <a:prstGeom prst="rect">
+            <a:avLst/>
+          </a:prstGeom>
+          <a:noFill/>
+          <a:ln/>
+        </p:spPr>
+        <p:txBody>
+          <a:bodyPr wrap="square" lIns="0" tIns="0" rIns="0" bIns="0" rtlCol="0" anchor="ctr"/>
+          <a:lstStyle/>
+          <a:p>
+            <a:pPr indent="0" marL="0">
+              <a:buNone/>
+            </a:pPr>
+            <a:r>
+              <a:rPr lang="en-US" sz="1100" b="1" dirty="0">
+                <a:solidFill>
+                  <a:srgbClr val="6699FF"/>
+                </a:solidFill>
+                <a:latin typeface="Arial" pitchFamily="34" charset="0"/>
+                <a:ea typeface="Arial" pitchFamily="34" charset="-122"/>
+                <a:cs typeface="Arial" pitchFamily="34" charset="-120"/>
+              </a:rPr>
+              <a:t>3</a:t>
+            </a:r>
+            <a:endParaRPr lang="en-US" sz="1100" dirty="0"/>
+          </a:p>
+        </p:txBody>
+      </p:sp>
+      <p:sp>
+        <p:nvSpPr>
+          <p:cNvPr id="17" name="Text 15"/>
+          <p:cNvSpPr/>
+          <p:nvPr/>
+        </p:nvSpPr>
+        <p:spPr>
+          <a:xfrm>
+            <a:off x="5243170" y="2560320"/>
+            <a:ext cx="1702613" cy="365760"/>
+          </a:xfrm>
+          <a:prstGeom prst="rect">
+            <a:avLst/>
+          </a:prstGeom>
+          <a:noFill/>
+          <a:ln/>
+        </p:spPr>
+        <p:txBody>
+          <a:bodyPr wrap="square" lIns="0" tIns="0" rIns="0" bIns="0" rtlCol="0" anchor="ctr"/>
+          <a:lstStyle/>
+          <a:p>
+            <a:pPr indent="0" marL="0">
+              <a:buNone/>
+            </a:pPr>
+            <a:r>
+              <a:rPr lang="en-US" sz="1350" b="1" dirty="0">
+                <a:solidFill>
+                  <a:srgbClr val="EDF2F7"/>
+                </a:solidFill>
+                <a:latin typeface="Arial" pitchFamily="34" charset="0"/>
+                <a:ea typeface="Arial" pitchFamily="34" charset="-122"/>
+                <a:cs typeface="Arial" pitchFamily="34" charset="-120"/>
+              </a:rPr>
+              <a:t>Zahlung</a:t>
+            </a:r>
+            <a:endParaRPr lang="en-US" sz="1350" dirty="0"/>
+          </a:p>
+        </p:txBody>
+      </p:sp>
+      <p:sp>
+        <p:nvSpPr>
+          <p:cNvPr id="18" name="Text 16"/>
+          <p:cNvSpPr/>
+          <p:nvPr/>
+        </p:nvSpPr>
+        <p:spPr>
+          <a:xfrm>
+            <a:off x="5243170" y="2944368"/>
+            <a:ext cx="1702613" cy="822960"/>
+          </a:xfrm>
+          <a:prstGeom prst="rect">
+            <a:avLst/>
+          </a:prstGeom>
+          <a:noFill/>
+          <a:ln/>
+        </p:spPr>
+        <p:txBody>
+          <a:bodyPr wrap="square" lIns="0" tIns="0" rIns="0" bIns="0" rtlCol="0" anchor="ctr"/>
+          <a:lstStyle/>
+          <a:p>
+            <a:pPr indent="0" marL="0">
+              <a:lnSpc>
+                <a:spcPct val="115000"/>
+              </a:lnSpc>
+              <a:buNone/>
+            </a:pPr>
+            <a:r>
+              <a:rPr lang="en-US" sz="1000" dirty="0">
+                <a:solidFill>
+                  <a:srgbClr val="8FA0B4"/>
+                </a:solidFill>
+                <a:latin typeface="Arial" pitchFamily="34" charset="0"/>
+                <a:ea typeface="Arial" pitchFamily="34" charset="-122"/>
+                <a:cs typeface="Arial" pitchFamily="34" charset="-120"/>
+              </a:rPr>
+              <a:t>TWINT und Karte einschalten</a:t>
+            </a:r>
+            <a:endParaRPr lang="en-US" sz="1000" dirty="0"/>
+          </a:p>
+        </p:txBody>
+      </p:sp>
+      <p:sp>
+        <p:nvSpPr>
+          <p:cNvPr id="19" name="Shape 17"/>
+          <p:cNvSpPr/>
+          <p:nvPr/>
+        </p:nvSpPr>
+        <p:spPr>
+          <a:xfrm>
+            <a:off x="7311542" y="2103120"/>
+            <a:ext cx="2104949" cy="1828800"/>
+          </a:xfrm>
+          <a:prstGeom prst="roundRect">
+            <a:avLst>
+              <a:gd name="adj" fmla="val 2500"/>
+            </a:avLst>
+          </a:prstGeom>
+          <a:solidFill>
+            <a:srgbClr val="141B24"/>
+          </a:solidFill>
+          <a:ln w="9525">
+            <a:solidFill>
+              <a:srgbClr val="243040"/>
+            </a:solidFill>
+            <a:prstDash val="solid"/>
+          </a:ln>
+        </p:spPr>
+      </p:sp>
+      <p:sp>
+        <p:nvSpPr>
+          <p:cNvPr id="20" name="Text 18"/>
+          <p:cNvSpPr/>
+          <p:nvPr/>
+        </p:nvSpPr>
+        <p:spPr>
+          <a:xfrm>
+            <a:off x="7512710" y="2267712"/>
+            <a:ext cx="548640" cy="274320"/>
+          </a:xfrm>
+          <a:prstGeom prst="rect">
+            <a:avLst/>
+          </a:prstGeom>
+          <a:noFill/>
+          <a:ln/>
+        </p:spPr>
+        <p:txBody>
+          <a:bodyPr wrap="square" lIns="0" tIns="0" rIns="0" bIns="0" rtlCol="0" anchor="ctr"/>
+          <a:lstStyle/>
+          <a:p>
+            <a:pPr indent="0" marL="0">
+              <a:buNone/>
+            </a:pPr>
+            <a:r>
+              <a:rPr lang="en-US" sz="1100" b="1" dirty="0">
+                <a:solidFill>
+                  <a:srgbClr val="6699FF"/>
+                </a:solidFill>
+                <a:latin typeface="Arial" pitchFamily="34" charset="0"/>
+                <a:ea typeface="Arial" pitchFamily="34" charset="-122"/>
+                <a:cs typeface="Arial" pitchFamily="34" charset="-120"/>
+              </a:rPr>
+              <a:t>4</a:t>
+            </a:r>
+            <a:endParaRPr lang="en-US" sz="1100" dirty="0"/>
+          </a:p>
+        </p:txBody>
+      </p:sp>
+      <p:sp>
+        <p:nvSpPr>
+          <p:cNvPr id="21" name="Text 19"/>
+          <p:cNvSpPr/>
+          <p:nvPr/>
+        </p:nvSpPr>
+        <p:spPr>
+          <a:xfrm>
+            <a:off x="7512710" y="2560320"/>
+            <a:ext cx="1702613" cy="365760"/>
+          </a:xfrm>
+          <a:prstGeom prst="rect">
+            <a:avLst/>
+          </a:prstGeom>
+          <a:noFill/>
+          <a:ln/>
+        </p:spPr>
+        <p:txBody>
+          <a:bodyPr wrap="square" lIns="0" tIns="0" rIns="0" bIns="0" rtlCol="0" anchor="ctr"/>
+          <a:lstStyle/>
+          <a:p>
+            <a:pPr indent="0" marL="0">
+              <a:buNone/>
+            </a:pPr>
+            <a:r>
+              <a:rPr lang="en-US" sz="1350" b="1" dirty="0">
+                <a:solidFill>
+                  <a:srgbClr val="EDF2F7"/>
+                </a:solidFill>
+                <a:latin typeface="Arial" pitchFamily="34" charset="0"/>
+                <a:ea typeface="Arial" pitchFamily="34" charset="-122"/>
+                <a:cs typeface="Arial" pitchFamily="34" charset="-120"/>
+              </a:rPr>
+              <a:t>Versand</a:t>
+            </a:r>
+            <a:endParaRPr lang="en-US" sz="1350" dirty="0"/>
+          </a:p>
+        </p:txBody>
+      </p:sp>
+      <p:sp>
+        <p:nvSpPr>
+          <p:cNvPr id="22" name="Text 20"/>
+          <p:cNvSpPr/>
+          <p:nvPr/>
+        </p:nvSpPr>
+        <p:spPr>
+          <a:xfrm>
+            <a:off x="7512710" y="2944368"/>
+            <a:ext cx="1702613" cy="822960"/>
+          </a:xfrm>
+          <a:prstGeom prst="rect">
+            <a:avLst/>
+          </a:prstGeom>
+          <a:noFill/>
+          <a:ln/>
+        </p:spPr>
+        <p:txBody>
+          <a:bodyPr wrap="square" lIns="0" tIns="0" rIns="0" bIns="0" rtlCol="0" anchor="ctr"/>
+          <a:lstStyle/>
+          <a:p>
+            <a:pPr indent="0" marL="0">
+              <a:lnSpc>
+                <a:spcPct val="115000"/>
+              </a:lnSpc>
+              <a:buNone/>
+            </a:pPr>
+            <a:r>
+              <a:rPr lang="en-US" sz="1000" dirty="0">
+                <a:solidFill>
+                  <a:srgbClr val="8FA0B4"/>
+                </a:solidFill>
+                <a:latin typeface="Arial" pitchFamily="34" charset="0"/>
+                <a:ea typeface="Arial" pitchFamily="34" charset="-122"/>
+                <a:cs typeface="Arial" pitchFamily="34" charset="-120"/>
+              </a:rPr>
+              <a:t>Post-Tarife hinterlegen, versichert</a:t>
+            </a:r>
+            <a:endParaRPr lang="en-US" sz="1000" dirty="0"/>
+          </a:p>
+        </p:txBody>
+      </p:sp>
+      <p:sp>
+        <p:nvSpPr>
+          <p:cNvPr id="23" name="Shape 21"/>
+          <p:cNvSpPr/>
+          <p:nvPr/>
+        </p:nvSpPr>
+        <p:spPr>
+          <a:xfrm>
+            <a:off x="9581083" y="2103120"/>
+            <a:ext cx="2104949" cy="1828800"/>
+          </a:xfrm>
+          <a:prstGeom prst="roundRect">
+            <a:avLst>
+              <a:gd name="adj" fmla="val 2500"/>
+            </a:avLst>
+          </a:prstGeom>
+          <a:solidFill>
+            <a:srgbClr val="141B24"/>
+          </a:solidFill>
+          <a:ln w="9525">
+            <a:solidFill>
+              <a:srgbClr val="243040"/>
+            </a:solidFill>
+            <a:prstDash val="solid"/>
+          </a:ln>
+        </p:spPr>
+      </p:sp>
+      <p:sp>
+        <p:nvSpPr>
+          <p:cNvPr id="24" name="Text 22"/>
+          <p:cNvSpPr/>
+          <p:nvPr/>
+        </p:nvSpPr>
+        <p:spPr>
+          <a:xfrm>
+            <a:off x="9782251" y="2267712"/>
+            <a:ext cx="548640" cy="274320"/>
+          </a:xfrm>
+          <a:prstGeom prst="rect">
+            <a:avLst/>
+          </a:prstGeom>
+          <a:noFill/>
+          <a:ln/>
+        </p:spPr>
+        <p:txBody>
+          <a:bodyPr wrap="square" lIns="0" tIns="0" rIns="0" bIns="0" rtlCol="0" anchor="ctr"/>
+          <a:lstStyle/>
+          <a:p>
+            <a:pPr indent="0" marL="0">
+              <a:buNone/>
+            </a:pPr>
+            <a:r>
+              <a:rPr lang="en-US" sz="1100" b="1" dirty="0">
+                <a:solidFill>
+                  <a:srgbClr val="6699FF"/>
+                </a:solidFill>
+                <a:latin typeface="Arial" pitchFamily="34" charset="0"/>
+                <a:ea typeface="Arial" pitchFamily="34" charset="-122"/>
+                <a:cs typeface="Arial" pitchFamily="34" charset="-120"/>
+              </a:rPr>
+              <a:t>5</a:t>
+            </a:r>
+            <a:endParaRPr lang="en-US" sz="1100" dirty="0"/>
+          </a:p>
+        </p:txBody>
+      </p:sp>
+      <p:sp>
+        <p:nvSpPr>
+          <p:cNvPr id="25" name="Text 23"/>
+          <p:cNvSpPr/>
+          <p:nvPr/>
+        </p:nvSpPr>
+        <p:spPr>
+          <a:xfrm>
+            <a:off x="9782251" y="2560320"/>
+            <a:ext cx="1702613" cy="365760"/>
+          </a:xfrm>
+          <a:prstGeom prst="rect">
+            <a:avLst/>
+          </a:prstGeom>
+          <a:noFill/>
+          <a:ln/>
+        </p:spPr>
+        <p:txBody>
+          <a:bodyPr wrap="square" lIns="0" tIns="0" rIns="0" bIns="0" rtlCol="0" anchor="ctr"/>
+          <a:lstStyle/>
+          <a:p>
+            <a:pPr indent="0" marL="0">
+              <a:buNone/>
+            </a:pPr>
+            <a:r>
+              <a:rPr lang="en-US" sz="1350" b="1" dirty="0">
+                <a:solidFill>
+                  <a:srgbClr val="EDF2F7"/>
+                </a:solidFill>
+                <a:latin typeface="Arial" pitchFamily="34" charset="0"/>
+                <a:ea typeface="Arial" pitchFamily="34" charset="-122"/>
+                <a:cs typeface="Arial" pitchFamily="34" charset="-120"/>
+              </a:rPr>
+              <a:t>Testkauf</a:t>
+            </a:r>
+            <a:endParaRPr lang="en-US" sz="1350" dirty="0"/>
+          </a:p>
+        </p:txBody>
+      </p:sp>
+      <p:sp>
+        <p:nvSpPr>
+          <p:cNvPr id="26" name="Text 24"/>
+          <p:cNvSpPr/>
+          <p:nvPr/>
+        </p:nvSpPr>
+        <p:spPr>
+          <a:xfrm>
+            <a:off x="9782251" y="2944368"/>
+            <a:ext cx="1702613" cy="822960"/>
+          </a:xfrm>
+          <a:prstGeom prst="rect">
+            <a:avLst/>
+          </a:prstGeom>
+          <a:noFill/>
+          <a:ln/>
+        </p:spPr>
+        <p:txBody>
+          <a:bodyPr wrap="square" lIns="0" tIns="0" rIns="0" bIns="0" rtlCol="0" anchor="ctr"/>
+          <a:lstStyle/>
+          <a:p>
+            <a:pPr indent="0" marL="0">
+              <a:lnSpc>
+                <a:spcPct val="115000"/>
+              </a:lnSpc>
+              <a:buNone/>
+            </a:pPr>
+            <a:r>
+              <a:rPr lang="en-US" sz="1000" dirty="0">
+                <a:solidFill>
+                  <a:srgbClr val="8FA0B4"/>
+                </a:solidFill>
+                <a:latin typeface="Arial" pitchFamily="34" charset="0"/>
+                <a:ea typeface="Arial" pitchFamily="34" charset="-122"/>
+                <a:cs typeface="Arial" pitchFamily="34" charset="-120"/>
+              </a:rPr>
+              <a:t>Selber bestellen — Screenshot als Beweis</a:t>
+            </a:r>
+            <a:endParaRPr lang="en-US" sz="1000" dirty="0"/>
+          </a:p>
+        </p:txBody>
+      </p:sp>
+      <p:sp>
+        <p:nvSpPr>
+          <p:cNvPr id="27" name="Text 25"/>
+          <p:cNvSpPr/>
+          <p:nvPr/>
+        </p:nvSpPr>
+        <p:spPr>
+          <a:xfrm>
+            <a:off x="502920" y="4389120"/>
+            <a:ext cx="10515600" cy="685800"/>
+          </a:xfrm>
+          <a:prstGeom prst="rect">
+            <a:avLst/>
+          </a:prstGeom>
+          <a:noFill/>
+          <a:ln/>
+        </p:spPr>
+        <p:txBody>
+          <a:bodyPr wrap="square" lIns="0" tIns="0" rIns="0" bIns="0" rtlCol="0" anchor="ctr"/>
+          <a:lstStyle/>
+          <a:p>
+            <a:pPr indent="0" marL="0">
+              <a:lnSpc>
+                <a:spcPct val="120000"/>
+              </a:lnSpc>
+              <a:buNone/>
+            </a:pPr>
+            <a:r>
+              <a:rPr lang="en-US" sz="1350" dirty="0">
+                <a:solidFill>
+                  <a:srgbClr val="8FA0B4"/>
+                </a:solidFill>
+                <a:latin typeface="Arial" pitchFamily="34" charset="0"/>
+                <a:ea typeface="Arial" pitchFamily="34" charset="-122"/>
+                <a:cs typeface="Arial" pitchFamily="34" charset="-120"/>
+              </a:rPr>
+              <a:t>Wie ein Tutorial: wer das nachmacht, hat am Wochenende einen eigenen Shop.</a:t>
+            </a:r>
+            <a:endParaRPr lang="en-US" sz="1350" dirty="0"/>
+          </a:p>
+        </p:txBody>
+      </p:sp>
+    </p:spTree>
+  </p:cSld>
+  <p:clrMapOvr>
+    <a:masterClrMapping/>
+  </p:clrMapOvr>
+  <mc:AlternateContent xmlns:mc="http://schemas.openxmlformats.org/markup-compatibility/2006">
+    <mc:Choice xmlns:p159="http://schemas.microsoft.com/office/powerpoint/2015/09/main" Requires="p159">
+      <p:transition xmlns:p14="http://schemas.microsoft.com/office/powerpoint/2010/main" spd="slow" p14:dur="700">
+        <p159:morph option="byObject"/>
+      </p:transition>
+    </mc:Choice>
+    <mc:Fallback>
+      <p:transition spd="slow">
+        <p:fade/>
+      </p:transition>
+    </mc:Fallback>
+  </mc:AlternateContent>
+  <p:timing>
+    <p:tnLst>
+      <p:par>
+        <p:cTn id="1" dur="indefinite" restart="never" nodeType="tmRoot">
+          <p:childTnLst>
+            <p:seq concurrent="1" nextAc="seek">
+              <p:cTn id="2" dur="indefinite" nodeType="mainSeq">
+                <p:childTnLst>
+                  <p:par>
+                    <p:cTn id="73" fill="hold">
+                      <p:stCondLst>
+                        <p:cond delay="indefinite"/>
+                        <p:cond evt="onBegin" delay="0">
+                          <p:tn val="2"/>
+                        </p:cond>
+                      </p:stCondLst>
+                      <p:childTnLst>
+                        <p:par>
+                          <p:cTn id="72" fill="hold">
+                            <p:stCondLst>
+                              <p:cond delay="0"/>
+                            </p:stCondLst>
+                            <p:childTnLst>
+                              <p:par>
+                                <p:cTn id="3" presetID="10" presetClass="entr" presetSubtype="0" fill="hold" grpId="0" nodeType="withEffect">
+                                  <p:stCondLst>
+                                    <p:cond delay="0"/>
+                                  </p:stCondLst>
+                                  <p:childTnLst>
+                                    <p:set>
+                                      <p:cBhvr>
+                                        <p:cTn id="4" dur="1" fill="hold">
+                                          <p:stCondLst>
+                                            <p:cond delay="0"/>
+                                          </p:stCondLst>
+                                        </p:cTn>
+                                        <p:tgtEl>
+                                          <p:spTgt spid="5"/>
+                                        </p:tgtEl>
+                                        <p:attrNameLst>
+                                          <p:attrName>style.visibility</p:attrName>
+                                        </p:attrNameLst>
+                                      </p:cBhvr>
+                                      <p:to>
+                                        <p:strVal val="visible"/>
+                                      </p:to>
+                                    </p:set>
+                                    <p:animEffect transition="in" filter="fade">
+                                      <p:cBhvr>
+                                        <p:cTn id="5" dur="400"/>
+                                        <p:tgtEl>
+                                          <p:spTgt spid="5"/>
+                                        </p:tgtEl>
+                                      </p:cBhvr>
+                                    </p:animEffect>
+                                  </p:childTnLst>
+                                </p:cTn>
+                              </p:par>
+                              <p:par>
+                                <p:cTn id="6" presetID="10" presetClass="entr" presetSubtype="0" fill="hold" grpId="0" nodeType="afterEffect">
+                                  <p:stCondLst>
+                                    <p:cond delay="130"/>
+                                  </p:stCondLst>
+                                  <p:childTnLst>
+                                    <p:set>
+                                      <p:cBhvr>
+                                        <p:cTn id="7" dur="1" fill="hold">
+                                          <p:stCondLst>
+                                            <p:cond delay="0"/>
+                                          </p:stCondLst>
+                                        </p:cTn>
+                                        <p:tgtEl>
+                                          <p:spTgt spid="6"/>
+                                        </p:tgtEl>
+                                        <p:attrNameLst>
+                                          <p:attrName>style.visibility</p:attrName>
+                                        </p:attrNameLst>
+                                      </p:cBhvr>
+                                      <p:to>
+                                        <p:strVal val="visible"/>
+                                      </p:to>
+                                    </p:set>
+                                    <p:animEffect transition="in" filter="fade">
+                                      <p:cBhvr>
+                                        <p:cTn id="8" dur="400"/>
+                                        <p:tgtEl>
+                                          <p:spTgt spid="6"/>
+                                        </p:tgtEl>
+                                      </p:cBhvr>
+                                    </p:animEffect>
+                                  </p:childTnLst>
+                                </p:cTn>
+                              </p:par>
+                              <p:par>
+                                <p:cTn id="9" presetID="10" presetClass="entr" presetSubtype="0" fill="hold" grpId="0" nodeType="afterEffect">
+                                  <p:stCondLst>
+                                    <p:cond delay="260"/>
+                                  </p:stCondLst>
+                                  <p:childTnLst>
+                                    <p:set>
+                                      <p:cBhvr>
+                                        <p:cTn id="10" dur="1" fill="hold">
+                                          <p:stCondLst>
+                                            <p:cond delay="0"/>
+                                          </p:stCondLst>
+                                        </p:cTn>
+                                        <p:tgtEl>
+                                          <p:spTgt spid="7"/>
+                                        </p:tgtEl>
+                                        <p:attrNameLst>
+                                          <p:attrName>style.visibility</p:attrName>
+                                        </p:attrNameLst>
+                                      </p:cBhvr>
+                                      <p:to>
+                                        <p:strVal val="visible"/>
+                                      </p:to>
+                                    </p:set>
+                                    <p:animEffect transition="in" filter="fade">
+                                      <p:cBhvr>
+                                        <p:cTn id="11" dur="400"/>
+                                        <p:tgtEl>
+                                          <p:spTgt spid="7"/>
+                                        </p:tgtEl>
+                                      </p:cBhvr>
+                                    </p:animEffect>
+                                  </p:childTnLst>
+                                </p:cTn>
+                              </p:par>
+                              <p:par>
+                                <p:cTn id="12" presetID="10" presetClass="entr" presetSubtype="0" fill="hold" grpId="0" nodeType="afterEffect">
+                                  <p:stCondLst>
+                                    <p:cond delay="390"/>
+                                  </p:stCondLst>
+                                  <p:childTnLst>
+                                    <p:set>
+                                      <p:cBhvr>
+                                        <p:cTn id="13" dur="1" fill="hold">
+                                          <p:stCondLst>
+                                            <p:cond delay="0"/>
+                                          </p:stCondLst>
+                                        </p:cTn>
+                                        <p:tgtEl>
+                                          <p:spTgt spid="8"/>
+                                        </p:tgtEl>
+                                        <p:attrNameLst>
+                                          <p:attrName>style.visibility</p:attrName>
+                                        </p:attrNameLst>
+                                      </p:cBhvr>
+                                      <p:to>
+                                        <p:strVal val="visible"/>
+                                      </p:to>
+                                    </p:set>
+                                    <p:animEffect transition="in" filter="fade">
+                                      <p:cBhvr>
+                                        <p:cTn id="14" dur="400"/>
+                                        <p:tgtEl>
+                                          <p:spTgt spid="8"/>
+                                        </p:tgtEl>
+                                      </p:cBhvr>
+                                    </p:animEffect>
+                                  </p:childTnLst>
+                                </p:cTn>
+                              </p:par>
+                              <p:par>
+                                <p:cTn id="15" presetID="10" presetClass="entr" presetSubtype="0" fill="hold" grpId="0" nodeType="afterEffect">
+                                  <p:stCondLst>
+                                    <p:cond delay="520"/>
+                                  </p:stCondLst>
+                                  <p:childTnLst>
+                                    <p:set>
+                                      <p:cBhvr>
+                                        <p:cTn id="16" dur="1" fill="hold">
+                                          <p:stCondLst>
+                                            <p:cond delay="0"/>
+                                          </p:stCondLst>
+                                        </p:cTn>
+                                        <p:tgtEl>
+                                          <p:spTgt spid="9"/>
+                                        </p:tgtEl>
+                                        <p:attrNameLst>
+                                          <p:attrName>style.visibility</p:attrName>
+                                        </p:attrNameLst>
+                                      </p:cBhvr>
+                                      <p:to>
+                                        <p:strVal val="visible"/>
+                                      </p:to>
+                                    </p:set>
+                                    <p:animEffect transition="in" filter="fade">
+                                      <p:cBhvr>
+                                        <p:cTn id="17" dur="400"/>
+                                        <p:tgtEl>
+                                          <p:spTgt spid="9"/>
+                                        </p:tgtEl>
+                                      </p:cBhvr>
+                                    </p:animEffect>
+                                  </p:childTnLst>
+                                </p:cTn>
+                              </p:par>
+                              <p:par>
+                                <p:cTn id="18" presetID="10" presetClass="entr" presetSubtype="0" fill="hold" grpId="0" nodeType="afterEffect">
+                                  <p:stCondLst>
+                                    <p:cond delay="650"/>
+                                  </p:stCondLst>
+                                  <p:childTnLst>
+                                    <p:set>
+                                      <p:cBhvr>
+                                        <p:cTn id="19" dur="1" fill="hold">
+                                          <p:stCondLst>
+                                            <p:cond delay="0"/>
+                                          </p:stCondLst>
+                                        </p:cTn>
+                                        <p:tgtEl>
+                                          <p:spTgt spid="10"/>
+                                        </p:tgtEl>
+                                        <p:attrNameLst>
+                                          <p:attrName>style.visibility</p:attrName>
+                                        </p:attrNameLst>
+                                      </p:cBhvr>
+                                      <p:to>
+                                        <p:strVal val="visible"/>
+                                      </p:to>
+                                    </p:set>
+                                    <p:animEffect transition="in" filter="fade">
+                                      <p:cBhvr>
+                                        <p:cTn id="20" dur="400"/>
+                                        <p:tgtEl>
+                                          <p:spTgt spid="10"/>
+                                        </p:tgtEl>
+                                      </p:cBhvr>
+                                    </p:animEffect>
+                                  </p:childTnLst>
+                                </p:cTn>
+                              </p:par>
+                              <p:par>
+                                <p:cTn id="21" presetID="10" presetClass="entr" presetSubtype="0" fill="hold" grpId="0" nodeType="afterEffect">
+                                  <p:stCondLst>
+                                    <p:cond delay="780"/>
+                                  </p:stCondLst>
+                                  <p:childTnLst>
+                                    <p:set>
+                                      <p:cBhvr>
+                                        <p:cTn id="22" dur="1" fill="hold">
+                                          <p:stCondLst>
+                                            <p:cond delay="0"/>
+                                          </p:stCondLst>
+                                        </p:cTn>
+                                        <p:tgtEl>
+                                          <p:spTgt spid="11"/>
+                                        </p:tgtEl>
+                                        <p:attrNameLst>
+                                          <p:attrName>style.visibility</p:attrName>
+                                        </p:attrNameLst>
+                                      </p:cBhvr>
+                                      <p:to>
+                                        <p:strVal val="visible"/>
+                                      </p:to>
+                                    </p:set>
+                                    <p:animEffect transition="in" filter="fade">
+                                      <p:cBhvr>
+                                        <p:cTn id="23" dur="400"/>
+                                        <p:tgtEl>
+                                          <p:spTgt spid="11"/>
+                                        </p:tgtEl>
+                                      </p:cBhvr>
+                                    </p:animEffect>
+                                  </p:childTnLst>
+                                </p:cTn>
+                              </p:par>
+                              <p:par>
+                                <p:cTn id="24" presetID="10" presetClass="entr" presetSubtype="0" fill="hold" grpId="0" nodeType="afterEffect">
+                                  <p:stCondLst>
+                                    <p:cond delay="910"/>
+                                  </p:stCondLst>
+                                  <p:childTnLst>
+                                    <p:set>
+                                      <p:cBhvr>
+                                        <p:cTn id="25" dur="1" fill="hold">
+                                          <p:stCondLst>
+                                            <p:cond delay="0"/>
+                                          </p:stCondLst>
+                                        </p:cTn>
+                                        <p:tgtEl>
+                                          <p:spTgt spid="12"/>
+                                        </p:tgtEl>
+                                        <p:attrNameLst>
+                                          <p:attrName>style.visibility</p:attrName>
+                                        </p:attrNameLst>
+                                      </p:cBhvr>
+                                      <p:to>
+                                        <p:strVal val="visible"/>
+                                      </p:to>
+                                    </p:set>
+                                    <p:animEffect transition="in" filter="fade">
+                                      <p:cBhvr>
+                                        <p:cTn id="26" dur="400"/>
+                                        <p:tgtEl>
+                                          <p:spTgt spid="12"/>
+                                        </p:tgtEl>
+                                      </p:cBhvr>
+                                    </p:animEffect>
+                                  </p:childTnLst>
+                                </p:cTn>
+                              </p:par>
+                              <p:par>
+                                <p:cTn id="27" presetID="10" presetClass="entr" presetSubtype="0" fill="hold" grpId="0" nodeType="afterEffect">
+                                  <p:stCondLst>
+                                    <p:cond delay="1040"/>
+                                  </p:stCondLst>
+                                  <p:childTnLst>
+                                    <p:set>
+                                      <p:cBhvr>
+                                        <p:cTn id="28" dur="1" fill="hold">
+                                          <p:stCondLst>
+                                            <p:cond delay="0"/>
+                                          </p:stCondLst>
+                                        </p:cTn>
+                                        <p:tgtEl>
+                                          <p:spTgt spid="13"/>
+                                        </p:tgtEl>
+                                        <p:attrNameLst>
+                                          <p:attrName>style.visibility</p:attrName>
+                                        </p:attrNameLst>
+                                      </p:cBhvr>
+                                      <p:to>
+                                        <p:strVal val="visible"/>
+                                      </p:to>
+                                    </p:set>
+                                    <p:animEffect transition="in" filter="fade">
+                                      <p:cBhvr>
+                                        <p:cTn id="29" dur="400"/>
+                                        <p:tgtEl>
+                                          <p:spTgt spid="13"/>
+                                        </p:tgtEl>
+                                      </p:cBhvr>
+                                    </p:animEffect>
+                                  </p:childTnLst>
+                                </p:cTn>
+                              </p:par>
+                              <p:par>
+                                <p:cTn id="30" presetID="10" presetClass="entr" presetSubtype="0" fill="hold" grpId="0" nodeType="afterEffect">
+                                  <p:stCondLst>
+                                    <p:cond delay="1170"/>
+                                  </p:stCondLst>
+                                  <p:childTnLst>
+                                    <p:set>
+                                      <p:cBhvr>
+                                        <p:cTn id="31" dur="1" fill="hold">
+                                          <p:stCondLst>
+                                            <p:cond delay="0"/>
+                                          </p:stCondLst>
+                                        </p:cTn>
+                                        <p:tgtEl>
+                                          <p:spTgt spid="14"/>
+                                        </p:tgtEl>
+                                        <p:attrNameLst>
+                                          <p:attrName>style.visibility</p:attrName>
+                                        </p:attrNameLst>
+                                      </p:cBhvr>
+                                      <p:to>
+                                        <p:strVal val="visible"/>
+                                      </p:to>
+                                    </p:set>
+                                    <p:animEffect transition="in" filter="fade">
+                                      <p:cBhvr>
+                                        <p:cTn id="32" dur="400"/>
+                                        <p:tgtEl>
+                                          <p:spTgt spid="14"/>
+                                        </p:tgtEl>
+                                      </p:cBhvr>
+                                    </p:animEffect>
+                                  </p:childTnLst>
+                                </p:cTn>
+                              </p:par>
+                              <p:par>
+                                <p:cTn id="33" presetID="10" presetClass="entr" presetSubtype="0" fill="hold" grpId="0" nodeType="afterEffect">
+                                  <p:stCondLst>
+                                    <p:cond delay="1300"/>
+                                  </p:stCondLst>
+                                  <p:childTnLst>
+                                    <p:set>
+                                      <p:cBhvr>
+                                        <p:cTn id="34" dur="1" fill="hold">
+                                          <p:stCondLst>
+                                            <p:cond delay="0"/>
+                                          </p:stCondLst>
+                                        </p:cTn>
+                                        <p:tgtEl>
+                                          <p:spTgt spid="15"/>
+                                        </p:tgtEl>
+                                        <p:attrNameLst>
+                                          <p:attrName>style.visibility</p:attrName>
+                                        </p:attrNameLst>
+                                      </p:cBhvr>
+                                      <p:to>
+                                        <p:strVal val="visible"/>
+                                      </p:to>
+                                    </p:set>
+                                    <p:animEffect transition="in" filter="fade">
+                                      <p:cBhvr>
+                                        <p:cTn id="35" dur="400"/>
+                                        <p:tgtEl>
+                                          <p:spTgt spid="15"/>
+                                        </p:tgtEl>
+                                      </p:cBhvr>
+                                    </p:animEffect>
+                                  </p:childTnLst>
+                                </p:cTn>
+                              </p:par>
+                              <p:par>
+                                <p:cTn id="36" presetID="10" presetClass="entr" presetSubtype="0" fill="hold" grpId="0" nodeType="afterEffect">
+                                  <p:stCondLst>
+                                    <p:cond delay="1430"/>
+                                  </p:stCondLst>
+                                  <p:childTnLst>
+                                    <p:set>
+                                      <p:cBhvr>
+                                        <p:cTn id="37" dur="1" fill="hold">
+                                          <p:stCondLst>
+                                            <p:cond delay="0"/>
+                                          </p:stCondLst>
+                                        </p:cTn>
+                                        <p:tgtEl>
+                                          <p:spTgt spid="16"/>
+                                        </p:tgtEl>
+                                        <p:attrNameLst>
+                                          <p:attrName>style.visibility</p:attrName>
+                                        </p:attrNameLst>
+                                      </p:cBhvr>
+                                      <p:to>
+                                        <p:strVal val="visible"/>
+                                      </p:to>
+                                    </p:set>
+                                    <p:animEffect transition="in" filter="fade">
+                                      <p:cBhvr>
+                                        <p:cTn id="38" dur="400"/>
+                                        <p:tgtEl>
+                                          <p:spTgt spid="16"/>
+                                        </p:tgtEl>
+                                      </p:cBhvr>
+                                    </p:animEffect>
+                                  </p:childTnLst>
+                                </p:cTn>
+                              </p:par>
+                              <p:par>
+                                <p:cTn id="39" presetID="10" presetClass="entr" presetSubtype="0" fill="hold" grpId="0" nodeType="afterEffect">
+                                  <p:stCondLst>
+                                    <p:cond delay="1560"/>
+                                  </p:stCondLst>
+                                  <p:childTnLst>
+                                    <p:set>
+                                      <p:cBhvr>
+                                        <p:cTn id="40" dur="1" fill="hold">
+                                          <p:stCondLst>
+                                            <p:cond delay="0"/>
+                                          </p:stCondLst>
+                                        </p:cTn>
+                                        <p:tgtEl>
+                                          <p:spTgt spid="17"/>
+                                        </p:tgtEl>
+                                        <p:attrNameLst>
+                                          <p:attrName>style.visibility</p:attrName>
+                                        </p:attrNameLst>
+                                      </p:cBhvr>
+                                      <p:to>
+                                        <p:strVal val="visible"/>
+                                      </p:to>
+                                    </p:set>
+                                    <p:animEffect transition="in" filter="fade">
+                                      <p:cBhvr>
+                                        <p:cTn id="41" dur="400"/>
+                                        <p:tgtEl>
+                                          <p:spTgt spid="17"/>
+                                        </p:tgtEl>
+                                      </p:cBhvr>
+                                    </p:animEffect>
+                                  </p:childTnLst>
+                                </p:cTn>
+                              </p:par>
+                              <p:par>
+                                <p:cTn id="42" presetID="10" presetClass="entr" presetSubtype="0" fill="hold" grpId="0" nodeType="afterEffect">
+                                  <p:stCondLst>
+                                    <p:cond delay="1690"/>
+                                  </p:stCondLst>
+                                  <p:childTnLst>
+                                    <p:set>
+                                      <p:cBhvr>
+                                        <p:cTn id="43" dur="1" fill="hold">
+                                          <p:stCondLst>
+                                            <p:cond delay="0"/>
+                                          </p:stCondLst>
+                                        </p:cTn>
+                                        <p:tgtEl>
+                                          <p:spTgt spid="18"/>
+                                        </p:tgtEl>
+                                        <p:attrNameLst>
+                                          <p:attrName>style.visibility</p:attrName>
+                                        </p:attrNameLst>
+                                      </p:cBhvr>
+                                      <p:to>
+                                        <p:strVal val="visible"/>
+                                      </p:to>
+                                    </p:set>
+                                    <p:animEffect transition="in" filter="fade">
+                                      <p:cBhvr>
+                                        <p:cTn id="44" dur="400"/>
+                                        <p:tgtEl>
+                                          <p:spTgt spid="18"/>
+                                        </p:tgtEl>
+                                      </p:cBhvr>
+                                    </p:animEffect>
+                                  </p:childTnLst>
+                                </p:cTn>
+                              </p:par>
+                              <p:par>
+                                <p:cTn id="45" presetID="10" presetClass="entr" presetSubtype="0" fill="hold" grpId="0" nodeType="afterEffect">
+                                  <p:stCondLst>
+                                    <p:cond delay="1820"/>
+                                  </p:stCondLst>
+                                  <p:childTnLst>
+                                    <p:set>
+                                      <p:cBhvr>
+                                        <p:cTn id="46" dur="1" fill="hold">
+                                          <p:stCondLst>
+                                            <p:cond delay="0"/>
+                                          </p:stCondLst>
+                                        </p:cTn>
+                                        <p:tgtEl>
+                                          <p:spTgt spid="19"/>
+                                        </p:tgtEl>
+                                        <p:attrNameLst>
+                                          <p:attrName>style.visibility</p:attrName>
+                                        </p:attrNameLst>
+                                      </p:cBhvr>
+                                      <p:to>
+                                        <p:strVal val="visible"/>
+                                      </p:to>
+                                    </p:set>
+                                    <p:animEffect transition="in" filter="fade">
+                                      <p:cBhvr>
+                                        <p:cTn id="47" dur="400"/>
+                                        <p:tgtEl>
+                                          <p:spTgt spid="19"/>
+                                        </p:tgtEl>
+                                      </p:cBhvr>
+                                    </p:animEffect>
+                                  </p:childTnLst>
+                                </p:cTn>
+                              </p:par>
+                              <p:par>
+                                <p:cTn id="48" presetID="10" presetClass="entr" presetSubtype="0" fill="hold" grpId="0" nodeType="afterEffect">
+                                  <p:stCondLst>
+                                    <p:cond delay="1950"/>
+                                  </p:stCondLst>
+                                  <p:childTnLst>
+                                    <p:set>
+                                      <p:cBhvr>
+                                        <p:cTn id="49" dur="1" fill="hold">
+                                          <p:stCondLst>
+                                            <p:cond delay="0"/>
+                                          </p:stCondLst>
+                                        </p:cTn>
+                                        <p:tgtEl>
+                                          <p:spTgt spid="20"/>
+                                        </p:tgtEl>
+                                        <p:attrNameLst>
+                                          <p:attrName>style.visibility</p:attrName>
+                                        </p:attrNameLst>
+                                      </p:cBhvr>
+                                      <p:to>
+                                        <p:strVal val="visible"/>
+                                      </p:to>
+                                    </p:set>
+                                    <p:animEffect transition="in" filter="fade">
+                                      <p:cBhvr>
+                                        <p:cTn id="50" dur="400"/>
+                                        <p:tgtEl>
+                                          <p:spTgt spid="20"/>
+                                        </p:tgtEl>
+                                      </p:cBhvr>
+                                    </p:animEffect>
+                                  </p:childTnLst>
+                                </p:cTn>
+                              </p:par>
+                              <p:par>
+                                <p:cTn id="51" presetID="10" presetClass="entr" presetSubtype="0" fill="hold" grpId="0" nodeType="afterEffect">
+                                  <p:stCondLst>
+                                    <p:cond delay="2080"/>
+                                  </p:stCondLst>
+                                  <p:childTnLst>
+                                    <p:set>
+                                      <p:cBhvr>
+                                        <p:cTn id="52" dur="1" fill="hold">
+                                          <p:stCondLst>
+                                            <p:cond delay="0"/>
+                                          </p:stCondLst>
+                                        </p:cTn>
+                                        <p:tgtEl>
+                                          <p:spTgt spid="21"/>
+                                        </p:tgtEl>
+                                        <p:attrNameLst>
+                                          <p:attrName>style.visibility</p:attrName>
+                                        </p:attrNameLst>
+                                      </p:cBhvr>
+                                      <p:to>
+                                        <p:strVal val="visible"/>
+                                      </p:to>
+                                    </p:set>
+                                    <p:animEffect transition="in" filter="fade">
+                                      <p:cBhvr>
+                                        <p:cTn id="53" dur="400"/>
+                                        <p:tgtEl>
+                                          <p:spTgt spid="21"/>
+                                        </p:tgtEl>
+                                      </p:cBhvr>
+                                    </p:animEffect>
+                                  </p:childTnLst>
+                                </p:cTn>
+                              </p:par>
+                              <p:par>
+                                <p:cTn id="54" presetID="10" presetClass="entr" presetSubtype="0" fill="hold" grpId="0" nodeType="afterEffect">
+                                  <p:stCondLst>
+                                    <p:cond delay="2210"/>
+                                  </p:stCondLst>
+                                  <p:childTnLst>
+                                    <p:set>
+                                      <p:cBhvr>
+                                        <p:cTn id="55" dur="1" fill="hold">
+                                          <p:stCondLst>
+                                            <p:cond delay="0"/>
+                                          </p:stCondLst>
+                                        </p:cTn>
+                                        <p:tgtEl>
+                                          <p:spTgt spid="22"/>
+                                        </p:tgtEl>
+                                        <p:attrNameLst>
+                                          <p:attrName>style.visibility</p:attrName>
+                                        </p:attrNameLst>
+                                      </p:cBhvr>
+                                      <p:to>
+                                        <p:strVal val="visible"/>
+                                      </p:to>
+                                    </p:set>
+                                    <p:animEffect transition="in" filter="fade">
+                                      <p:cBhvr>
+                                        <p:cTn id="56" dur="400"/>
+                                        <p:tgtEl>
+                                          <p:spTgt spid="22"/>
+                                        </p:tgtEl>
+                                      </p:cBhvr>
+                                    </p:animEffect>
+                                  </p:childTnLst>
+                                </p:cTn>
+                              </p:par>
+                              <p:par>
+                                <p:cTn id="57" presetID="10" presetClass="entr" presetSubtype="0" fill="hold" grpId="0" nodeType="afterEffect">
+                                  <p:stCondLst>
+                                    <p:cond delay="2340"/>
+                                  </p:stCondLst>
+                                  <p:childTnLst>
+                                    <p:set>
+                                      <p:cBhvr>
+                                        <p:cTn id="58" dur="1" fill="hold">
+                                          <p:stCondLst>
+                                            <p:cond delay="0"/>
+                                          </p:stCondLst>
+                                        </p:cTn>
+                                        <p:tgtEl>
+                                          <p:spTgt spid="23"/>
+                                        </p:tgtEl>
+                                        <p:attrNameLst>
+                                          <p:attrName>style.visibility</p:attrName>
+                                        </p:attrNameLst>
+                                      </p:cBhvr>
+                                      <p:to>
+                                        <p:strVal val="visible"/>
+                                      </p:to>
+                                    </p:set>
+                                    <p:animEffect transition="in" filter="fade">
+                                      <p:cBhvr>
+                                        <p:cTn id="59" dur="400"/>
+                                        <p:tgtEl>
+                                          <p:spTgt spid="23"/>
+                                        </p:tgtEl>
+                                      </p:cBhvr>
+                                    </p:animEffect>
+                                  </p:childTnLst>
+                                </p:cTn>
+                              </p:par>
+                              <p:par>
+                                <p:cTn id="60" presetID="10" presetClass="entr" presetSubtype="0" fill="hold" grpId="0" nodeType="afterEffect">
+                                  <p:stCondLst>
+                                    <p:cond delay="2470"/>
+                                  </p:stCondLst>
+                                  <p:childTnLst>
+                                    <p:set>
+                                      <p:cBhvr>
+                                        <p:cTn id="61" dur="1" fill="hold">
+                                          <p:stCondLst>
+                                            <p:cond delay="0"/>
+                                          </p:stCondLst>
+                                        </p:cTn>
+                                        <p:tgtEl>
+                                          <p:spTgt spid="24"/>
+                                        </p:tgtEl>
+                                        <p:attrNameLst>
+                                          <p:attrName>style.visibility</p:attrName>
+                                        </p:attrNameLst>
+                                      </p:cBhvr>
+                                      <p:to>
+                                        <p:strVal val="visible"/>
+                                      </p:to>
+                                    </p:set>
+                                    <p:animEffect transition="in" filter="fade">
+                                      <p:cBhvr>
+                                        <p:cTn id="62" dur="400"/>
+                                        <p:tgtEl>
+                                          <p:spTgt spid="24"/>
+                                        </p:tgtEl>
+                                      </p:cBhvr>
+                                    </p:animEffect>
+                                  </p:childTnLst>
+                                </p:cTn>
+                              </p:par>
+                              <p:par>
+                                <p:cTn id="63" presetID="10" presetClass="entr" presetSubtype="0" fill="hold" grpId="0" nodeType="afterEffect">
+                                  <p:stCondLst>
+                                    <p:cond delay="2600"/>
+                                  </p:stCondLst>
+                                  <p:childTnLst>
+                                    <p:set>
+                                      <p:cBhvr>
+                                        <p:cTn id="64" dur="1" fill="hold">
+                                          <p:stCondLst>
+                                            <p:cond delay="0"/>
+                                          </p:stCondLst>
+                                        </p:cTn>
+                                        <p:tgtEl>
+                                          <p:spTgt spid="25"/>
+                                        </p:tgtEl>
+                                        <p:attrNameLst>
+                                          <p:attrName>style.visibility</p:attrName>
+                                        </p:attrNameLst>
+                                      </p:cBhvr>
+                                      <p:to>
+                                        <p:strVal val="visible"/>
+                                      </p:to>
+                                    </p:set>
+                                    <p:animEffect transition="in" filter="fade">
+                                      <p:cBhvr>
+                                        <p:cTn id="65" dur="400"/>
+                                        <p:tgtEl>
+                                          <p:spTgt spid="25"/>
+                                        </p:tgtEl>
+                                      </p:cBhvr>
+                                    </p:animEffect>
+                                  </p:childTnLst>
+                                </p:cTn>
+                              </p:par>
+                              <p:par>
+                                <p:cTn id="66" presetID="10" presetClass="entr" presetSubtype="0" fill="hold" grpId="0" nodeType="afterEffect">
+                                  <p:stCondLst>
+                                    <p:cond delay="2730"/>
+                                  </p:stCondLst>
+                                  <p:childTnLst>
+                                    <p:set>
+                                      <p:cBhvr>
+                                        <p:cTn id="67" dur="1" fill="hold">
+                                          <p:stCondLst>
+                                            <p:cond delay="0"/>
+                                          </p:stCondLst>
+                                        </p:cTn>
+                                        <p:tgtEl>
+                                          <p:spTgt spid="26"/>
+                                        </p:tgtEl>
+                                        <p:attrNameLst>
+                                          <p:attrName>style.visibility</p:attrName>
+                                        </p:attrNameLst>
+                                      </p:cBhvr>
+                                      <p:to>
+                                        <p:strVal val="visible"/>
+                                      </p:to>
+                                    </p:set>
+                                    <p:animEffect transition="in" filter="fade">
+                                      <p:cBhvr>
+                                        <p:cTn id="68" dur="400"/>
+                                        <p:tgtEl>
+                                          <p:spTgt spid="26"/>
+                                        </p:tgtEl>
+                                      </p:cBhvr>
+                                    </p:animEffect>
+                                  </p:childTnLst>
+                                </p:cTn>
+                              </p:par>
+                              <p:par>
+                                <p:cTn id="69" presetID="10" presetClass="entr" presetSubtype="0" fill="hold" grpId="0" nodeType="afterEffect">
+                                  <p:stCondLst>
+                                    <p:cond delay="2860"/>
+                                  </p:stCondLst>
+                                  <p:childTnLst>
+                                    <p:set>
+                                      <p:cBhvr>
+                                        <p:cTn id="70" dur="1" fill="hold">
+                                          <p:stCondLst>
+                                            <p:cond delay="0"/>
+                                          </p:stCondLst>
+                                        </p:cTn>
+                                        <p:tgtEl>
+                                          <p:spTgt spid="27"/>
+                                        </p:tgtEl>
+                                        <p:attrNameLst>
+                                          <p:attrName>style.visibility</p:attrName>
+                                        </p:attrNameLst>
+                                      </p:cBhvr>
+                                      <p:to>
+                                        <p:strVal val="visible"/>
+                                      </p:to>
+                                    </p:set>
+                                    <p:animEffect transition="in" filter="fade">
+                                      <p:cBhvr>
+                                        <p:cTn id="71" dur="400"/>
+                                        <p:tgtEl>
+                                          <p:spTgt spid="27"/>
+                                        </p:tgtEl>
+                                      </p:cBhvr>
+                                    </p:animEffect>
+                                  </p:childTnLst>
+                                </p:cTn>
+                              </p:par>
+                            </p:childTnLst>
+                          </p:cTn>
+                        </p:par>
+                      </p:childTnLst>
+                    </p:cTn>
+                  </p:par>
+                </p:childTnLst>
+              </p:cTn>
+              <p:prevCondLst>
+                <p:cond evt="onPrev" delay="0">
+                  <p:tgtEl>
+                    <p:sldTgt/>
+                  </p:tgtEl>
+                </p:cond>
+              </p:prevCondLst>
+              <p:nextCondLst>
+                <p:cond evt="onNext" delay="0">
+                  <p:tgtEl>
+                    <p:sldTgt/>
+                  </p:tgtEl>
+                </p:cond>
+              </p:nextCondLst>
+            </p:seq>
+          </p:childTnLst>
+        </p:cTn>
+      </p:par>
+    </p:tnLst>
+    <p:bldLst>
+      <p:bldP spid="5" grpId="0"/>
+      <p:bldP spid="6" grpId="0"/>
+      <p:bldP spid="7" grpId="0"/>
+      <p:bldP spid="8" grpId="0"/>
+      <p:bldP spid="9" grpId="0"/>
+      <p:bldP spid="10" grpId="0"/>
+      <p:bldP spid="11" grpId="0"/>
+      <p:bldP spid="12" grpId="0"/>
+      <p:bldP spid="13" grpId="0"/>
+      <p:bldP spid="14" grpId="0"/>
+      <p:bldP spid="15" grpId="0"/>
+      <p:bldP spid="16" grpId="0"/>
+      <p:bldP spid="17" grpId="0"/>
+      <p:bldP spid="18" grpId="0"/>
+      <p:bldP spid="19" grpId="0"/>
+      <p:bldP spid="20" grpId="0"/>
+      <p:bldP spid="21" grpId="0"/>
+      <p:bldP spid="22" grpId="0"/>
+      <p:bldP spid="23" grpId="0"/>
+      <p:bldP spid="24" grpId="0"/>
+      <p:bldP spid="25" grpId="0"/>
+      <p:bldP spid="26" grpId="0"/>
+      <p:bldP spid="27" grpId="0"/>
     </p:bldLst>
   </p:timing>
 </p:sld>
@@ -17446,1903 +18819,6 @@
       </p:sp>
       <p:sp>
         <p:nvSpPr>
-          <p:cNvPr id="4" name="chrome-reserve"/>
-          <p:cNvSpPr/>
-          <p:nvPr/>
-        </p:nvSpPr>
-        <p:spPr>
-          <a:xfrm>
-            <a:off x="8778240" y="384048"/>
-            <a:ext cx="2926080" cy="274320"/>
-          </a:xfrm>
-          <a:prstGeom prst="rect">
-            <a:avLst/>
-          </a:prstGeom>
-          <a:noFill/>
-          <a:ln/>
-        </p:spPr>
-        <p:txBody>
-          <a:bodyPr wrap="square" lIns="0" tIns="0" rIns="0" bIns="0" rtlCol="0" anchor="ctr"/>
-          <a:lstStyle/>
-          <a:p>
-            <a:pPr algn="r" indent="0" marL="0">
-              <a:buNone/>
-            </a:pPr>
-            <a:r>
-              <a:rPr lang="en-US" sz="900" b="1" spc="200" kern="0" dirty="0">
-                <a:solidFill>
-                  <a:srgbClr val="5C6E82"/>
-                </a:solidFill>
-                <a:latin typeface="Arial" pitchFamily="34" charset="0"/>
-                <a:ea typeface="Arial" pitchFamily="34" charset="-122"/>
-                <a:cs typeface="Arial" pitchFamily="34" charset="-120"/>
-              </a:rPr>
-              <a:t>RESERVE · NUR BEI NACHFRAGE</a:t>
-            </a:r>
-            <a:endParaRPr lang="en-US" sz="900" dirty="0"/>
-          </a:p>
-        </p:txBody>
-      </p:sp>
-      <p:sp>
-        <p:nvSpPr>
-          <p:cNvPr id="5" name="Text 3"/>
-          <p:cNvSpPr/>
-          <p:nvPr/>
-        </p:nvSpPr>
-        <p:spPr>
-          <a:xfrm>
-            <a:off x="502920" y="411480"/>
-            <a:ext cx="8229600" cy="274320"/>
-          </a:xfrm>
-          <a:prstGeom prst="rect">
-            <a:avLst/>
-          </a:prstGeom>
-          <a:noFill/>
-          <a:ln/>
-        </p:spPr>
-        <p:txBody>
-          <a:bodyPr wrap="square" lIns="0" tIns="0" rIns="0" bIns="0" rtlCol="0" anchor="ctr"/>
-          <a:lstStyle/>
-          <a:p>
-            <a:pPr indent="0" marL="0">
-              <a:buNone/>
-            </a:pPr>
-            <a:r>
-              <a:rPr lang="en-US" sz="1050" b="1" spc="300" kern="0" dirty="0">
-                <a:solidFill>
-                  <a:srgbClr val="6699FF"/>
-                </a:solidFill>
-                <a:latin typeface="Arial" pitchFamily="34" charset="0"/>
-                <a:ea typeface="Arial" pitchFamily="34" charset="-122"/>
-                <a:cs typeface="Arial" pitchFamily="34" charset="-120"/>
-              </a:rPr>
-              <a:t>10 · SELBER MACHEN</a:t>
-            </a:r>
-            <a:endParaRPr lang="en-US" sz="1050" dirty="0"/>
-          </a:p>
-        </p:txBody>
-      </p:sp>
-      <p:sp>
-        <p:nvSpPr>
-          <p:cNvPr id="6" name="Text 4"/>
-          <p:cNvSpPr/>
-          <p:nvPr/>
-        </p:nvSpPr>
-        <p:spPr>
-          <a:xfrm>
-            <a:off x="502920" y="777240"/>
-            <a:ext cx="11155680" cy="685800"/>
-          </a:xfrm>
-          <a:prstGeom prst="rect">
-            <a:avLst/>
-          </a:prstGeom>
-          <a:noFill/>
-          <a:ln/>
-        </p:spPr>
-        <p:txBody>
-          <a:bodyPr wrap="square" lIns="0" tIns="0" rIns="0" bIns="0" rtlCol="0" anchor="ctr"/>
-          <a:lstStyle/>
-          <a:p>
-            <a:pPr indent="0" marL="0">
-              <a:buNone/>
-            </a:pPr>
-            <a:r>
-              <a:rPr lang="en-US" sz="3000" b="1" dirty="0">
-                <a:solidFill>
-                  <a:srgbClr val="EDF2F7"/>
-                </a:solidFill>
-                <a:latin typeface="Arial" pitchFamily="34" charset="0"/>
-                <a:ea typeface="Arial" pitchFamily="34" charset="-122"/>
-                <a:cs typeface="Arial" pitchFamily="34" charset="-120"/>
-              </a:rPr>
-              <a:t>In fünf Schritten zum eigenen Shop</a:t>
-            </a:r>
-            <a:endParaRPr lang="en-US" sz="3000" dirty="0"/>
-          </a:p>
-        </p:txBody>
-      </p:sp>
-      <p:sp>
-        <p:nvSpPr>
-          <p:cNvPr id="7" name="Shape 5"/>
-          <p:cNvSpPr/>
-          <p:nvPr/>
-        </p:nvSpPr>
-        <p:spPr>
-          <a:xfrm>
-            <a:off x="502920" y="2103120"/>
-            <a:ext cx="2104949" cy="1828800"/>
-          </a:xfrm>
-          <a:prstGeom prst="roundRect">
-            <a:avLst>
-              <a:gd name="adj" fmla="val 2500"/>
-            </a:avLst>
-          </a:prstGeom>
-          <a:solidFill>
-            <a:srgbClr val="141B24"/>
-          </a:solidFill>
-          <a:ln w="9525">
-            <a:solidFill>
-              <a:srgbClr val="243040"/>
-            </a:solidFill>
-            <a:prstDash val="solid"/>
-          </a:ln>
-        </p:spPr>
-      </p:sp>
-      <p:sp>
-        <p:nvSpPr>
-          <p:cNvPr id="8" name="Text 6"/>
-          <p:cNvSpPr/>
-          <p:nvPr/>
-        </p:nvSpPr>
-        <p:spPr>
-          <a:xfrm>
-            <a:off x="704088" y="2267712"/>
-            <a:ext cx="548640" cy="274320"/>
-          </a:xfrm>
-          <a:prstGeom prst="rect">
-            <a:avLst/>
-          </a:prstGeom>
-          <a:noFill/>
-          <a:ln/>
-        </p:spPr>
-        <p:txBody>
-          <a:bodyPr wrap="square" lIns="0" tIns="0" rIns="0" bIns="0" rtlCol="0" anchor="ctr"/>
-          <a:lstStyle/>
-          <a:p>
-            <a:pPr indent="0" marL="0">
-              <a:buNone/>
-            </a:pPr>
-            <a:r>
-              <a:rPr lang="en-US" sz="1100" b="1" dirty="0">
-                <a:solidFill>
-                  <a:srgbClr val="6699FF"/>
-                </a:solidFill>
-                <a:latin typeface="Arial" pitchFamily="34" charset="0"/>
-                <a:ea typeface="Arial" pitchFamily="34" charset="-122"/>
-                <a:cs typeface="Arial" pitchFamily="34" charset="-120"/>
-              </a:rPr>
-              <a:t>1</a:t>
-            </a:r>
-            <a:endParaRPr lang="en-US" sz="1100" dirty="0"/>
-          </a:p>
-        </p:txBody>
-      </p:sp>
-      <p:sp>
-        <p:nvSpPr>
-          <p:cNvPr id="9" name="Text 7"/>
-          <p:cNvSpPr/>
-          <p:nvPr/>
-        </p:nvSpPr>
-        <p:spPr>
-          <a:xfrm>
-            <a:off x="704088" y="2560320"/>
-            <a:ext cx="1702613" cy="365760"/>
-          </a:xfrm>
-          <a:prstGeom prst="rect">
-            <a:avLst/>
-          </a:prstGeom>
-          <a:noFill/>
-          <a:ln/>
-        </p:spPr>
-        <p:txBody>
-          <a:bodyPr wrap="square" lIns="0" tIns="0" rIns="0" bIns="0" rtlCol="0" anchor="ctr"/>
-          <a:lstStyle/>
-          <a:p>
-            <a:pPr indent="0" marL="0">
-              <a:buNone/>
-            </a:pPr>
-            <a:r>
-              <a:rPr lang="en-US" sz="1350" b="1" dirty="0">
-                <a:solidFill>
-                  <a:srgbClr val="EDF2F7"/>
-                </a:solidFill>
-                <a:latin typeface="Arial" pitchFamily="34" charset="0"/>
-                <a:ea typeface="Arial" pitchFamily="34" charset="-122"/>
-                <a:cs typeface="Arial" pitchFamily="34" charset="-120"/>
-              </a:rPr>
-              <a:t>Konto</a:t>
-            </a:r>
-            <a:endParaRPr lang="en-US" sz="1350" dirty="0"/>
-          </a:p>
-        </p:txBody>
-      </p:sp>
-      <p:sp>
-        <p:nvSpPr>
-          <p:cNvPr id="10" name="Text 8"/>
-          <p:cNvSpPr/>
-          <p:nvPr/>
-        </p:nvSpPr>
-        <p:spPr>
-          <a:xfrm>
-            <a:off x="704088" y="2944368"/>
-            <a:ext cx="1702613" cy="822960"/>
-          </a:xfrm>
-          <a:prstGeom prst="rect">
-            <a:avLst/>
-          </a:prstGeom>
-          <a:noFill/>
-          <a:ln/>
-        </p:spPr>
-        <p:txBody>
-          <a:bodyPr wrap="square" lIns="0" tIns="0" rIns="0" bIns="0" rtlCol="0" anchor="ctr"/>
-          <a:lstStyle/>
-          <a:p>
-            <a:pPr indent="0" marL="0">
-              <a:lnSpc>
-                <a:spcPct val="115000"/>
-              </a:lnSpc>
-              <a:buNone/>
-            </a:pPr>
-            <a:r>
-              <a:rPr lang="en-US" sz="1000" dirty="0">
-                <a:solidFill>
-                  <a:srgbClr val="8FA0B4"/>
-                </a:solidFill>
-                <a:latin typeface="Arial" pitchFamily="34" charset="0"/>
-                <a:ea typeface="Arial" pitchFamily="34" charset="-122"/>
-                <a:cs typeface="Arial" pitchFamily="34" charset="-120"/>
-              </a:rPr>
-              <a:t>shopify.com — 3 Tage gratis, dann CHF 1/Monat</a:t>
-            </a:r>
-            <a:endParaRPr lang="en-US" sz="1000" dirty="0"/>
-          </a:p>
-        </p:txBody>
-      </p:sp>
-      <p:sp>
-        <p:nvSpPr>
-          <p:cNvPr id="11" name="Shape 9"/>
-          <p:cNvSpPr/>
-          <p:nvPr/>
-        </p:nvSpPr>
-        <p:spPr>
-          <a:xfrm>
-            <a:off x="2772461" y="2103120"/>
-            <a:ext cx="2104949" cy="1828800"/>
-          </a:xfrm>
-          <a:prstGeom prst="roundRect">
-            <a:avLst>
-              <a:gd name="adj" fmla="val 2500"/>
-            </a:avLst>
-          </a:prstGeom>
-          <a:solidFill>
-            <a:srgbClr val="141B24"/>
-          </a:solidFill>
-          <a:ln w="9525">
-            <a:solidFill>
-              <a:srgbClr val="243040"/>
-            </a:solidFill>
-            <a:prstDash val="solid"/>
-          </a:ln>
-        </p:spPr>
-      </p:sp>
-      <p:sp>
-        <p:nvSpPr>
-          <p:cNvPr id="12" name="Text 10"/>
-          <p:cNvSpPr/>
-          <p:nvPr/>
-        </p:nvSpPr>
-        <p:spPr>
-          <a:xfrm>
-            <a:off x="2973629" y="2267712"/>
-            <a:ext cx="548640" cy="274320"/>
-          </a:xfrm>
-          <a:prstGeom prst="rect">
-            <a:avLst/>
-          </a:prstGeom>
-          <a:noFill/>
-          <a:ln/>
-        </p:spPr>
-        <p:txBody>
-          <a:bodyPr wrap="square" lIns="0" tIns="0" rIns="0" bIns="0" rtlCol="0" anchor="ctr"/>
-          <a:lstStyle/>
-          <a:p>
-            <a:pPr indent="0" marL="0">
-              <a:buNone/>
-            </a:pPr>
-            <a:r>
-              <a:rPr lang="en-US" sz="1100" b="1" dirty="0">
-                <a:solidFill>
-                  <a:srgbClr val="6699FF"/>
-                </a:solidFill>
-                <a:latin typeface="Arial" pitchFamily="34" charset="0"/>
-                <a:ea typeface="Arial" pitchFamily="34" charset="-122"/>
-                <a:cs typeface="Arial" pitchFamily="34" charset="-120"/>
-              </a:rPr>
-              <a:t>2</a:t>
-            </a:r>
-            <a:endParaRPr lang="en-US" sz="1100" dirty="0"/>
-          </a:p>
-        </p:txBody>
-      </p:sp>
-      <p:sp>
-        <p:nvSpPr>
-          <p:cNvPr id="13" name="Text 11"/>
-          <p:cNvSpPr/>
-          <p:nvPr/>
-        </p:nvSpPr>
-        <p:spPr>
-          <a:xfrm>
-            <a:off x="2973629" y="2560320"/>
-            <a:ext cx="1702613" cy="365760"/>
-          </a:xfrm>
-          <a:prstGeom prst="rect">
-            <a:avLst/>
-          </a:prstGeom>
-          <a:noFill/>
-          <a:ln/>
-        </p:spPr>
-        <p:txBody>
-          <a:bodyPr wrap="square" lIns="0" tIns="0" rIns="0" bIns="0" rtlCol="0" anchor="ctr"/>
-          <a:lstStyle/>
-          <a:p>
-            <a:pPr indent="0" marL="0">
-              <a:buNone/>
-            </a:pPr>
-            <a:r>
-              <a:rPr lang="en-US" sz="1350" b="1" dirty="0">
-                <a:solidFill>
-                  <a:srgbClr val="EDF2F7"/>
-                </a:solidFill>
-                <a:latin typeface="Arial" pitchFamily="34" charset="0"/>
-                <a:ea typeface="Arial" pitchFamily="34" charset="-122"/>
-                <a:cs typeface="Arial" pitchFamily="34" charset="-120"/>
-              </a:rPr>
-              <a:t>Produkte</a:t>
-            </a:r>
-            <a:endParaRPr lang="en-US" sz="1350" dirty="0"/>
-          </a:p>
-        </p:txBody>
-      </p:sp>
-      <p:sp>
-        <p:nvSpPr>
-          <p:cNvPr id="14" name="Text 12"/>
-          <p:cNvSpPr/>
-          <p:nvPr/>
-        </p:nvSpPr>
-        <p:spPr>
-          <a:xfrm>
-            <a:off x="2973629" y="2944368"/>
-            <a:ext cx="1702613" cy="822960"/>
-          </a:xfrm>
-          <a:prstGeom prst="rect">
-            <a:avLst/>
-          </a:prstGeom>
-          <a:noFill/>
-          <a:ln/>
-        </p:spPr>
-        <p:txBody>
-          <a:bodyPr wrap="square" lIns="0" tIns="0" rIns="0" bIns="0" rtlCol="0" anchor="ctr"/>
-          <a:lstStyle/>
-          <a:p>
-            <a:pPr indent="0" marL="0">
-              <a:lnSpc>
-                <a:spcPct val="115000"/>
-              </a:lnSpc>
-              <a:buNone/>
-            </a:pPr>
-            <a:r>
-              <a:rPr lang="en-US" sz="1000" dirty="0">
-                <a:solidFill>
-                  <a:srgbClr val="8FA0B4"/>
-                </a:solidFill>
-                <a:latin typeface="Arial" pitchFamily="34" charset="0"/>
-                <a:ea typeface="Arial" pitchFamily="34" charset="-122"/>
-                <a:cs typeface="Arial" pitchFamily="34" charset="-120"/>
-              </a:rPr>
-              <a:t>6 Artikel anlegen: Foto, Text, Preis</a:t>
-            </a:r>
-            <a:endParaRPr lang="en-US" sz="1000" dirty="0"/>
-          </a:p>
-        </p:txBody>
-      </p:sp>
-      <p:sp>
-        <p:nvSpPr>
-          <p:cNvPr id="15" name="Shape 13"/>
-          <p:cNvSpPr/>
-          <p:nvPr/>
-        </p:nvSpPr>
-        <p:spPr>
-          <a:xfrm>
-            <a:off x="5042002" y="2103120"/>
-            <a:ext cx="2104949" cy="1828800"/>
-          </a:xfrm>
-          <a:prstGeom prst="roundRect">
-            <a:avLst>
-              <a:gd name="adj" fmla="val 2500"/>
-            </a:avLst>
-          </a:prstGeom>
-          <a:solidFill>
-            <a:srgbClr val="141B24"/>
-          </a:solidFill>
-          <a:ln w="9525">
-            <a:solidFill>
-              <a:srgbClr val="243040"/>
-            </a:solidFill>
-            <a:prstDash val="solid"/>
-          </a:ln>
-        </p:spPr>
-      </p:sp>
-      <p:sp>
-        <p:nvSpPr>
-          <p:cNvPr id="16" name="Text 14"/>
-          <p:cNvSpPr/>
-          <p:nvPr/>
-        </p:nvSpPr>
-        <p:spPr>
-          <a:xfrm>
-            <a:off x="5243170" y="2267712"/>
-            <a:ext cx="548640" cy="274320"/>
-          </a:xfrm>
-          <a:prstGeom prst="rect">
-            <a:avLst/>
-          </a:prstGeom>
-          <a:noFill/>
-          <a:ln/>
-        </p:spPr>
-        <p:txBody>
-          <a:bodyPr wrap="square" lIns="0" tIns="0" rIns="0" bIns="0" rtlCol="0" anchor="ctr"/>
-          <a:lstStyle/>
-          <a:p>
-            <a:pPr indent="0" marL="0">
-              <a:buNone/>
-            </a:pPr>
-            <a:r>
-              <a:rPr lang="en-US" sz="1100" b="1" dirty="0">
-                <a:solidFill>
-                  <a:srgbClr val="6699FF"/>
-                </a:solidFill>
-                <a:latin typeface="Arial" pitchFamily="34" charset="0"/>
-                <a:ea typeface="Arial" pitchFamily="34" charset="-122"/>
-                <a:cs typeface="Arial" pitchFamily="34" charset="-120"/>
-              </a:rPr>
-              <a:t>3</a:t>
-            </a:r>
-            <a:endParaRPr lang="en-US" sz="1100" dirty="0"/>
-          </a:p>
-        </p:txBody>
-      </p:sp>
-      <p:sp>
-        <p:nvSpPr>
-          <p:cNvPr id="17" name="Text 15"/>
-          <p:cNvSpPr/>
-          <p:nvPr/>
-        </p:nvSpPr>
-        <p:spPr>
-          <a:xfrm>
-            <a:off x="5243170" y="2560320"/>
-            <a:ext cx="1702613" cy="365760"/>
-          </a:xfrm>
-          <a:prstGeom prst="rect">
-            <a:avLst/>
-          </a:prstGeom>
-          <a:noFill/>
-          <a:ln/>
-        </p:spPr>
-        <p:txBody>
-          <a:bodyPr wrap="square" lIns="0" tIns="0" rIns="0" bIns="0" rtlCol="0" anchor="ctr"/>
-          <a:lstStyle/>
-          <a:p>
-            <a:pPr indent="0" marL="0">
-              <a:buNone/>
-            </a:pPr>
-            <a:r>
-              <a:rPr lang="en-US" sz="1350" b="1" dirty="0">
-                <a:solidFill>
-                  <a:srgbClr val="EDF2F7"/>
-                </a:solidFill>
-                <a:latin typeface="Arial" pitchFamily="34" charset="0"/>
-                <a:ea typeface="Arial" pitchFamily="34" charset="-122"/>
-                <a:cs typeface="Arial" pitchFamily="34" charset="-120"/>
-              </a:rPr>
-              <a:t>Zahlung</a:t>
-            </a:r>
-            <a:endParaRPr lang="en-US" sz="1350" dirty="0"/>
-          </a:p>
-        </p:txBody>
-      </p:sp>
-      <p:sp>
-        <p:nvSpPr>
-          <p:cNvPr id="18" name="Text 16"/>
-          <p:cNvSpPr/>
-          <p:nvPr/>
-        </p:nvSpPr>
-        <p:spPr>
-          <a:xfrm>
-            <a:off x="5243170" y="2944368"/>
-            <a:ext cx="1702613" cy="822960"/>
-          </a:xfrm>
-          <a:prstGeom prst="rect">
-            <a:avLst/>
-          </a:prstGeom>
-          <a:noFill/>
-          <a:ln/>
-        </p:spPr>
-        <p:txBody>
-          <a:bodyPr wrap="square" lIns="0" tIns="0" rIns="0" bIns="0" rtlCol="0" anchor="ctr"/>
-          <a:lstStyle/>
-          <a:p>
-            <a:pPr indent="0" marL="0">
-              <a:lnSpc>
-                <a:spcPct val="115000"/>
-              </a:lnSpc>
-              <a:buNone/>
-            </a:pPr>
-            <a:r>
-              <a:rPr lang="en-US" sz="1000" dirty="0">
-                <a:solidFill>
-                  <a:srgbClr val="8FA0B4"/>
-                </a:solidFill>
-                <a:latin typeface="Arial" pitchFamily="34" charset="0"/>
-                <a:ea typeface="Arial" pitchFamily="34" charset="-122"/>
-                <a:cs typeface="Arial" pitchFamily="34" charset="-120"/>
-              </a:rPr>
-              <a:t>TWINT und Karte einschalten</a:t>
-            </a:r>
-            <a:endParaRPr lang="en-US" sz="1000" dirty="0"/>
-          </a:p>
-        </p:txBody>
-      </p:sp>
-      <p:sp>
-        <p:nvSpPr>
-          <p:cNvPr id="19" name="Shape 17"/>
-          <p:cNvSpPr/>
-          <p:nvPr/>
-        </p:nvSpPr>
-        <p:spPr>
-          <a:xfrm>
-            <a:off x="7311542" y="2103120"/>
-            <a:ext cx="2104949" cy="1828800"/>
-          </a:xfrm>
-          <a:prstGeom prst="roundRect">
-            <a:avLst>
-              <a:gd name="adj" fmla="val 2500"/>
-            </a:avLst>
-          </a:prstGeom>
-          <a:solidFill>
-            <a:srgbClr val="141B24"/>
-          </a:solidFill>
-          <a:ln w="9525">
-            <a:solidFill>
-              <a:srgbClr val="243040"/>
-            </a:solidFill>
-            <a:prstDash val="solid"/>
-          </a:ln>
-        </p:spPr>
-      </p:sp>
-      <p:sp>
-        <p:nvSpPr>
-          <p:cNvPr id="20" name="Text 18"/>
-          <p:cNvSpPr/>
-          <p:nvPr/>
-        </p:nvSpPr>
-        <p:spPr>
-          <a:xfrm>
-            <a:off x="7512710" y="2267712"/>
-            <a:ext cx="548640" cy="274320"/>
-          </a:xfrm>
-          <a:prstGeom prst="rect">
-            <a:avLst/>
-          </a:prstGeom>
-          <a:noFill/>
-          <a:ln/>
-        </p:spPr>
-        <p:txBody>
-          <a:bodyPr wrap="square" lIns="0" tIns="0" rIns="0" bIns="0" rtlCol="0" anchor="ctr"/>
-          <a:lstStyle/>
-          <a:p>
-            <a:pPr indent="0" marL="0">
-              <a:buNone/>
-            </a:pPr>
-            <a:r>
-              <a:rPr lang="en-US" sz="1100" b="1" dirty="0">
-                <a:solidFill>
-                  <a:srgbClr val="6699FF"/>
-                </a:solidFill>
-                <a:latin typeface="Arial" pitchFamily="34" charset="0"/>
-                <a:ea typeface="Arial" pitchFamily="34" charset="-122"/>
-                <a:cs typeface="Arial" pitchFamily="34" charset="-120"/>
-              </a:rPr>
-              <a:t>4</a:t>
-            </a:r>
-            <a:endParaRPr lang="en-US" sz="1100" dirty="0"/>
-          </a:p>
-        </p:txBody>
-      </p:sp>
-      <p:sp>
-        <p:nvSpPr>
-          <p:cNvPr id="21" name="Text 19"/>
-          <p:cNvSpPr/>
-          <p:nvPr/>
-        </p:nvSpPr>
-        <p:spPr>
-          <a:xfrm>
-            <a:off x="7512710" y="2560320"/>
-            <a:ext cx="1702613" cy="365760"/>
-          </a:xfrm>
-          <a:prstGeom prst="rect">
-            <a:avLst/>
-          </a:prstGeom>
-          <a:noFill/>
-          <a:ln/>
-        </p:spPr>
-        <p:txBody>
-          <a:bodyPr wrap="square" lIns="0" tIns="0" rIns="0" bIns="0" rtlCol="0" anchor="ctr"/>
-          <a:lstStyle/>
-          <a:p>
-            <a:pPr indent="0" marL="0">
-              <a:buNone/>
-            </a:pPr>
-            <a:r>
-              <a:rPr lang="en-US" sz="1350" b="1" dirty="0">
-                <a:solidFill>
-                  <a:srgbClr val="EDF2F7"/>
-                </a:solidFill>
-                <a:latin typeface="Arial" pitchFamily="34" charset="0"/>
-                <a:ea typeface="Arial" pitchFamily="34" charset="-122"/>
-                <a:cs typeface="Arial" pitchFamily="34" charset="-120"/>
-              </a:rPr>
-              <a:t>Versand</a:t>
-            </a:r>
-            <a:endParaRPr lang="en-US" sz="1350" dirty="0"/>
-          </a:p>
-        </p:txBody>
-      </p:sp>
-      <p:sp>
-        <p:nvSpPr>
-          <p:cNvPr id="22" name="Text 20"/>
-          <p:cNvSpPr/>
-          <p:nvPr/>
-        </p:nvSpPr>
-        <p:spPr>
-          <a:xfrm>
-            <a:off x="7512710" y="2944368"/>
-            <a:ext cx="1702613" cy="822960"/>
-          </a:xfrm>
-          <a:prstGeom prst="rect">
-            <a:avLst/>
-          </a:prstGeom>
-          <a:noFill/>
-          <a:ln/>
-        </p:spPr>
-        <p:txBody>
-          <a:bodyPr wrap="square" lIns="0" tIns="0" rIns="0" bIns="0" rtlCol="0" anchor="ctr"/>
-          <a:lstStyle/>
-          <a:p>
-            <a:pPr indent="0" marL="0">
-              <a:lnSpc>
-                <a:spcPct val="115000"/>
-              </a:lnSpc>
-              <a:buNone/>
-            </a:pPr>
-            <a:r>
-              <a:rPr lang="en-US" sz="1000" dirty="0">
-                <a:solidFill>
-                  <a:srgbClr val="8FA0B4"/>
-                </a:solidFill>
-                <a:latin typeface="Arial" pitchFamily="34" charset="0"/>
-                <a:ea typeface="Arial" pitchFamily="34" charset="-122"/>
-                <a:cs typeface="Arial" pitchFamily="34" charset="-120"/>
-              </a:rPr>
-              <a:t>Post-Tarife hinterlegen, versichert</a:t>
-            </a:r>
-            <a:endParaRPr lang="en-US" sz="1000" dirty="0"/>
-          </a:p>
-        </p:txBody>
-      </p:sp>
-      <p:sp>
-        <p:nvSpPr>
-          <p:cNvPr id="23" name="Shape 21"/>
-          <p:cNvSpPr/>
-          <p:nvPr/>
-        </p:nvSpPr>
-        <p:spPr>
-          <a:xfrm>
-            <a:off x="9581083" y="2103120"/>
-            <a:ext cx="2104949" cy="1828800"/>
-          </a:xfrm>
-          <a:prstGeom prst="roundRect">
-            <a:avLst>
-              <a:gd name="adj" fmla="val 2500"/>
-            </a:avLst>
-          </a:prstGeom>
-          <a:solidFill>
-            <a:srgbClr val="141B24"/>
-          </a:solidFill>
-          <a:ln w="9525">
-            <a:solidFill>
-              <a:srgbClr val="243040"/>
-            </a:solidFill>
-            <a:prstDash val="solid"/>
-          </a:ln>
-        </p:spPr>
-      </p:sp>
-      <p:sp>
-        <p:nvSpPr>
-          <p:cNvPr id="24" name="Text 22"/>
-          <p:cNvSpPr/>
-          <p:nvPr/>
-        </p:nvSpPr>
-        <p:spPr>
-          <a:xfrm>
-            <a:off x="9782251" y="2267712"/>
-            <a:ext cx="548640" cy="274320"/>
-          </a:xfrm>
-          <a:prstGeom prst="rect">
-            <a:avLst/>
-          </a:prstGeom>
-          <a:noFill/>
-          <a:ln/>
-        </p:spPr>
-        <p:txBody>
-          <a:bodyPr wrap="square" lIns="0" tIns="0" rIns="0" bIns="0" rtlCol="0" anchor="ctr"/>
-          <a:lstStyle/>
-          <a:p>
-            <a:pPr indent="0" marL="0">
-              <a:buNone/>
-            </a:pPr>
-            <a:r>
-              <a:rPr lang="en-US" sz="1100" b="1" dirty="0">
-                <a:solidFill>
-                  <a:srgbClr val="6699FF"/>
-                </a:solidFill>
-                <a:latin typeface="Arial" pitchFamily="34" charset="0"/>
-                <a:ea typeface="Arial" pitchFamily="34" charset="-122"/>
-                <a:cs typeface="Arial" pitchFamily="34" charset="-120"/>
-              </a:rPr>
-              <a:t>5</a:t>
-            </a:r>
-            <a:endParaRPr lang="en-US" sz="1100" dirty="0"/>
-          </a:p>
-        </p:txBody>
-      </p:sp>
-      <p:sp>
-        <p:nvSpPr>
-          <p:cNvPr id="25" name="Text 23"/>
-          <p:cNvSpPr/>
-          <p:nvPr/>
-        </p:nvSpPr>
-        <p:spPr>
-          <a:xfrm>
-            <a:off x="9782251" y="2560320"/>
-            <a:ext cx="1702613" cy="365760"/>
-          </a:xfrm>
-          <a:prstGeom prst="rect">
-            <a:avLst/>
-          </a:prstGeom>
-          <a:noFill/>
-          <a:ln/>
-        </p:spPr>
-        <p:txBody>
-          <a:bodyPr wrap="square" lIns="0" tIns="0" rIns="0" bIns="0" rtlCol="0" anchor="ctr"/>
-          <a:lstStyle/>
-          <a:p>
-            <a:pPr indent="0" marL="0">
-              <a:buNone/>
-            </a:pPr>
-            <a:r>
-              <a:rPr lang="en-US" sz="1350" b="1" dirty="0">
-                <a:solidFill>
-                  <a:srgbClr val="EDF2F7"/>
-                </a:solidFill>
-                <a:latin typeface="Arial" pitchFamily="34" charset="0"/>
-                <a:ea typeface="Arial" pitchFamily="34" charset="-122"/>
-                <a:cs typeface="Arial" pitchFamily="34" charset="-120"/>
-              </a:rPr>
-              <a:t>Testkauf</a:t>
-            </a:r>
-            <a:endParaRPr lang="en-US" sz="1350" dirty="0"/>
-          </a:p>
-        </p:txBody>
-      </p:sp>
-      <p:sp>
-        <p:nvSpPr>
-          <p:cNvPr id="26" name="Text 24"/>
-          <p:cNvSpPr/>
-          <p:nvPr/>
-        </p:nvSpPr>
-        <p:spPr>
-          <a:xfrm>
-            <a:off x="9782251" y="2944368"/>
-            <a:ext cx="1702613" cy="822960"/>
-          </a:xfrm>
-          <a:prstGeom prst="rect">
-            <a:avLst/>
-          </a:prstGeom>
-          <a:noFill/>
-          <a:ln/>
-        </p:spPr>
-        <p:txBody>
-          <a:bodyPr wrap="square" lIns="0" tIns="0" rIns="0" bIns="0" rtlCol="0" anchor="ctr"/>
-          <a:lstStyle/>
-          <a:p>
-            <a:pPr indent="0" marL="0">
-              <a:lnSpc>
-                <a:spcPct val="115000"/>
-              </a:lnSpc>
-              <a:buNone/>
-            </a:pPr>
-            <a:r>
-              <a:rPr lang="en-US" sz="1000" dirty="0">
-                <a:solidFill>
-                  <a:srgbClr val="8FA0B4"/>
-                </a:solidFill>
-                <a:latin typeface="Arial" pitchFamily="34" charset="0"/>
-                <a:ea typeface="Arial" pitchFamily="34" charset="-122"/>
-                <a:cs typeface="Arial" pitchFamily="34" charset="-120"/>
-              </a:rPr>
-              <a:t>Selber bestellen — Screenshot als Beweis</a:t>
-            </a:r>
-            <a:endParaRPr lang="en-US" sz="1000" dirty="0"/>
-          </a:p>
-        </p:txBody>
-      </p:sp>
-      <p:sp>
-        <p:nvSpPr>
-          <p:cNvPr id="27" name="Text 25"/>
-          <p:cNvSpPr/>
-          <p:nvPr/>
-        </p:nvSpPr>
-        <p:spPr>
-          <a:xfrm>
-            <a:off x="502920" y="4389120"/>
-            <a:ext cx="10515600" cy="685800"/>
-          </a:xfrm>
-          <a:prstGeom prst="rect">
-            <a:avLst/>
-          </a:prstGeom>
-          <a:noFill/>
-          <a:ln/>
-        </p:spPr>
-        <p:txBody>
-          <a:bodyPr wrap="square" lIns="0" tIns="0" rIns="0" bIns="0" rtlCol="0" anchor="ctr"/>
-          <a:lstStyle/>
-          <a:p>
-            <a:pPr indent="0" marL="0">
-              <a:lnSpc>
-                <a:spcPct val="120000"/>
-              </a:lnSpc>
-              <a:buNone/>
-            </a:pPr>
-            <a:r>
-              <a:rPr lang="en-US" sz="1350" dirty="0">
-                <a:solidFill>
-                  <a:srgbClr val="8FA0B4"/>
-                </a:solidFill>
-                <a:latin typeface="Arial" pitchFamily="34" charset="0"/>
-                <a:ea typeface="Arial" pitchFamily="34" charset="-122"/>
-                <a:cs typeface="Arial" pitchFamily="34" charset="-120"/>
-              </a:rPr>
-              <a:t>Wie ein Tutorial: wer das nachmacht, hat am Wochenende einen eigenen Shop.</a:t>
-            </a:r>
-            <a:endParaRPr lang="en-US" sz="1350" dirty="0"/>
-          </a:p>
-        </p:txBody>
-      </p:sp>
-    </p:spTree>
-  </p:cSld>
-  <p:clrMapOvr>
-    <a:masterClrMapping/>
-  </p:clrMapOvr>
-  <mc:AlternateContent xmlns:mc="http://schemas.openxmlformats.org/markup-compatibility/2006">
-    <mc:Choice xmlns:p159="http://schemas.microsoft.com/office/powerpoint/2015/09/main" Requires="p159">
-      <p:transition xmlns:p14="http://schemas.microsoft.com/office/powerpoint/2010/main" spd="slow" p14:dur="700">
-        <p159:morph option="byObject"/>
-      </p:transition>
-    </mc:Choice>
-    <mc:Fallback>
-      <p:transition spd="slow">
-        <p:fade/>
-      </p:transition>
-    </mc:Fallback>
-  </mc:AlternateContent>
-  <p:timing>
-    <p:tnLst>
-      <p:par>
-        <p:cTn id="1" dur="indefinite" restart="never" nodeType="tmRoot">
-          <p:childTnLst>
-            <p:seq concurrent="1" nextAc="seek">
-              <p:cTn id="2" dur="indefinite" nodeType="mainSeq">
-                <p:childTnLst>
-                  <p:par>
-                    <p:cTn id="73" fill="hold">
-                      <p:stCondLst>
-                        <p:cond delay="indefinite"/>
-                        <p:cond evt="onBegin" delay="0">
-                          <p:tn val="2"/>
-                        </p:cond>
-                      </p:stCondLst>
-                      <p:childTnLst>
-                        <p:par>
-                          <p:cTn id="72" fill="hold">
-                            <p:stCondLst>
-                              <p:cond delay="0"/>
-                            </p:stCondLst>
-                            <p:childTnLst>
-                              <p:par>
-                                <p:cTn id="3" presetID="10" presetClass="entr" presetSubtype="0" fill="hold" grpId="0" nodeType="withEffect">
-                                  <p:stCondLst>
-                                    <p:cond delay="0"/>
-                                  </p:stCondLst>
-                                  <p:childTnLst>
-                                    <p:set>
-                                      <p:cBhvr>
-                                        <p:cTn id="4" dur="1" fill="hold">
-                                          <p:stCondLst>
-                                            <p:cond delay="0"/>
-                                          </p:stCondLst>
-                                        </p:cTn>
-                                        <p:tgtEl>
-                                          <p:spTgt spid="5"/>
-                                        </p:tgtEl>
-                                        <p:attrNameLst>
-                                          <p:attrName>style.visibility</p:attrName>
-                                        </p:attrNameLst>
-                                      </p:cBhvr>
-                                      <p:to>
-                                        <p:strVal val="visible"/>
-                                      </p:to>
-                                    </p:set>
-                                    <p:animEffect transition="in" filter="fade">
-                                      <p:cBhvr>
-                                        <p:cTn id="5" dur="400"/>
-                                        <p:tgtEl>
-                                          <p:spTgt spid="5"/>
-                                        </p:tgtEl>
-                                      </p:cBhvr>
-                                    </p:animEffect>
-                                  </p:childTnLst>
-                                </p:cTn>
-                              </p:par>
-                              <p:par>
-                                <p:cTn id="6" presetID="10" presetClass="entr" presetSubtype="0" fill="hold" grpId="0" nodeType="afterEffect">
-                                  <p:stCondLst>
-                                    <p:cond delay="130"/>
-                                  </p:stCondLst>
-                                  <p:childTnLst>
-                                    <p:set>
-                                      <p:cBhvr>
-                                        <p:cTn id="7" dur="1" fill="hold">
-                                          <p:stCondLst>
-                                            <p:cond delay="0"/>
-                                          </p:stCondLst>
-                                        </p:cTn>
-                                        <p:tgtEl>
-                                          <p:spTgt spid="6"/>
-                                        </p:tgtEl>
-                                        <p:attrNameLst>
-                                          <p:attrName>style.visibility</p:attrName>
-                                        </p:attrNameLst>
-                                      </p:cBhvr>
-                                      <p:to>
-                                        <p:strVal val="visible"/>
-                                      </p:to>
-                                    </p:set>
-                                    <p:animEffect transition="in" filter="fade">
-                                      <p:cBhvr>
-                                        <p:cTn id="8" dur="400"/>
-                                        <p:tgtEl>
-                                          <p:spTgt spid="6"/>
-                                        </p:tgtEl>
-                                      </p:cBhvr>
-                                    </p:animEffect>
-                                  </p:childTnLst>
-                                </p:cTn>
-                              </p:par>
-                              <p:par>
-                                <p:cTn id="9" presetID="10" presetClass="entr" presetSubtype="0" fill="hold" grpId="0" nodeType="afterEffect">
-                                  <p:stCondLst>
-                                    <p:cond delay="260"/>
-                                  </p:stCondLst>
-                                  <p:childTnLst>
-                                    <p:set>
-                                      <p:cBhvr>
-                                        <p:cTn id="10" dur="1" fill="hold">
-                                          <p:stCondLst>
-                                            <p:cond delay="0"/>
-                                          </p:stCondLst>
-                                        </p:cTn>
-                                        <p:tgtEl>
-                                          <p:spTgt spid="7"/>
-                                        </p:tgtEl>
-                                        <p:attrNameLst>
-                                          <p:attrName>style.visibility</p:attrName>
-                                        </p:attrNameLst>
-                                      </p:cBhvr>
-                                      <p:to>
-                                        <p:strVal val="visible"/>
-                                      </p:to>
-                                    </p:set>
-                                    <p:animEffect transition="in" filter="fade">
-                                      <p:cBhvr>
-                                        <p:cTn id="11" dur="400"/>
-                                        <p:tgtEl>
-                                          <p:spTgt spid="7"/>
-                                        </p:tgtEl>
-                                      </p:cBhvr>
-                                    </p:animEffect>
-                                  </p:childTnLst>
-                                </p:cTn>
-                              </p:par>
-                              <p:par>
-                                <p:cTn id="12" presetID="10" presetClass="entr" presetSubtype="0" fill="hold" grpId="0" nodeType="afterEffect">
-                                  <p:stCondLst>
-                                    <p:cond delay="390"/>
-                                  </p:stCondLst>
-                                  <p:childTnLst>
-                                    <p:set>
-                                      <p:cBhvr>
-                                        <p:cTn id="13" dur="1" fill="hold">
-                                          <p:stCondLst>
-                                            <p:cond delay="0"/>
-                                          </p:stCondLst>
-                                        </p:cTn>
-                                        <p:tgtEl>
-                                          <p:spTgt spid="8"/>
-                                        </p:tgtEl>
-                                        <p:attrNameLst>
-                                          <p:attrName>style.visibility</p:attrName>
-                                        </p:attrNameLst>
-                                      </p:cBhvr>
-                                      <p:to>
-                                        <p:strVal val="visible"/>
-                                      </p:to>
-                                    </p:set>
-                                    <p:animEffect transition="in" filter="fade">
-                                      <p:cBhvr>
-                                        <p:cTn id="14" dur="400"/>
-                                        <p:tgtEl>
-                                          <p:spTgt spid="8"/>
-                                        </p:tgtEl>
-                                      </p:cBhvr>
-                                    </p:animEffect>
-                                  </p:childTnLst>
-                                </p:cTn>
-                              </p:par>
-                              <p:par>
-                                <p:cTn id="15" presetID="10" presetClass="entr" presetSubtype="0" fill="hold" grpId="0" nodeType="afterEffect">
-                                  <p:stCondLst>
-                                    <p:cond delay="520"/>
-                                  </p:stCondLst>
-                                  <p:childTnLst>
-                                    <p:set>
-                                      <p:cBhvr>
-                                        <p:cTn id="16" dur="1" fill="hold">
-                                          <p:stCondLst>
-                                            <p:cond delay="0"/>
-                                          </p:stCondLst>
-                                        </p:cTn>
-                                        <p:tgtEl>
-                                          <p:spTgt spid="9"/>
-                                        </p:tgtEl>
-                                        <p:attrNameLst>
-                                          <p:attrName>style.visibility</p:attrName>
-                                        </p:attrNameLst>
-                                      </p:cBhvr>
-                                      <p:to>
-                                        <p:strVal val="visible"/>
-                                      </p:to>
-                                    </p:set>
-                                    <p:animEffect transition="in" filter="fade">
-                                      <p:cBhvr>
-                                        <p:cTn id="17" dur="400"/>
-                                        <p:tgtEl>
-                                          <p:spTgt spid="9"/>
-                                        </p:tgtEl>
-                                      </p:cBhvr>
-                                    </p:animEffect>
-                                  </p:childTnLst>
-                                </p:cTn>
-                              </p:par>
-                              <p:par>
-                                <p:cTn id="18" presetID="10" presetClass="entr" presetSubtype="0" fill="hold" grpId="0" nodeType="afterEffect">
-                                  <p:stCondLst>
-                                    <p:cond delay="650"/>
-                                  </p:stCondLst>
-                                  <p:childTnLst>
-                                    <p:set>
-                                      <p:cBhvr>
-                                        <p:cTn id="19" dur="1" fill="hold">
-                                          <p:stCondLst>
-                                            <p:cond delay="0"/>
-                                          </p:stCondLst>
-                                        </p:cTn>
-                                        <p:tgtEl>
-                                          <p:spTgt spid="10"/>
-                                        </p:tgtEl>
-                                        <p:attrNameLst>
-                                          <p:attrName>style.visibility</p:attrName>
-                                        </p:attrNameLst>
-                                      </p:cBhvr>
-                                      <p:to>
-                                        <p:strVal val="visible"/>
-                                      </p:to>
-                                    </p:set>
-                                    <p:animEffect transition="in" filter="fade">
-                                      <p:cBhvr>
-                                        <p:cTn id="20" dur="400"/>
-                                        <p:tgtEl>
-                                          <p:spTgt spid="10"/>
-                                        </p:tgtEl>
-                                      </p:cBhvr>
-                                    </p:animEffect>
-                                  </p:childTnLst>
-                                </p:cTn>
-                              </p:par>
-                              <p:par>
-                                <p:cTn id="21" presetID="10" presetClass="entr" presetSubtype="0" fill="hold" grpId="0" nodeType="afterEffect">
-                                  <p:stCondLst>
-                                    <p:cond delay="780"/>
-                                  </p:stCondLst>
-                                  <p:childTnLst>
-                                    <p:set>
-                                      <p:cBhvr>
-                                        <p:cTn id="22" dur="1" fill="hold">
-                                          <p:stCondLst>
-                                            <p:cond delay="0"/>
-                                          </p:stCondLst>
-                                        </p:cTn>
-                                        <p:tgtEl>
-                                          <p:spTgt spid="11"/>
-                                        </p:tgtEl>
-                                        <p:attrNameLst>
-                                          <p:attrName>style.visibility</p:attrName>
-                                        </p:attrNameLst>
-                                      </p:cBhvr>
-                                      <p:to>
-                                        <p:strVal val="visible"/>
-                                      </p:to>
-                                    </p:set>
-                                    <p:animEffect transition="in" filter="fade">
-                                      <p:cBhvr>
-                                        <p:cTn id="23" dur="400"/>
-                                        <p:tgtEl>
-                                          <p:spTgt spid="11"/>
-                                        </p:tgtEl>
-                                      </p:cBhvr>
-                                    </p:animEffect>
-                                  </p:childTnLst>
-                                </p:cTn>
-                              </p:par>
-                              <p:par>
-                                <p:cTn id="24" presetID="10" presetClass="entr" presetSubtype="0" fill="hold" grpId="0" nodeType="afterEffect">
-                                  <p:stCondLst>
-                                    <p:cond delay="910"/>
-                                  </p:stCondLst>
-                                  <p:childTnLst>
-                                    <p:set>
-                                      <p:cBhvr>
-                                        <p:cTn id="25" dur="1" fill="hold">
-                                          <p:stCondLst>
-                                            <p:cond delay="0"/>
-                                          </p:stCondLst>
-                                        </p:cTn>
-                                        <p:tgtEl>
-                                          <p:spTgt spid="12"/>
-                                        </p:tgtEl>
-                                        <p:attrNameLst>
-                                          <p:attrName>style.visibility</p:attrName>
-                                        </p:attrNameLst>
-                                      </p:cBhvr>
-                                      <p:to>
-                                        <p:strVal val="visible"/>
-                                      </p:to>
-                                    </p:set>
-                                    <p:animEffect transition="in" filter="fade">
-                                      <p:cBhvr>
-                                        <p:cTn id="26" dur="400"/>
-                                        <p:tgtEl>
-                                          <p:spTgt spid="12"/>
-                                        </p:tgtEl>
-                                      </p:cBhvr>
-                                    </p:animEffect>
-                                  </p:childTnLst>
-                                </p:cTn>
-                              </p:par>
-                              <p:par>
-                                <p:cTn id="27" presetID="10" presetClass="entr" presetSubtype="0" fill="hold" grpId="0" nodeType="afterEffect">
-                                  <p:stCondLst>
-                                    <p:cond delay="1040"/>
-                                  </p:stCondLst>
-                                  <p:childTnLst>
-                                    <p:set>
-                                      <p:cBhvr>
-                                        <p:cTn id="28" dur="1" fill="hold">
-                                          <p:stCondLst>
-                                            <p:cond delay="0"/>
-                                          </p:stCondLst>
-                                        </p:cTn>
-                                        <p:tgtEl>
-                                          <p:spTgt spid="13"/>
-                                        </p:tgtEl>
-                                        <p:attrNameLst>
-                                          <p:attrName>style.visibility</p:attrName>
-                                        </p:attrNameLst>
-                                      </p:cBhvr>
-                                      <p:to>
-                                        <p:strVal val="visible"/>
-                                      </p:to>
-                                    </p:set>
-                                    <p:animEffect transition="in" filter="fade">
-                                      <p:cBhvr>
-                                        <p:cTn id="29" dur="400"/>
-                                        <p:tgtEl>
-                                          <p:spTgt spid="13"/>
-                                        </p:tgtEl>
-                                      </p:cBhvr>
-                                    </p:animEffect>
-                                  </p:childTnLst>
-                                </p:cTn>
-                              </p:par>
-                              <p:par>
-                                <p:cTn id="30" presetID="10" presetClass="entr" presetSubtype="0" fill="hold" grpId="0" nodeType="afterEffect">
-                                  <p:stCondLst>
-                                    <p:cond delay="1170"/>
-                                  </p:stCondLst>
-                                  <p:childTnLst>
-                                    <p:set>
-                                      <p:cBhvr>
-                                        <p:cTn id="31" dur="1" fill="hold">
-                                          <p:stCondLst>
-                                            <p:cond delay="0"/>
-                                          </p:stCondLst>
-                                        </p:cTn>
-                                        <p:tgtEl>
-                                          <p:spTgt spid="14"/>
-                                        </p:tgtEl>
-                                        <p:attrNameLst>
-                                          <p:attrName>style.visibility</p:attrName>
-                                        </p:attrNameLst>
-                                      </p:cBhvr>
-                                      <p:to>
-                                        <p:strVal val="visible"/>
-                                      </p:to>
-                                    </p:set>
-                                    <p:animEffect transition="in" filter="fade">
-                                      <p:cBhvr>
-                                        <p:cTn id="32" dur="400"/>
-                                        <p:tgtEl>
-                                          <p:spTgt spid="14"/>
-                                        </p:tgtEl>
-                                      </p:cBhvr>
-                                    </p:animEffect>
-                                  </p:childTnLst>
-                                </p:cTn>
-                              </p:par>
-                              <p:par>
-                                <p:cTn id="33" presetID="10" presetClass="entr" presetSubtype="0" fill="hold" grpId="0" nodeType="afterEffect">
-                                  <p:stCondLst>
-                                    <p:cond delay="1300"/>
-                                  </p:stCondLst>
-                                  <p:childTnLst>
-                                    <p:set>
-                                      <p:cBhvr>
-                                        <p:cTn id="34" dur="1" fill="hold">
-                                          <p:stCondLst>
-                                            <p:cond delay="0"/>
-                                          </p:stCondLst>
-                                        </p:cTn>
-                                        <p:tgtEl>
-                                          <p:spTgt spid="15"/>
-                                        </p:tgtEl>
-                                        <p:attrNameLst>
-                                          <p:attrName>style.visibility</p:attrName>
-                                        </p:attrNameLst>
-                                      </p:cBhvr>
-                                      <p:to>
-                                        <p:strVal val="visible"/>
-                                      </p:to>
-                                    </p:set>
-                                    <p:animEffect transition="in" filter="fade">
-                                      <p:cBhvr>
-                                        <p:cTn id="35" dur="400"/>
-                                        <p:tgtEl>
-                                          <p:spTgt spid="15"/>
-                                        </p:tgtEl>
-                                      </p:cBhvr>
-                                    </p:animEffect>
-                                  </p:childTnLst>
-                                </p:cTn>
-                              </p:par>
-                              <p:par>
-                                <p:cTn id="36" presetID="10" presetClass="entr" presetSubtype="0" fill="hold" grpId="0" nodeType="afterEffect">
-                                  <p:stCondLst>
-                                    <p:cond delay="1430"/>
-                                  </p:stCondLst>
-                                  <p:childTnLst>
-                                    <p:set>
-                                      <p:cBhvr>
-                                        <p:cTn id="37" dur="1" fill="hold">
-                                          <p:stCondLst>
-                                            <p:cond delay="0"/>
-                                          </p:stCondLst>
-                                        </p:cTn>
-                                        <p:tgtEl>
-                                          <p:spTgt spid="16"/>
-                                        </p:tgtEl>
-                                        <p:attrNameLst>
-                                          <p:attrName>style.visibility</p:attrName>
-                                        </p:attrNameLst>
-                                      </p:cBhvr>
-                                      <p:to>
-                                        <p:strVal val="visible"/>
-                                      </p:to>
-                                    </p:set>
-                                    <p:animEffect transition="in" filter="fade">
-                                      <p:cBhvr>
-                                        <p:cTn id="38" dur="400"/>
-                                        <p:tgtEl>
-                                          <p:spTgt spid="16"/>
-                                        </p:tgtEl>
-                                      </p:cBhvr>
-                                    </p:animEffect>
-                                  </p:childTnLst>
-                                </p:cTn>
-                              </p:par>
-                              <p:par>
-                                <p:cTn id="39" presetID="10" presetClass="entr" presetSubtype="0" fill="hold" grpId="0" nodeType="afterEffect">
-                                  <p:stCondLst>
-                                    <p:cond delay="1560"/>
-                                  </p:stCondLst>
-                                  <p:childTnLst>
-                                    <p:set>
-                                      <p:cBhvr>
-                                        <p:cTn id="40" dur="1" fill="hold">
-                                          <p:stCondLst>
-                                            <p:cond delay="0"/>
-                                          </p:stCondLst>
-                                        </p:cTn>
-                                        <p:tgtEl>
-                                          <p:spTgt spid="17"/>
-                                        </p:tgtEl>
-                                        <p:attrNameLst>
-                                          <p:attrName>style.visibility</p:attrName>
-                                        </p:attrNameLst>
-                                      </p:cBhvr>
-                                      <p:to>
-                                        <p:strVal val="visible"/>
-                                      </p:to>
-                                    </p:set>
-                                    <p:animEffect transition="in" filter="fade">
-                                      <p:cBhvr>
-                                        <p:cTn id="41" dur="400"/>
-                                        <p:tgtEl>
-                                          <p:spTgt spid="17"/>
-                                        </p:tgtEl>
-                                      </p:cBhvr>
-                                    </p:animEffect>
-                                  </p:childTnLst>
-                                </p:cTn>
-                              </p:par>
-                              <p:par>
-                                <p:cTn id="42" presetID="10" presetClass="entr" presetSubtype="0" fill="hold" grpId="0" nodeType="afterEffect">
-                                  <p:stCondLst>
-                                    <p:cond delay="1690"/>
-                                  </p:stCondLst>
-                                  <p:childTnLst>
-                                    <p:set>
-                                      <p:cBhvr>
-                                        <p:cTn id="43" dur="1" fill="hold">
-                                          <p:stCondLst>
-                                            <p:cond delay="0"/>
-                                          </p:stCondLst>
-                                        </p:cTn>
-                                        <p:tgtEl>
-                                          <p:spTgt spid="18"/>
-                                        </p:tgtEl>
-                                        <p:attrNameLst>
-                                          <p:attrName>style.visibility</p:attrName>
-                                        </p:attrNameLst>
-                                      </p:cBhvr>
-                                      <p:to>
-                                        <p:strVal val="visible"/>
-                                      </p:to>
-                                    </p:set>
-                                    <p:animEffect transition="in" filter="fade">
-                                      <p:cBhvr>
-                                        <p:cTn id="44" dur="400"/>
-                                        <p:tgtEl>
-                                          <p:spTgt spid="18"/>
-                                        </p:tgtEl>
-                                      </p:cBhvr>
-                                    </p:animEffect>
-                                  </p:childTnLst>
-                                </p:cTn>
-                              </p:par>
-                              <p:par>
-                                <p:cTn id="45" presetID="10" presetClass="entr" presetSubtype="0" fill="hold" grpId="0" nodeType="afterEffect">
-                                  <p:stCondLst>
-                                    <p:cond delay="1820"/>
-                                  </p:stCondLst>
-                                  <p:childTnLst>
-                                    <p:set>
-                                      <p:cBhvr>
-                                        <p:cTn id="46" dur="1" fill="hold">
-                                          <p:stCondLst>
-                                            <p:cond delay="0"/>
-                                          </p:stCondLst>
-                                        </p:cTn>
-                                        <p:tgtEl>
-                                          <p:spTgt spid="19"/>
-                                        </p:tgtEl>
-                                        <p:attrNameLst>
-                                          <p:attrName>style.visibility</p:attrName>
-                                        </p:attrNameLst>
-                                      </p:cBhvr>
-                                      <p:to>
-                                        <p:strVal val="visible"/>
-                                      </p:to>
-                                    </p:set>
-                                    <p:animEffect transition="in" filter="fade">
-                                      <p:cBhvr>
-                                        <p:cTn id="47" dur="400"/>
-                                        <p:tgtEl>
-                                          <p:spTgt spid="19"/>
-                                        </p:tgtEl>
-                                      </p:cBhvr>
-                                    </p:animEffect>
-                                  </p:childTnLst>
-                                </p:cTn>
-                              </p:par>
-                              <p:par>
-                                <p:cTn id="48" presetID="10" presetClass="entr" presetSubtype="0" fill="hold" grpId="0" nodeType="afterEffect">
-                                  <p:stCondLst>
-                                    <p:cond delay="1950"/>
-                                  </p:stCondLst>
-                                  <p:childTnLst>
-                                    <p:set>
-                                      <p:cBhvr>
-                                        <p:cTn id="49" dur="1" fill="hold">
-                                          <p:stCondLst>
-                                            <p:cond delay="0"/>
-                                          </p:stCondLst>
-                                        </p:cTn>
-                                        <p:tgtEl>
-                                          <p:spTgt spid="20"/>
-                                        </p:tgtEl>
-                                        <p:attrNameLst>
-                                          <p:attrName>style.visibility</p:attrName>
-                                        </p:attrNameLst>
-                                      </p:cBhvr>
-                                      <p:to>
-                                        <p:strVal val="visible"/>
-                                      </p:to>
-                                    </p:set>
-                                    <p:animEffect transition="in" filter="fade">
-                                      <p:cBhvr>
-                                        <p:cTn id="50" dur="400"/>
-                                        <p:tgtEl>
-                                          <p:spTgt spid="20"/>
-                                        </p:tgtEl>
-                                      </p:cBhvr>
-                                    </p:animEffect>
-                                  </p:childTnLst>
-                                </p:cTn>
-                              </p:par>
-                              <p:par>
-                                <p:cTn id="51" presetID="10" presetClass="entr" presetSubtype="0" fill="hold" grpId="0" nodeType="afterEffect">
-                                  <p:stCondLst>
-                                    <p:cond delay="2080"/>
-                                  </p:stCondLst>
-                                  <p:childTnLst>
-                                    <p:set>
-                                      <p:cBhvr>
-                                        <p:cTn id="52" dur="1" fill="hold">
-                                          <p:stCondLst>
-                                            <p:cond delay="0"/>
-                                          </p:stCondLst>
-                                        </p:cTn>
-                                        <p:tgtEl>
-                                          <p:spTgt spid="21"/>
-                                        </p:tgtEl>
-                                        <p:attrNameLst>
-                                          <p:attrName>style.visibility</p:attrName>
-                                        </p:attrNameLst>
-                                      </p:cBhvr>
-                                      <p:to>
-                                        <p:strVal val="visible"/>
-                                      </p:to>
-                                    </p:set>
-                                    <p:animEffect transition="in" filter="fade">
-                                      <p:cBhvr>
-                                        <p:cTn id="53" dur="400"/>
-                                        <p:tgtEl>
-                                          <p:spTgt spid="21"/>
-                                        </p:tgtEl>
-                                      </p:cBhvr>
-                                    </p:animEffect>
-                                  </p:childTnLst>
-                                </p:cTn>
-                              </p:par>
-                              <p:par>
-                                <p:cTn id="54" presetID="10" presetClass="entr" presetSubtype="0" fill="hold" grpId="0" nodeType="afterEffect">
-                                  <p:stCondLst>
-                                    <p:cond delay="2210"/>
-                                  </p:stCondLst>
-                                  <p:childTnLst>
-                                    <p:set>
-                                      <p:cBhvr>
-                                        <p:cTn id="55" dur="1" fill="hold">
-                                          <p:stCondLst>
-                                            <p:cond delay="0"/>
-                                          </p:stCondLst>
-                                        </p:cTn>
-                                        <p:tgtEl>
-                                          <p:spTgt spid="22"/>
-                                        </p:tgtEl>
-                                        <p:attrNameLst>
-                                          <p:attrName>style.visibility</p:attrName>
-                                        </p:attrNameLst>
-                                      </p:cBhvr>
-                                      <p:to>
-                                        <p:strVal val="visible"/>
-                                      </p:to>
-                                    </p:set>
-                                    <p:animEffect transition="in" filter="fade">
-                                      <p:cBhvr>
-                                        <p:cTn id="56" dur="400"/>
-                                        <p:tgtEl>
-                                          <p:spTgt spid="22"/>
-                                        </p:tgtEl>
-                                      </p:cBhvr>
-                                    </p:animEffect>
-                                  </p:childTnLst>
-                                </p:cTn>
-                              </p:par>
-                              <p:par>
-                                <p:cTn id="57" presetID="10" presetClass="entr" presetSubtype="0" fill="hold" grpId="0" nodeType="afterEffect">
-                                  <p:stCondLst>
-                                    <p:cond delay="2340"/>
-                                  </p:stCondLst>
-                                  <p:childTnLst>
-                                    <p:set>
-                                      <p:cBhvr>
-                                        <p:cTn id="58" dur="1" fill="hold">
-                                          <p:stCondLst>
-                                            <p:cond delay="0"/>
-                                          </p:stCondLst>
-                                        </p:cTn>
-                                        <p:tgtEl>
-                                          <p:spTgt spid="23"/>
-                                        </p:tgtEl>
-                                        <p:attrNameLst>
-                                          <p:attrName>style.visibility</p:attrName>
-                                        </p:attrNameLst>
-                                      </p:cBhvr>
-                                      <p:to>
-                                        <p:strVal val="visible"/>
-                                      </p:to>
-                                    </p:set>
-                                    <p:animEffect transition="in" filter="fade">
-                                      <p:cBhvr>
-                                        <p:cTn id="59" dur="400"/>
-                                        <p:tgtEl>
-                                          <p:spTgt spid="23"/>
-                                        </p:tgtEl>
-                                      </p:cBhvr>
-                                    </p:animEffect>
-                                  </p:childTnLst>
-                                </p:cTn>
-                              </p:par>
-                              <p:par>
-                                <p:cTn id="60" presetID="10" presetClass="entr" presetSubtype="0" fill="hold" grpId="0" nodeType="afterEffect">
-                                  <p:stCondLst>
-                                    <p:cond delay="2470"/>
-                                  </p:stCondLst>
-                                  <p:childTnLst>
-                                    <p:set>
-                                      <p:cBhvr>
-                                        <p:cTn id="61" dur="1" fill="hold">
-                                          <p:stCondLst>
-                                            <p:cond delay="0"/>
-                                          </p:stCondLst>
-                                        </p:cTn>
-                                        <p:tgtEl>
-                                          <p:spTgt spid="24"/>
-                                        </p:tgtEl>
-                                        <p:attrNameLst>
-                                          <p:attrName>style.visibility</p:attrName>
-                                        </p:attrNameLst>
-                                      </p:cBhvr>
-                                      <p:to>
-                                        <p:strVal val="visible"/>
-                                      </p:to>
-                                    </p:set>
-                                    <p:animEffect transition="in" filter="fade">
-                                      <p:cBhvr>
-                                        <p:cTn id="62" dur="400"/>
-                                        <p:tgtEl>
-                                          <p:spTgt spid="24"/>
-                                        </p:tgtEl>
-                                      </p:cBhvr>
-                                    </p:animEffect>
-                                  </p:childTnLst>
-                                </p:cTn>
-                              </p:par>
-                              <p:par>
-                                <p:cTn id="63" presetID="10" presetClass="entr" presetSubtype="0" fill="hold" grpId="0" nodeType="afterEffect">
-                                  <p:stCondLst>
-                                    <p:cond delay="2600"/>
-                                  </p:stCondLst>
-                                  <p:childTnLst>
-                                    <p:set>
-                                      <p:cBhvr>
-                                        <p:cTn id="64" dur="1" fill="hold">
-                                          <p:stCondLst>
-                                            <p:cond delay="0"/>
-                                          </p:stCondLst>
-                                        </p:cTn>
-                                        <p:tgtEl>
-                                          <p:spTgt spid="25"/>
-                                        </p:tgtEl>
-                                        <p:attrNameLst>
-                                          <p:attrName>style.visibility</p:attrName>
-                                        </p:attrNameLst>
-                                      </p:cBhvr>
-                                      <p:to>
-                                        <p:strVal val="visible"/>
-                                      </p:to>
-                                    </p:set>
-                                    <p:animEffect transition="in" filter="fade">
-                                      <p:cBhvr>
-                                        <p:cTn id="65" dur="400"/>
-                                        <p:tgtEl>
-                                          <p:spTgt spid="25"/>
-                                        </p:tgtEl>
-                                      </p:cBhvr>
-                                    </p:animEffect>
-                                  </p:childTnLst>
-                                </p:cTn>
-                              </p:par>
-                              <p:par>
-                                <p:cTn id="66" presetID="10" presetClass="entr" presetSubtype="0" fill="hold" grpId="0" nodeType="afterEffect">
-                                  <p:stCondLst>
-                                    <p:cond delay="2730"/>
-                                  </p:stCondLst>
-                                  <p:childTnLst>
-                                    <p:set>
-                                      <p:cBhvr>
-                                        <p:cTn id="67" dur="1" fill="hold">
-                                          <p:stCondLst>
-                                            <p:cond delay="0"/>
-                                          </p:stCondLst>
-                                        </p:cTn>
-                                        <p:tgtEl>
-                                          <p:spTgt spid="26"/>
-                                        </p:tgtEl>
-                                        <p:attrNameLst>
-                                          <p:attrName>style.visibility</p:attrName>
-                                        </p:attrNameLst>
-                                      </p:cBhvr>
-                                      <p:to>
-                                        <p:strVal val="visible"/>
-                                      </p:to>
-                                    </p:set>
-                                    <p:animEffect transition="in" filter="fade">
-                                      <p:cBhvr>
-                                        <p:cTn id="68" dur="400"/>
-                                        <p:tgtEl>
-                                          <p:spTgt spid="26"/>
-                                        </p:tgtEl>
-                                      </p:cBhvr>
-                                    </p:animEffect>
-                                  </p:childTnLst>
-                                </p:cTn>
-                              </p:par>
-                              <p:par>
-                                <p:cTn id="69" presetID="10" presetClass="entr" presetSubtype="0" fill="hold" grpId="0" nodeType="afterEffect">
-                                  <p:stCondLst>
-                                    <p:cond delay="2860"/>
-                                  </p:stCondLst>
-                                  <p:childTnLst>
-                                    <p:set>
-                                      <p:cBhvr>
-                                        <p:cTn id="70" dur="1" fill="hold">
-                                          <p:stCondLst>
-                                            <p:cond delay="0"/>
-                                          </p:stCondLst>
-                                        </p:cTn>
-                                        <p:tgtEl>
-                                          <p:spTgt spid="27"/>
-                                        </p:tgtEl>
-                                        <p:attrNameLst>
-                                          <p:attrName>style.visibility</p:attrName>
-                                        </p:attrNameLst>
-                                      </p:cBhvr>
-                                      <p:to>
-                                        <p:strVal val="visible"/>
-                                      </p:to>
-                                    </p:set>
-                                    <p:animEffect transition="in" filter="fade">
-                                      <p:cBhvr>
-                                        <p:cTn id="71" dur="400"/>
-                                        <p:tgtEl>
-                                          <p:spTgt spid="27"/>
-                                        </p:tgtEl>
-                                      </p:cBhvr>
-                                    </p:animEffect>
-                                  </p:childTnLst>
-                                </p:cTn>
-                              </p:par>
-                            </p:childTnLst>
-                          </p:cTn>
-                        </p:par>
-                      </p:childTnLst>
-                    </p:cTn>
-                  </p:par>
-                </p:childTnLst>
-              </p:cTn>
-              <p:prevCondLst>
-                <p:cond evt="onPrev" delay="0">
-                  <p:tgtEl>
-                    <p:sldTgt/>
-                  </p:tgtEl>
-                </p:cond>
-              </p:prevCondLst>
-              <p:nextCondLst>
-                <p:cond evt="onNext" delay="0">
-                  <p:tgtEl>
-                    <p:sldTgt/>
-                  </p:tgtEl>
-                </p:cond>
-              </p:nextCondLst>
-            </p:seq>
-          </p:childTnLst>
-        </p:cTn>
-      </p:par>
-    </p:tnLst>
-    <p:bldLst>
-      <p:bldP spid="5" grpId="0"/>
-      <p:bldP spid="6" grpId="0"/>
-      <p:bldP spid="7" grpId="0"/>
-      <p:bldP spid="8" grpId="0"/>
-      <p:bldP spid="9" grpId="0"/>
-      <p:bldP spid="10" grpId="0"/>
-      <p:bldP spid="11" grpId="0"/>
-      <p:bldP spid="12" grpId="0"/>
-      <p:bldP spid="13" grpId="0"/>
-      <p:bldP spid="14" grpId="0"/>
-      <p:bldP spid="15" grpId="0"/>
-      <p:bldP spid="16" grpId="0"/>
-      <p:bldP spid="17" grpId="0"/>
-      <p:bldP spid="18" grpId="0"/>
-      <p:bldP spid="19" grpId="0"/>
-      <p:bldP spid="20" grpId="0"/>
-      <p:bldP spid="21" grpId="0"/>
-      <p:bldP spid="22" grpId="0"/>
-      <p:bldP spid="23" grpId="0"/>
-      <p:bldP spid="24" grpId="0"/>
-      <p:bldP spid="25" grpId="0"/>
-      <p:bldP spid="26" grpId="0"/>
-      <p:bldP spid="27" grpId="0"/>
-    </p:bldLst>
-  </p:timing>
-</p:sld>
-</file>
-
-<file path=ppt/slides/slide21.xml><?xml version="1.0" encoding="utf-8"?>
-<p:sld xmlns:a="http://schemas.openxmlformats.org/drawingml/2006/main" xmlns:r="http://schemas.openxmlformats.org/officeDocument/2006/relationships" xmlns:p="http://schemas.openxmlformats.org/presentationml/2006/main">
-  <p:cSld name="Slide 21">
-    <p:bg>
-      <p:bgPr>
-        <a:solidFill>
-          <a:srgbClr val="080B0F"/>
-        </a:solidFill>
-      </p:bgPr>
-    </p:bg>
-    <p:spTree>
-      <p:nvGrpSpPr>
-        <p:cNvPr id="1" name=""/>
-        <p:cNvGrpSpPr/>
-        <p:nvPr/>
-      </p:nvGrpSpPr>
-      <p:grpSpPr>
-        <a:xfrm>
-          <a:off x="0" y="0"/>
-          <a:ext cx="0" cy="0"/>
-          <a:chOff x="0" y="0"/>
-          <a:chExt cx="0" cy="0"/>
-        </a:xfrm>
-      </p:grpSpPr>
-      <p:sp>
-        <p:nvSpPr>
-          <p:cNvPr id="2" name="chrome-footer"/>
-          <p:cNvSpPr/>
-          <p:nvPr/>
-        </p:nvSpPr>
-        <p:spPr>
-          <a:xfrm>
-            <a:off x="502920" y="6510528"/>
-            <a:ext cx="4572000" cy="237744"/>
-          </a:xfrm>
-          <a:prstGeom prst="rect">
-            <a:avLst/>
-          </a:prstGeom>
-          <a:noFill/>
-          <a:ln/>
-        </p:spPr>
-        <p:txBody>
-          <a:bodyPr wrap="square" lIns="0" tIns="0" rIns="0" bIns="0" rtlCol="0" anchor="ctr"/>
-          <a:lstStyle/>
-          <a:p>
-            <a:pPr indent="0" marL="0">
-              <a:buNone/>
-            </a:pPr>
-            <a:r>
-              <a:rPr lang="en-US" sz="850" dirty="0">
-                <a:solidFill>
-                  <a:srgbClr val="5C6E82"/>
-                </a:solidFill>
-                <a:latin typeface="Arial" pitchFamily="34" charset="0"/>
-                <a:ea typeface="Arial" pitchFamily="34" charset="-122"/>
-                <a:cs typeface="Arial" pitchFamily="34" charset="-120"/>
-              </a:rPr>
-              <a:t>Fairtech Schweiz · Projekt E-Commerce</a:t>
-            </a:r>
-            <a:endParaRPr lang="en-US" sz="850" dirty="0"/>
-          </a:p>
-        </p:txBody>
-      </p:sp>
-      <p:sp>
-        <p:nvSpPr>
-          <p:cNvPr id="3" name="chrome-page"/>
-          <p:cNvSpPr/>
-          <p:nvPr/>
-        </p:nvSpPr>
-        <p:spPr>
-          <a:xfrm>
-            <a:off x="11430000" y="6510528"/>
-            <a:ext cx="256032" cy="237744"/>
-          </a:xfrm>
-          <a:prstGeom prst="rect">
-            <a:avLst/>
-          </a:prstGeom>
-          <a:noFill/>
-          <a:ln/>
-        </p:spPr>
-        <p:txBody>
-          <a:bodyPr wrap="square" lIns="0" tIns="0" rIns="0" bIns="0" rtlCol="0" anchor="ctr"/>
-          <a:lstStyle/>
-          <a:p>
-            <a:pPr algn="r" indent="0" marL="0">
-              <a:buNone/>
-            </a:pPr>
-            <a:r>
-              <a:rPr lang="en-US" sz="850" dirty="0">
-                <a:solidFill>
-                  <a:srgbClr val="5C6E82"/>
-                </a:solidFill>
-                <a:latin typeface="Arial" pitchFamily="34" charset="0"/>
-                <a:ea typeface="Arial" pitchFamily="34" charset="-122"/>
-                <a:cs typeface="Arial" pitchFamily="34" charset="-120"/>
-              </a:rPr>
-              <a:t>21</a:t>
-            </a:r>
-            <a:endParaRPr lang="en-US" sz="850" dirty="0"/>
-          </a:p>
-        </p:txBody>
-      </p:sp>
-      <p:sp>
-        <p:nvSpPr>
           <p:cNvPr id="4" name="Text 2"/>
           <p:cNvSpPr/>
           <p:nvPr/>
@@ -21097,9 +20573,9 @@
 </p:sld>
 </file>
 
-<file path=ppt/slides/slide22.xml><?xml version="1.0" encoding="utf-8"?>
+<file path=ppt/slides/slide21.xml><?xml version="1.0" encoding="utf-8"?>
 <p:sld xmlns:a="http://schemas.openxmlformats.org/drawingml/2006/main" xmlns:r="http://schemas.openxmlformats.org/officeDocument/2006/relationships" xmlns:p="http://schemas.openxmlformats.org/presentationml/2006/main">
-  <p:cSld name="Slide 22">
+  <p:cSld name="Slide 21">
     <p:bg>
       <p:bgPr>
         <a:solidFill>
@@ -21193,7 +20669,7 @@
                 <a:ea typeface="Arial" pitchFamily="34" charset="-122"/>
                 <a:cs typeface="Arial" pitchFamily="34" charset="-120"/>
               </a:rPr>
-              <a:t>22</a:t>
+              <a:t>21</a:t>
             </a:r>
             <a:endParaRPr lang="en-US" sz="850" dirty="0"/>
           </a:p>
@@ -22343,9 +21819,9 @@
 </p:sld>
 </file>
 
-<file path=ppt/slides/slide23.xml><?xml version="1.0" encoding="utf-8"?>
+<file path=ppt/slides/slide22.xml><?xml version="1.0" encoding="utf-8"?>
 <p:sld xmlns:a="http://schemas.openxmlformats.org/drawingml/2006/main" xmlns:r="http://schemas.openxmlformats.org/officeDocument/2006/relationships" xmlns:p="http://schemas.openxmlformats.org/presentationml/2006/main">
-  <p:cSld name="Slide 23">
+  <p:cSld name="Slide 22">
     <p:bg>
       <p:bgPr>
         <a:solidFill>
@@ -22439,7 +21915,7 @@
                 <a:ea typeface="Arial" pitchFamily="34" charset="-122"/>
                 <a:cs typeface="Arial" pitchFamily="34" charset="-120"/>
               </a:rPr>
-              <a:t>23</a:t>
+              <a:t>22</a:t>
             </a:r>
             <a:endParaRPr lang="en-US" sz="850" dirty="0"/>
           </a:p>
@@ -22818,9 +22294,9 @@
 </p:sld>
 </file>
 
-<file path=ppt/slides/slide24.xml><?xml version="1.0" encoding="utf-8"?>
+<file path=ppt/slides/slide23.xml><?xml version="1.0" encoding="utf-8"?>
 <p:sld xmlns:a="http://schemas.openxmlformats.org/drawingml/2006/main" xmlns:r="http://schemas.openxmlformats.org/officeDocument/2006/relationships" xmlns:p="http://schemas.openxmlformats.org/presentationml/2006/main">
-  <p:cSld name="Slide 24">
+  <p:cSld name="Slide 23">
     <p:bg>
       <p:bgPr>
         <a:solidFill>
@@ -22914,7 +22390,7 @@
                 <a:ea typeface="Arial" pitchFamily="34" charset="-122"/>
                 <a:cs typeface="Arial" pitchFamily="34" charset="-120"/>
               </a:rPr>
-              <a:t>24</a:t>
+              <a:t>23</a:t>
             </a:r>
             <a:endParaRPr lang="en-US" sz="850" dirty="0"/>
           </a:p>
@@ -24421,9 +23897,9 @@
 </p:sld>
 </file>
 
-<file path=ppt/slides/slide25.xml><?xml version="1.0" encoding="utf-8"?>
+<file path=ppt/slides/slide24.xml><?xml version="1.0" encoding="utf-8"?>
 <p:sld xmlns:a="http://schemas.openxmlformats.org/drawingml/2006/main" xmlns:r="http://schemas.openxmlformats.org/officeDocument/2006/relationships" xmlns:p="http://schemas.openxmlformats.org/presentationml/2006/main">
-  <p:cSld name="Slide 25">
+  <p:cSld name="Slide 24">
     <p:bg>
       <p:bgPr>
         <a:solidFill>
@@ -24517,7 +23993,7 @@
                 <a:ea typeface="Arial" pitchFamily="34" charset="-122"/>
                 <a:cs typeface="Arial" pitchFamily="34" charset="-120"/>
               </a:rPr>
-              <a:t>25</a:t>
+              <a:t>24</a:t>
             </a:r>
             <a:endParaRPr lang="en-US" sz="850" dirty="0"/>
           </a:p>
@@ -26490,9 +25966,9 @@
 </p:sld>
 </file>
 
-<file path=ppt/slides/slide26.xml><?xml version="1.0" encoding="utf-8"?>
+<file path=ppt/slides/slide25.xml><?xml version="1.0" encoding="utf-8"?>
 <p:sld xmlns:a="http://schemas.openxmlformats.org/drawingml/2006/main" xmlns:r="http://schemas.openxmlformats.org/officeDocument/2006/relationships" xmlns:p="http://schemas.openxmlformats.org/presentationml/2006/main">
-  <p:cSld name="Slide 26">
+  <p:cSld name="Slide 25">
     <p:bg>
       <p:bgPr>
         <a:solidFill>
@@ -26586,7 +26062,7 @@
                 <a:ea typeface="Arial" pitchFamily="34" charset="-122"/>
                 <a:cs typeface="Arial" pitchFamily="34" charset="-120"/>
               </a:rPr>
-              <a:t>26</a:t>
+              <a:t>25</a:t>
             </a:r>
             <a:endParaRPr lang="en-US" sz="850" dirty="0"/>
           </a:p>
@@ -28018,9 +27494,9 @@
 </p:sld>
 </file>
 
-<file path=ppt/slides/slide27.xml><?xml version="1.0" encoding="utf-8"?>
+<file path=ppt/slides/slide26.xml><?xml version="1.0" encoding="utf-8"?>
 <p:sld xmlns:a="http://schemas.openxmlformats.org/drawingml/2006/main" xmlns:r="http://schemas.openxmlformats.org/officeDocument/2006/relationships" xmlns:p="http://schemas.openxmlformats.org/presentationml/2006/main">
-  <p:cSld name="Slide 27">
+  <p:cSld name="Slide 26">
     <p:bg>
       <p:bgPr>
         <a:solidFill>
@@ -28114,7 +27590,7 @@
                 <a:ea typeface="Arial" pitchFamily="34" charset="-122"/>
                 <a:cs typeface="Arial" pitchFamily="34" charset="-120"/>
               </a:rPr>
-              <a:t>27</a:t>
+              <a:t>26</a:t>
             </a:r>
             <a:endParaRPr lang="en-US" sz="850" dirty="0"/>
           </a:p>
@@ -28835,9 +28311,9 @@
 </p:sld>
 </file>
 
-<file path=ppt/slides/slide28.xml><?xml version="1.0" encoding="utf-8"?>
+<file path=ppt/slides/slide27.xml><?xml version="1.0" encoding="utf-8"?>
 <p:sld xmlns:a="http://schemas.openxmlformats.org/drawingml/2006/main" xmlns:r="http://schemas.openxmlformats.org/officeDocument/2006/relationships" xmlns:p="http://schemas.openxmlformats.org/presentationml/2006/main">
-  <p:cSld name="Slide 28">
+  <p:cSld name="Slide 27">
     <p:bg>
       <p:bgPr>
         <a:solidFill>
@@ -28931,7 +28407,7 @@
                 <a:ea typeface="Arial" pitchFamily="34" charset="-122"/>
                 <a:cs typeface="Arial" pitchFamily="34" charset="-120"/>
               </a:rPr>
-              <a:t>28</a:t>
+              <a:t>27</a:t>
             </a:r>
             <a:endParaRPr lang="en-US" sz="850" dirty="0"/>
           </a:p>

</xml_diff>